<commit_message>
Update the section 3 cyber twin system design.
</commit_message>
<xml_diff>
--- a/5_CaseStudy_Doc/Case0_img/designDoc.pptx
+++ b/5_CaseStudy_Doc/Case0_img/designDoc.pptx
@@ -6,6 +6,7 @@
   </p:sldMasterIdLst>
   <p:sldIdLst>
     <p:sldId id="256" r:id="rId2"/>
+    <p:sldId id="257" r:id="rId3"/>
   </p:sldIdLst>
   <p:sldSz cx="12192000" cy="6858000"/>
   <p:notesSz cx="6858000" cy="9144000"/>
@@ -104,6 +105,11 @@
       </a:defRPr>
     </a:lvl9pPr>
   </p:defaultTextStyle>
+  <p:extLst>
+    <p:ext uri="{EFAFB233-063F-42B5-8137-9DF3F51BA10A}">
+      <p15:sldGuideLst xmlns:p15="http://schemas.microsoft.com/office/powerpoint/2012/main"/>
+    </p:ext>
+  </p:extLst>
 </p:presentation>
 </file>
 
@@ -256,7 +262,7 @@
           <a:p>
             <a:fld id="{34BE27F4-F3F1-4FF7-9C3C-2BECB05327F1}" type="datetimeFigureOut">
               <a:rPr lang="en-SG" smtClean="0"/>
-              <a:t>7/5/2026</a:t>
+              <a:t>8/5/2026</a:t>
             </a:fld>
             <a:endParaRPr lang="en-SG"/>
           </a:p>
@@ -456,7 +462,7 @@
           <a:p>
             <a:fld id="{34BE27F4-F3F1-4FF7-9C3C-2BECB05327F1}" type="datetimeFigureOut">
               <a:rPr lang="en-SG" smtClean="0"/>
-              <a:t>7/5/2026</a:t>
+              <a:t>8/5/2026</a:t>
             </a:fld>
             <a:endParaRPr lang="en-SG"/>
           </a:p>
@@ -666,7 +672,7 @@
           <a:p>
             <a:fld id="{34BE27F4-F3F1-4FF7-9C3C-2BECB05327F1}" type="datetimeFigureOut">
               <a:rPr lang="en-SG" smtClean="0"/>
-              <a:t>7/5/2026</a:t>
+              <a:t>8/5/2026</a:t>
             </a:fld>
             <a:endParaRPr lang="en-SG"/>
           </a:p>
@@ -866,7 +872,7 @@
           <a:p>
             <a:fld id="{34BE27F4-F3F1-4FF7-9C3C-2BECB05327F1}" type="datetimeFigureOut">
               <a:rPr lang="en-SG" smtClean="0"/>
-              <a:t>7/5/2026</a:t>
+              <a:t>8/5/2026</a:t>
             </a:fld>
             <a:endParaRPr lang="en-SG"/>
           </a:p>
@@ -1142,7 +1148,7 @@
           <a:p>
             <a:fld id="{34BE27F4-F3F1-4FF7-9C3C-2BECB05327F1}" type="datetimeFigureOut">
               <a:rPr lang="en-SG" smtClean="0"/>
-              <a:t>7/5/2026</a:t>
+              <a:t>8/5/2026</a:t>
             </a:fld>
             <a:endParaRPr lang="en-SG"/>
           </a:p>
@@ -1410,7 +1416,7 @@
           <a:p>
             <a:fld id="{34BE27F4-F3F1-4FF7-9C3C-2BECB05327F1}" type="datetimeFigureOut">
               <a:rPr lang="en-SG" smtClean="0"/>
-              <a:t>7/5/2026</a:t>
+              <a:t>8/5/2026</a:t>
             </a:fld>
             <a:endParaRPr lang="en-SG"/>
           </a:p>
@@ -1825,7 +1831,7 @@
           <a:p>
             <a:fld id="{34BE27F4-F3F1-4FF7-9C3C-2BECB05327F1}" type="datetimeFigureOut">
               <a:rPr lang="en-SG" smtClean="0"/>
-              <a:t>7/5/2026</a:t>
+              <a:t>8/5/2026</a:t>
             </a:fld>
             <a:endParaRPr lang="en-SG"/>
           </a:p>
@@ -1967,7 +1973,7 @@
           <a:p>
             <a:fld id="{34BE27F4-F3F1-4FF7-9C3C-2BECB05327F1}" type="datetimeFigureOut">
               <a:rPr lang="en-SG" smtClean="0"/>
-              <a:t>7/5/2026</a:t>
+              <a:t>8/5/2026</a:t>
             </a:fld>
             <a:endParaRPr lang="en-SG"/>
           </a:p>
@@ -2080,7 +2086,7 @@
           <a:p>
             <a:fld id="{34BE27F4-F3F1-4FF7-9C3C-2BECB05327F1}" type="datetimeFigureOut">
               <a:rPr lang="en-SG" smtClean="0"/>
-              <a:t>7/5/2026</a:t>
+              <a:t>8/5/2026</a:t>
             </a:fld>
             <a:endParaRPr lang="en-SG"/>
           </a:p>
@@ -2393,7 +2399,7 @@
           <a:p>
             <a:fld id="{34BE27F4-F3F1-4FF7-9C3C-2BECB05327F1}" type="datetimeFigureOut">
               <a:rPr lang="en-SG" smtClean="0"/>
-              <a:t>7/5/2026</a:t>
+              <a:t>8/5/2026</a:t>
             </a:fld>
             <a:endParaRPr lang="en-SG"/>
           </a:p>
@@ -2682,7 +2688,7 @@
           <a:p>
             <a:fld id="{34BE27F4-F3F1-4FF7-9C3C-2BECB05327F1}" type="datetimeFigureOut">
               <a:rPr lang="en-SG" smtClean="0"/>
-              <a:t>7/5/2026</a:t>
+              <a:t>8/5/2026</a:t>
             </a:fld>
             <a:endParaRPr lang="en-SG"/>
           </a:p>
@@ -2925,7 +2931,7 @@
           <a:p>
             <a:fld id="{34BE27F4-F3F1-4FF7-9C3C-2BECB05327F1}" type="datetimeFigureOut">
               <a:rPr lang="en-SG" smtClean="0"/>
-              <a:t>7/5/2026</a:t>
+              <a:t>8/5/2026</a:t>
             </a:fld>
             <a:endParaRPr lang="en-SG"/>
           </a:p>
@@ -3425,6 +3431,3407 @@
 </p:sld>
 </file>
 
+<file path=ppt/slides/slide2.xml><?xml version="1.0" encoding="utf-8"?>
+<p:sld xmlns:a="http://schemas.openxmlformats.org/drawingml/2006/main" xmlns:r="http://schemas.openxmlformats.org/officeDocument/2006/relationships" xmlns:p="http://schemas.openxmlformats.org/presentationml/2006/main">
+  <p:cSld>
+    <p:spTree>
+      <p:nvGrpSpPr>
+        <p:cNvPr id="1" name=""/>
+        <p:cNvGrpSpPr/>
+        <p:nvPr/>
+      </p:nvGrpSpPr>
+      <p:grpSpPr>
+        <a:xfrm>
+          <a:off x="0" y="0"/>
+          <a:ext cx="0" cy="0"/>
+          <a:chOff x="0" y="0"/>
+          <a:chExt cx="0" cy="0"/>
+        </a:xfrm>
+      </p:grpSpPr>
+      <p:pic>
+        <p:nvPicPr>
+          <p:cNvPr id="4" name="Picture 2" descr="Train Side View: Over 3,932 Royalty-Free Licensable Stock Illustrations &amp;  Drawings | Shutterstock">
+            <a:extLst>
+              <a:ext uri="{FF2B5EF4-FFF2-40B4-BE49-F238E27FC236}">
+                <a16:creationId xmlns:a16="http://schemas.microsoft.com/office/drawing/2014/main" id="{80820D67-DD1F-ADCF-FCFE-F01D392396C5}"/>
+              </a:ext>
+            </a:extLst>
+          </p:cNvPr>
+          <p:cNvPicPr>
+            <a:picLocks noChangeAspect="1" noChangeArrowheads="1"/>
+          </p:cNvPicPr>
+          <p:nvPr/>
+        </p:nvPicPr>
+        <p:blipFill rotWithShape="1">
+          <a:blip r:embed="rId2">
+            <a:alphaModFix amt="70000"/>
+            <a:extLst>
+              <a:ext uri="{28A0092B-C50C-407E-A947-70E740481C1C}">
+                <a14:useLocalDpi xmlns:a14="http://schemas.microsoft.com/office/drawing/2010/main" val="0"/>
+              </a:ext>
+            </a:extLst>
+          </a:blip>
+          <a:srcRect t="18869" b="33339"/>
+          <a:stretch/>
+        </p:blipFill>
+        <p:spPr bwMode="auto">
+          <a:xfrm flipH="1">
+            <a:off x="866522" y="4087368"/>
+            <a:ext cx="3787778" cy="1114019"/>
+          </a:xfrm>
+          <a:prstGeom prst="rect">
+            <a:avLst/>
+          </a:prstGeom>
+          <a:noFill/>
+          <a:extLst>
+            <a:ext uri="{909E8E84-426E-40DD-AFC4-6F175D3DCCD1}">
+              <a14:hiddenFill xmlns:a14="http://schemas.microsoft.com/office/drawing/2010/main">
+                <a:solidFill>
+                  <a:srgbClr val="FFFFFF"/>
+                </a:solidFill>
+              </a14:hiddenFill>
+            </a:ext>
+          </a:extLst>
+        </p:spPr>
+      </p:pic>
+      <p:cxnSp>
+        <p:nvCxnSpPr>
+          <p:cNvPr id="5" name="Straight Connector 4">
+            <a:extLst>
+              <a:ext uri="{FF2B5EF4-FFF2-40B4-BE49-F238E27FC236}">
+                <a16:creationId xmlns:a16="http://schemas.microsoft.com/office/drawing/2014/main" id="{5C0076CB-F0B3-D918-DAE4-D6DDC3C6E439}"/>
+              </a:ext>
+            </a:extLst>
+          </p:cNvPr>
+          <p:cNvCxnSpPr>
+            <a:cxnSpLocks/>
+          </p:cNvCxnSpPr>
+          <p:nvPr/>
+        </p:nvCxnSpPr>
+        <p:spPr>
+          <a:xfrm>
+            <a:off x="663105" y="5053236"/>
+            <a:ext cx="11029183" cy="0"/>
+          </a:xfrm>
+          <a:prstGeom prst="line">
+            <a:avLst/>
+          </a:prstGeom>
+          <a:ln w="38100">
+            <a:solidFill>
+              <a:schemeClr val="tx1"/>
+            </a:solidFill>
+          </a:ln>
+        </p:spPr>
+        <p:style>
+          <a:lnRef idx="2">
+            <a:schemeClr val="accent1"/>
+          </a:lnRef>
+          <a:fillRef idx="0">
+            <a:schemeClr val="accent1"/>
+          </a:fillRef>
+          <a:effectRef idx="1">
+            <a:schemeClr val="accent1"/>
+          </a:effectRef>
+          <a:fontRef idx="minor">
+            <a:schemeClr val="tx1"/>
+          </a:fontRef>
+        </p:style>
+      </p:cxnSp>
+      <p:pic>
+        <p:nvPicPr>
+          <p:cNvPr id="8" name="Picture 7" descr="Radio tower - Free communications icons">
+            <a:extLst>
+              <a:ext uri="{FF2B5EF4-FFF2-40B4-BE49-F238E27FC236}">
+                <a16:creationId xmlns:a16="http://schemas.microsoft.com/office/drawing/2014/main" id="{DBBA64DA-B62F-1FE8-729A-5586EBD4ABBF}"/>
+              </a:ext>
+            </a:extLst>
+          </p:cNvPr>
+          <p:cNvPicPr>
+            <a:picLocks noChangeAspect="1"/>
+          </p:cNvPicPr>
+          <p:nvPr/>
+        </p:nvPicPr>
+        <p:blipFill>
+          <a:blip r:embed="rId3"/>
+          <a:stretch>
+            <a:fillRect/>
+          </a:stretch>
+        </p:blipFill>
+        <p:spPr>
+          <a:xfrm>
+            <a:off x="4846324" y="5258541"/>
+            <a:ext cx="650959" cy="650959"/>
+          </a:xfrm>
+          <a:prstGeom prst="rect">
+            <a:avLst/>
+          </a:prstGeom>
+        </p:spPr>
+      </p:pic>
+      <p:pic>
+        <p:nvPicPr>
+          <p:cNvPr id="9" name="Picture 8" descr="Radio tower - Free communications icons">
+            <a:extLst>
+              <a:ext uri="{FF2B5EF4-FFF2-40B4-BE49-F238E27FC236}">
+                <a16:creationId xmlns:a16="http://schemas.microsoft.com/office/drawing/2014/main" id="{708FA7AE-0243-AA2E-9DD9-70919EE38DAA}"/>
+              </a:ext>
+            </a:extLst>
+          </p:cNvPr>
+          <p:cNvPicPr>
+            <a:picLocks noChangeAspect="1"/>
+          </p:cNvPicPr>
+          <p:nvPr/>
+        </p:nvPicPr>
+        <p:blipFill>
+          <a:blip r:embed="rId3"/>
+          <a:stretch>
+            <a:fillRect/>
+          </a:stretch>
+        </p:blipFill>
+        <p:spPr>
+          <a:xfrm>
+            <a:off x="8519107" y="5223585"/>
+            <a:ext cx="720873" cy="720873"/>
+          </a:xfrm>
+          <a:prstGeom prst="rect">
+            <a:avLst/>
+          </a:prstGeom>
+        </p:spPr>
+      </p:pic>
+      <p:cxnSp>
+        <p:nvCxnSpPr>
+          <p:cNvPr id="11" name="Straight Connector 10">
+            <a:extLst>
+              <a:ext uri="{FF2B5EF4-FFF2-40B4-BE49-F238E27FC236}">
+                <a16:creationId xmlns:a16="http://schemas.microsoft.com/office/drawing/2014/main" id="{A092F178-50D0-AA7F-4EA6-B125EE122710}"/>
+              </a:ext>
+            </a:extLst>
+          </p:cNvPr>
+          <p:cNvCxnSpPr>
+            <a:cxnSpLocks/>
+          </p:cNvCxnSpPr>
+          <p:nvPr/>
+        </p:nvCxnSpPr>
+        <p:spPr>
+          <a:xfrm>
+            <a:off x="663105" y="4172364"/>
+            <a:ext cx="1750911" cy="0"/>
+          </a:xfrm>
+          <a:prstGeom prst="line">
+            <a:avLst/>
+          </a:prstGeom>
+          <a:ln w="28575">
+            <a:solidFill>
+              <a:srgbClr val="C00000"/>
+            </a:solidFill>
+            <a:prstDash val="solid"/>
+          </a:ln>
+        </p:spPr>
+        <p:style>
+          <a:lnRef idx="2">
+            <a:schemeClr val="accent1"/>
+          </a:lnRef>
+          <a:fillRef idx="0">
+            <a:schemeClr val="accent1"/>
+          </a:fillRef>
+          <a:effectRef idx="1">
+            <a:schemeClr val="accent1"/>
+          </a:effectRef>
+          <a:fontRef idx="minor">
+            <a:schemeClr val="tx1"/>
+          </a:fontRef>
+        </p:style>
+      </p:cxnSp>
+      <p:cxnSp>
+        <p:nvCxnSpPr>
+          <p:cNvPr id="16" name="Straight Connector 15">
+            <a:extLst>
+              <a:ext uri="{FF2B5EF4-FFF2-40B4-BE49-F238E27FC236}">
+                <a16:creationId xmlns:a16="http://schemas.microsoft.com/office/drawing/2014/main" id="{1C8CE927-BF95-668E-6BC1-35ED52E702D0}"/>
+              </a:ext>
+            </a:extLst>
+          </p:cNvPr>
+          <p:cNvCxnSpPr>
+            <a:cxnSpLocks/>
+          </p:cNvCxnSpPr>
+          <p:nvPr/>
+        </p:nvCxnSpPr>
+        <p:spPr>
+          <a:xfrm>
+            <a:off x="2552865" y="4172364"/>
+            <a:ext cx="1750911" cy="0"/>
+          </a:xfrm>
+          <a:prstGeom prst="line">
+            <a:avLst/>
+          </a:prstGeom>
+          <a:ln w="28575">
+            <a:solidFill>
+              <a:srgbClr val="C00000"/>
+            </a:solidFill>
+            <a:prstDash val="solid"/>
+          </a:ln>
+        </p:spPr>
+        <p:style>
+          <a:lnRef idx="2">
+            <a:schemeClr val="accent1"/>
+          </a:lnRef>
+          <a:fillRef idx="0">
+            <a:schemeClr val="accent1"/>
+          </a:fillRef>
+          <a:effectRef idx="1">
+            <a:schemeClr val="accent1"/>
+          </a:effectRef>
+          <a:fontRef idx="minor">
+            <a:schemeClr val="tx1"/>
+          </a:fontRef>
+        </p:style>
+      </p:cxnSp>
+      <p:cxnSp>
+        <p:nvCxnSpPr>
+          <p:cNvPr id="17" name="Straight Connector 16">
+            <a:extLst>
+              <a:ext uri="{FF2B5EF4-FFF2-40B4-BE49-F238E27FC236}">
+                <a16:creationId xmlns:a16="http://schemas.microsoft.com/office/drawing/2014/main" id="{2F23AFA3-C53E-ED26-176C-9840BFD2E976}"/>
+              </a:ext>
+            </a:extLst>
+          </p:cNvPr>
+          <p:cNvCxnSpPr>
+            <a:cxnSpLocks/>
+          </p:cNvCxnSpPr>
+          <p:nvPr/>
+        </p:nvCxnSpPr>
+        <p:spPr>
+          <a:xfrm>
+            <a:off x="4473105" y="4172364"/>
+            <a:ext cx="1750911" cy="0"/>
+          </a:xfrm>
+          <a:prstGeom prst="line">
+            <a:avLst/>
+          </a:prstGeom>
+          <a:ln w="28575">
+            <a:solidFill>
+              <a:srgbClr val="C00000"/>
+            </a:solidFill>
+            <a:prstDash val="solid"/>
+          </a:ln>
+        </p:spPr>
+        <p:style>
+          <a:lnRef idx="2">
+            <a:schemeClr val="accent1"/>
+          </a:lnRef>
+          <a:fillRef idx="0">
+            <a:schemeClr val="accent1"/>
+          </a:fillRef>
+          <a:effectRef idx="1">
+            <a:schemeClr val="accent1"/>
+          </a:effectRef>
+          <a:fontRef idx="minor">
+            <a:schemeClr val="tx1"/>
+          </a:fontRef>
+        </p:style>
+      </p:cxnSp>
+      <p:cxnSp>
+        <p:nvCxnSpPr>
+          <p:cNvPr id="18" name="Straight Connector 17">
+            <a:extLst>
+              <a:ext uri="{FF2B5EF4-FFF2-40B4-BE49-F238E27FC236}">
+                <a16:creationId xmlns:a16="http://schemas.microsoft.com/office/drawing/2014/main" id="{4BF36244-1777-75F0-38CF-0DBE41C20C06}"/>
+              </a:ext>
+            </a:extLst>
+          </p:cNvPr>
+          <p:cNvCxnSpPr>
+            <a:cxnSpLocks/>
+          </p:cNvCxnSpPr>
+          <p:nvPr/>
+        </p:nvCxnSpPr>
+        <p:spPr>
+          <a:xfrm>
+            <a:off x="6329337" y="4172364"/>
+            <a:ext cx="1750911" cy="0"/>
+          </a:xfrm>
+          <a:prstGeom prst="line">
+            <a:avLst/>
+          </a:prstGeom>
+          <a:ln w="28575">
+            <a:solidFill>
+              <a:srgbClr val="C00000"/>
+            </a:solidFill>
+            <a:prstDash val="solid"/>
+          </a:ln>
+        </p:spPr>
+        <p:style>
+          <a:lnRef idx="2">
+            <a:schemeClr val="accent1"/>
+          </a:lnRef>
+          <a:fillRef idx="0">
+            <a:schemeClr val="accent1"/>
+          </a:fillRef>
+          <a:effectRef idx="1">
+            <a:schemeClr val="accent1"/>
+          </a:effectRef>
+          <a:fontRef idx="minor">
+            <a:schemeClr val="tx1"/>
+          </a:fontRef>
+        </p:style>
+      </p:cxnSp>
+      <p:cxnSp>
+        <p:nvCxnSpPr>
+          <p:cNvPr id="19" name="Straight Connector 18">
+            <a:extLst>
+              <a:ext uri="{FF2B5EF4-FFF2-40B4-BE49-F238E27FC236}">
+                <a16:creationId xmlns:a16="http://schemas.microsoft.com/office/drawing/2014/main" id="{9E93B5FA-A168-BC0F-B1A1-4D6D01F58319}"/>
+              </a:ext>
+            </a:extLst>
+          </p:cNvPr>
+          <p:cNvCxnSpPr>
+            <a:cxnSpLocks/>
+          </p:cNvCxnSpPr>
+          <p:nvPr/>
+        </p:nvCxnSpPr>
+        <p:spPr>
+          <a:xfrm>
+            <a:off x="8158137" y="4181508"/>
+            <a:ext cx="1750911" cy="0"/>
+          </a:xfrm>
+          <a:prstGeom prst="line">
+            <a:avLst/>
+          </a:prstGeom>
+          <a:ln w="28575">
+            <a:solidFill>
+              <a:srgbClr val="C00000"/>
+            </a:solidFill>
+            <a:prstDash val="solid"/>
+          </a:ln>
+        </p:spPr>
+        <p:style>
+          <a:lnRef idx="2">
+            <a:schemeClr val="accent1"/>
+          </a:lnRef>
+          <a:fillRef idx="0">
+            <a:schemeClr val="accent1"/>
+          </a:fillRef>
+          <a:effectRef idx="1">
+            <a:schemeClr val="accent1"/>
+          </a:effectRef>
+          <a:fontRef idx="minor">
+            <a:schemeClr val="tx1"/>
+          </a:fontRef>
+        </p:style>
+      </p:cxnSp>
+      <p:pic>
+        <p:nvPicPr>
+          <p:cNvPr id="20" name="Picture 19" descr="Transformer - Free electronics icons">
+            <a:extLst>
+              <a:ext uri="{FF2B5EF4-FFF2-40B4-BE49-F238E27FC236}">
+                <a16:creationId xmlns:a16="http://schemas.microsoft.com/office/drawing/2014/main" id="{27CA5BC6-BD66-1C68-15A4-1D81380B99AF}"/>
+              </a:ext>
+            </a:extLst>
+          </p:cNvPr>
+          <p:cNvPicPr>
+            <a:picLocks noChangeAspect="1"/>
+          </p:cNvPicPr>
+          <p:nvPr/>
+        </p:nvPicPr>
+        <p:blipFill>
+          <a:blip r:embed="rId4"/>
+          <a:stretch>
+            <a:fillRect/>
+          </a:stretch>
+        </p:blipFill>
+        <p:spPr>
+          <a:xfrm>
+            <a:off x="1353645" y="2279755"/>
+            <a:ext cx="797687" cy="797687"/>
+          </a:xfrm>
+          <a:prstGeom prst="rect">
+            <a:avLst/>
+          </a:prstGeom>
+        </p:spPr>
+      </p:pic>
+      <p:cxnSp>
+        <p:nvCxnSpPr>
+          <p:cNvPr id="22" name="Straight Connector 21">
+            <a:extLst>
+              <a:ext uri="{FF2B5EF4-FFF2-40B4-BE49-F238E27FC236}">
+                <a16:creationId xmlns:a16="http://schemas.microsoft.com/office/drawing/2014/main" id="{4E801A6F-CB02-8484-5726-4EB009630592}"/>
+              </a:ext>
+            </a:extLst>
+          </p:cNvPr>
+          <p:cNvCxnSpPr>
+            <a:cxnSpLocks/>
+            <a:stCxn id="20" idx="2"/>
+          </p:cNvCxnSpPr>
+          <p:nvPr/>
+        </p:nvCxnSpPr>
+        <p:spPr>
+          <a:xfrm flipH="1">
+            <a:off x="1752488" y="3077442"/>
+            <a:ext cx="1" cy="318159"/>
+          </a:xfrm>
+          <a:prstGeom prst="line">
+            <a:avLst/>
+          </a:prstGeom>
+          <a:ln>
+            <a:solidFill>
+              <a:srgbClr val="C00000"/>
+            </a:solidFill>
+          </a:ln>
+        </p:spPr>
+        <p:style>
+          <a:lnRef idx="2">
+            <a:schemeClr val="accent1"/>
+          </a:lnRef>
+          <a:fillRef idx="0">
+            <a:schemeClr val="accent1"/>
+          </a:fillRef>
+          <a:effectRef idx="1">
+            <a:schemeClr val="accent1"/>
+          </a:effectRef>
+          <a:fontRef idx="minor">
+            <a:schemeClr val="tx1"/>
+          </a:fontRef>
+        </p:style>
+      </p:cxnSp>
+      <p:pic>
+        <p:nvPicPr>
+          <p:cNvPr id="24" name="Picture 23">
+            <a:extLst>
+              <a:ext uri="{FF2B5EF4-FFF2-40B4-BE49-F238E27FC236}">
+                <a16:creationId xmlns:a16="http://schemas.microsoft.com/office/drawing/2014/main" id="{BA40457E-7B1D-A88F-EBE5-E4F330F1ADD7}"/>
+              </a:ext>
+            </a:extLst>
+          </p:cNvPr>
+          <p:cNvPicPr>
+            <a:picLocks noChangeAspect="1"/>
+          </p:cNvPicPr>
+          <p:nvPr/>
+        </p:nvPicPr>
+        <p:blipFill>
+          <a:blip r:embed="rId5"/>
+          <a:stretch>
+            <a:fillRect/>
+          </a:stretch>
+        </p:blipFill>
+        <p:spPr>
+          <a:xfrm>
+            <a:off x="1606314" y="3387610"/>
+            <a:ext cx="292347" cy="433648"/>
+          </a:xfrm>
+          <a:prstGeom prst="rect">
+            <a:avLst/>
+          </a:prstGeom>
+        </p:spPr>
+      </p:pic>
+      <p:sp>
+        <p:nvSpPr>
+          <p:cNvPr id="25" name="TextBox 24">
+            <a:extLst>
+              <a:ext uri="{FF2B5EF4-FFF2-40B4-BE49-F238E27FC236}">
+                <a16:creationId xmlns:a16="http://schemas.microsoft.com/office/drawing/2014/main" id="{F2B1BC40-3F3E-848C-2E05-2478EE41E0C2}"/>
+              </a:ext>
+            </a:extLst>
+          </p:cNvPr>
+          <p:cNvSpPr txBox="1"/>
+          <p:nvPr/>
+        </p:nvSpPr>
+        <p:spPr>
+          <a:xfrm>
+            <a:off x="1172801" y="1648316"/>
+            <a:ext cx="1493520" cy="523220"/>
+          </a:xfrm>
+          <a:prstGeom prst="rect">
+            <a:avLst/>
+          </a:prstGeom>
+          <a:noFill/>
+        </p:spPr>
+        <p:txBody>
+          <a:bodyPr wrap="square">
+            <a:spAutoFit/>
+          </a:bodyPr>
+          <a:lstStyle/>
+          <a:p>
+            <a:r>
+              <a:rPr lang="en-US" sz="1400" b="1" dirty="0">
+                <a:solidFill>
+                  <a:srgbClr val="C00000"/>
+                </a:solidFill>
+              </a:rPr>
+              <a:t>750V DC Transformer </a:t>
+            </a:r>
+            <a:endParaRPr lang="en-SG" sz="1400" b="1" dirty="0">
+              <a:solidFill>
+                <a:srgbClr val="C00000"/>
+              </a:solidFill>
+            </a:endParaRPr>
+          </a:p>
+        </p:txBody>
+      </p:sp>
+      <p:cxnSp>
+        <p:nvCxnSpPr>
+          <p:cNvPr id="29" name="Straight Connector 28">
+            <a:extLst>
+              <a:ext uri="{FF2B5EF4-FFF2-40B4-BE49-F238E27FC236}">
+                <a16:creationId xmlns:a16="http://schemas.microsoft.com/office/drawing/2014/main" id="{AFB6382A-B0B9-6A85-045B-6A66BCEB02A7}"/>
+              </a:ext>
+            </a:extLst>
+          </p:cNvPr>
+          <p:cNvCxnSpPr>
+            <a:cxnSpLocks/>
+          </p:cNvCxnSpPr>
+          <p:nvPr/>
+        </p:nvCxnSpPr>
+        <p:spPr>
+          <a:xfrm flipH="1">
+            <a:off x="1752487" y="3824435"/>
+            <a:ext cx="1" cy="318159"/>
+          </a:xfrm>
+          <a:prstGeom prst="line">
+            <a:avLst/>
+          </a:prstGeom>
+          <a:ln>
+            <a:solidFill>
+              <a:srgbClr val="C00000"/>
+            </a:solidFill>
+          </a:ln>
+        </p:spPr>
+        <p:style>
+          <a:lnRef idx="2">
+            <a:schemeClr val="accent1"/>
+          </a:lnRef>
+          <a:fillRef idx="0">
+            <a:schemeClr val="accent1"/>
+          </a:fillRef>
+          <a:effectRef idx="1">
+            <a:schemeClr val="accent1"/>
+          </a:effectRef>
+          <a:fontRef idx="minor">
+            <a:schemeClr val="tx1"/>
+          </a:fontRef>
+        </p:style>
+      </p:cxnSp>
+      <p:pic>
+        <p:nvPicPr>
+          <p:cNvPr id="32" name="Picture 31">
+            <a:extLst>
+              <a:ext uri="{FF2B5EF4-FFF2-40B4-BE49-F238E27FC236}">
+                <a16:creationId xmlns:a16="http://schemas.microsoft.com/office/drawing/2014/main" id="{A78165CB-B6A6-1979-71A8-D8E370BC3312}"/>
+              </a:ext>
+            </a:extLst>
+          </p:cNvPr>
+          <p:cNvPicPr>
+            <a:picLocks noChangeAspect="1"/>
+          </p:cNvPicPr>
+          <p:nvPr/>
+        </p:nvPicPr>
+        <p:blipFill>
+          <a:blip r:embed="rId5"/>
+          <a:stretch>
+            <a:fillRect/>
+          </a:stretch>
+        </p:blipFill>
+        <p:spPr>
+          <a:xfrm>
+            <a:off x="3135973" y="3395601"/>
+            <a:ext cx="292347" cy="433648"/>
+          </a:xfrm>
+          <a:prstGeom prst="rect">
+            <a:avLst/>
+          </a:prstGeom>
+        </p:spPr>
+      </p:pic>
+      <p:pic>
+        <p:nvPicPr>
+          <p:cNvPr id="33" name="Picture 32">
+            <a:extLst>
+              <a:ext uri="{FF2B5EF4-FFF2-40B4-BE49-F238E27FC236}">
+                <a16:creationId xmlns:a16="http://schemas.microsoft.com/office/drawing/2014/main" id="{1BFBCF4F-8A1D-9F89-1F17-087136FD65B3}"/>
+              </a:ext>
+            </a:extLst>
+          </p:cNvPr>
+          <p:cNvPicPr>
+            <a:picLocks noChangeAspect="1"/>
+          </p:cNvPicPr>
+          <p:nvPr/>
+        </p:nvPicPr>
+        <p:blipFill>
+          <a:blip r:embed="rId5"/>
+          <a:stretch>
+            <a:fillRect/>
+          </a:stretch>
+        </p:blipFill>
+        <p:spPr>
+          <a:xfrm>
+            <a:off x="5204936" y="3395601"/>
+            <a:ext cx="292347" cy="433648"/>
+          </a:xfrm>
+          <a:prstGeom prst="rect">
+            <a:avLst/>
+          </a:prstGeom>
+        </p:spPr>
+      </p:pic>
+      <p:pic>
+        <p:nvPicPr>
+          <p:cNvPr id="34" name="Picture 33">
+            <a:extLst>
+              <a:ext uri="{FF2B5EF4-FFF2-40B4-BE49-F238E27FC236}">
+                <a16:creationId xmlns:a16="http://schemas.microsoft.com/office/drawing/2014/main" id="{7A5FF2FA-089A-B35A-5650-70384AEDFA7F}"/>
+              </a:ext>
+            </a:extLst>
+          </p:cNvPr>
+          <p:cNvPicPr>
+            <a:picLocks noChangeAspect="1"/>
+          </p:cNvPicPr>
+          <p:nvPr/>
+        </p:nvPicPr>
+        <p:blipFill>
+          <a:blip r:embed="rId5"/>
+          <a:stretch>
+            <a:fillRect/>
+          </a:stretch>
+        </p:blipFill>
+        <p:spPr>
+          <a:xfrm>
+            <a:off x="7058618" y="3370050"/>
+            <a:ext cx="292347" cy="433648"/>
+          </a:xfrm>
+          <a:prstGeom prst="rect">
+            <a:avLst/>
+          </a:prstGeom>
+        </p:spPr>
+      </p:pic>
+      <p:pic>
+        <p:nvPicPr>
+          <p:cNvPr id="35" name="Picture 34">
+            <a:extLst>
+              <a:ext uri="{FF2B5EF4-FFF2-40B4-BE49-F238E27FC236}">
+                <a16:creationId xmlns:a16="http://schemas.microsoft.com/office/drawing/2014/main" id="{C41471CF-A6C4-3653-1615-6D73E10284D4}"/>
+              </a:ext>
+            </a:extLst>
+          </p:cNvPr>
+          <p:cNvPicPr>
+            <a:picLocks noChangeAspect="1"/>
+          </p:cNvPicPr>
+          <p:nvPr/>
+        </p:nvPicPr>
+        <p:blipFill>
+          <a:blip r:embed="rId5"/>
+          <a:stretch>
+            <a:fillRect/>
+          </a:stretch>
+        </p:blipFill>
+        <p:spPr>
+          <a:xfrm>
+            <a:off x="8786413" y="3360246"/>
+            <a:ext cx="292347" cy="433648"/>
+          </a:xfrm>
+          <a:prstGeom prst="rect">
+            <a:avLst/>
+          </a:prstGeom>
+        </p:spPr>
+      </p:pic>
+      <p:cxnSp>
+        <p:nvCxnSpPr>
+          <p:cNvPr id="36" name="Straight Connector 35">
+            <a:extLst>
+              <a:ext uri="{FF2B5EF4-FFF2-40B4-BE49-F238E27FC236}">
+                <a16:creationId xmlns:a16="http://schemas.microsoft.com/office/drawing/2014/main" id="{EC2E5FAA-10D9-B4F5-E1EC-B66AFD0CDEF9}"/>
+              </a:ext>
+            </a:extLst>
+          </p:cNvPr>
+          <p:cNvCxnSpPr>
+            <a:cxnSpLocks/>
+          </p:cNvCxnSpPr>
+          <p:nvPr/>
+        </p:nvCxnSpPr>
+        <p:spPr>
+          <a:xfrm>
+            <a:off x="1752487" y="3191691"/>
+            <a:ext cx="7159812" cy="4456"/>
+          </a:xfrm>
+          <a:prstGeom prst="line">
+            <a:avLst/>
+          </a:prstGeom>
+          <a:ln>
+            <a:solidFill>
+              <a:srgbClr val="C00000"/>
+            </a:solidFill>
+          </a:ln>
+        </p:spPr>
+        <p:style>
+          <a:lnRef idx="2">
+            <a:schemeClr val="accent1"/>
+          </a:lnRef>
+          <a:fillRef idx="0">
+            <a:schemeClr val="accent1"/>
+          </a:fillRef>
+          <a:effectRef idx="1">
+            <a:schemeClr val="accent1"/>
+          </a:effectRef>
+          <a:fontRef idx="minor">
+            <a:schemeClr val="tx1"/>
+          </a:fontRef>
+        </p:style>
+      </p:cxnSp>
+      <p:sp>
+        <p:nvSpPr>
+          <p:cNvPr id="38" name="TextBox 37">
+            <a:extLst>
+              <a:ext uri="{FF2B5EF4-FFF2-40B4-BE49-F238E27FC236}">
+                <a16:creationId xmlns:a16="http://schemas.microsoft.com/office/drawing/2014/main" id="{2FFD3457-2862-64D7-C1B5-5EB44C7A7A09}"/>
+              </a:ext>
+            </a:extLst>
+          </p:cNvPr>
+          <p:cNvSpPr txBox="1"/>
+          <p:nvPr/>
+        </p:nvSpPr>
+        <p:spPr>
+          <a:xfrm>
+            <a:off x="814955" y="3135606"/>
+            <a:ext cx="885568" cy="646331"/>
+          </a:xfrm>
+          <a:prstGeom prst="rect">
+            <a:avLst/>
+          </a:prstGeom>
+          <a:noFill/>
+        </p:spPr>
+        <p:txBody>
+          <a:bodyPr wrap="square">
+            <a:spAutoFit/>
+          </a:bodyPr>
+          <a:lstStyle/>
+          <a:p>
+            <a:r>
+              <a:rPr lang="en-US" sz="1200" b="1" dirty="0">
+                <a:solidFill>
+                  <a:srgbClr val="C00000"/>
+                </a:solidFill>
+              </a:rPr>
+              <a:t>Motorized control breaker </a:t>
+            </a:r>
+            <a:endParaRPr lang="en-SG" sz="1200" b="1" dirty="0">
+              <a:solidFill>
+                <a:srgbClr val="C00000"/>
+              </a:solidFill>
+            </a:endParaRPr>
+          </a:p>
+        </p:txBody>
+      </p:sp>
+      <p:cxnSp>
+        <p:nvCxnSpPr>
+          <p:cNvPr id="39" name="Straight Connector 38">
+            <a:extLst>
+              <a:ext uri="{FF2B5EF4-FFF2-40B4-BE49-F238E27FC236}">
+                <a16:creationId xmlns:a16="http://schemas.microsoft.com/office/drawing/2014/main" id="{6B3BDAAF-A520-E22D-DEBC-624B3F926058}"/>
+              </a:ext>
+            </a:extLst>
+          </p:cNvPr>
+          <p:cNvCxnSpPr>
+            <a:cxnSpLocks/>
+            <a:endCxn id="32" idx="0"/>
+          </p:cNvCxnSpPr>
+          <p:nvPr/>
+        </p:nvCxnSpPr>
+        <p:spPr>
+          <a:xfrm>
+            <a:off x="3282146" y="3191691"/>
+            <a:ext cx="1" cy="203910"/>
+          </a:xfrm>
+          <a:prstGeom prst="line">
+            <a:avLst/>
+          </a:prstGeom>
+          <a:ln>
+            <a:solidFill>
+              <a:srgbClr val="C00000"/>
+            </a:solidFill>
+          </a:ln>
+        </p:spPr>
+        <p:style>
+          <a:lnRef idx="2">
+            <a:schemeClr val="accent1"/>
+          </a:lnRef>
+          <a:fillRef idx="0">
+            <a:schemeClr val="accent1"/>
+          </a:fillRef>
+          <a:effectRef idx="1">
+            <a:schemeClr val="accent1"/>
+          </a:effectRef>
+          <a:fontRef idx="minor">
+            <a:schemeClr val="tx1"/>
+          </a:fontRef>
+        </p:style>
+      </p:cxnSp>
+      <p:cxnSp>
+        <p:nvCxnSpPr>
+          <p:cNvPr id="42" name="Straight Connector 41">
+            <a:extLst>
+              <a:ext uri="{FF2B5EF4-FFF2-40B4-BE49-F238E27FC236}">
+                <a16:creationId xmlns:a16="http://schemas.microsoft.com/office/drawing/2014/main" id="{90D9419F-21D5-5045-EF05-B385EEC22484}"/>
+              </a:ext>
+            </a:extLst>
+          </p:cNvPr>
+          <p:cNvCxnSpPr>
+            <a:cxnSpLocks/>
+          </p:cNvCxnSpPr>
+          <p:nvPr/>
+        </p:nvCxnSpPr>
+        <p:spPr>
+          <a:xfrm>
+            <a:off x="3282146" y="3803698"/>
+            <a:ext cx="0" cy="338896"/>
+          </a:xfrm>
+          <a:prstGeom prst="line">
+            <a:avLst/>
+          </a:prstGeom>
+          <a:ln>
+            <a:solidFill>
+              <a:srgbClr val="C00000"/>
+            </a:solidFill>
+          </a:ln>
+        </p:spPr>
+        <p:style>
+          <a:lnRef idx="2">
+            <a:schemeClr val="accent1"/>
+          </a:lnRef>
+          <a:fillRef idx="0">
+            <a:schemeClr val="accent1"/>
+          </a:fillRef>
+          <a:effectRef idx="1">
+            <a:schemeClr val="accent1"/>
+          </a:effectRef>
+          <a:fontRef idx="minor">
+            <a:schemeClr val="tx1"/>
+          </a:fontRef>
+        </p:style>
+      </p:cxnSp>
+      <p:cxnSp>
+        <p:nvCxnSpPr>
+          <p:cNvPr id="44" name="Straight Connector 43">
+            <a:extLst>
+              <a:ext uri="{FF2B5EF4-FFF2-40B4-BE49-F238E27FC236}">
+                <a16:creationId xmlns:a16="http://schemas.microsoft.com/office/drawing/2014/main" id="{861891D7-9523-0513-40DE-FBC3876C1EC9}"/>
+              </a:ext>
+            </a:extLst>
+          </p:cNvPr>
+          <p:cNvCxnSpPr>
+            <a:cxnSpLocks/>
+          </p:cNvCxnSpPr>
+          <p:nvPr/>
+        </p:nvCxnSpPr>
+        <p:spPr>
+          <a:xfrm flipH="1">
+            <a:off x="5340376" y="3821258"/>
+            <a:ext cx="8185" cy="351106"/>
+          </a:xfrm>
+          <a:prstGeom prst="line">
+            <a:avLst/>
+          </a:prstGeom>
+          <a:ln>
+            <a:solidFill>
+              <a:srgbClr val="C00000"/>
+            </a:solidFill>
+          </a:ln>
+        </p:spPr>
+        <p:style>
+          <a:lnRef idx="2">
+            <a:schemeClr val="accent1"/>
+          </a:lnRef>
+          <a:fillRef idx="0">
+            <a:schemeClr val="accent1"/>
+          </a:fillRef>
+          <a:effectRef idx="1">
+            <a:schemeClr val="accent1"/>
+          </a:effectRef>
+          <a:fontRef idx="minor">
+            <a:schemeClr val="tx1"/>
+          </a:fontRef>
+        </p:style>
+      </p:cxnSp>
+      <p:cxnSp>
+        <p:nvCxnSpPr>
+          <p:cNvPr id="45" name="Straight Connector 44">
+            <a:extLst>
+              <a:ext uri="{FF2B5EF4-FFF2-40B4-BE49-F238E27FC236}">
+                <a16:creationId xmlns:a16="http://schemas.microsoft.com/office/drawing/2014/main" id="{554260F0-C412-5EF3-3236-1A005E41A01E}"/>
+              </a:ext>
+            </a:extLst>
+          </p:cNvPr>
+          <p:cNvCxnSpPr>
+            <a:cxnSpLocks/>
+          </p:cNvCxnSpPr>
+          <p:nvPr/>
+        </p:nvCxnSpPr>
+        <p:spPr>
+          <a:xfrm>
+            <a:off x="7192356" y="3793894"/>
+            <a:ext cx="0" cy="368121"/>
+          </a:xfrm>
+          <a:prstGeom prst="line">
+            <a:avLst/>
+          </a:prstGeom>
+          <a:ln>
+            <a:solidFill>
+              <a:srgbClr val="C00000"/>
+            </a:solidFill>
+          </a:ln>
+        </p:spPr>
+        <p:style>
+          <a:lnRef idx="2">
+            <a:schemeClr val="accent1"/>
+          </a:lnRef>
+          <a:fillRef idx="0">
+            <a:schemeClr val="accent1"/>
+          </a:fillRef>
+          <a:effectRef idx="1">
+            <a:schemeClr val="accent1"/>
+          </a:effectRef>
+          <a:fontRef idx="minor">
+            <a:schemeClr val="tx1"/>
+          </a:fontRef>
+        </p:style>
+      </p:cxnSp>
+      <p:cxnSp>
+        <p:nvCxnSpPr>
+          <p:cNvPr id="49" name="Straight Connector 48">
+            <a:extLst>
+              <a:ext uri="{FF2B5EF4-FFF2-40B4-BE49-F238E27FC236}">
+                <a16:creationId xmlns:a16="http://schemas.microsoft.com/office/drawing/2014/main" id="{29DBBDD3-1681-E2E6-5296-97D590774A05}"/>
+              </a:ext>
+            </a:extLst>
+          </p:cNvPr>
+          <p:cNvCxnSpPr>
+            <a:cxnSpLocks/>
+          </p:cNvCxnSpPr>
+          <p:nvPr/>
+        </p:nvCxnSpPr>
+        <p:spPr>
+          <a:xfrm flipH="1">
+            <a:off x="8941470" y="3829249"/>
+            <a:ext cx="8185" cy="351106"/>
+          </a:xfrm>
+          <a:prstGeom prst="line">
+            <a:avLst/>
+          </a:prstGeom>
+          <a:ln>
+            <a:solidFill>
+              <a:srgbClr val="C00000"/>
+            </a:solidFill>
+          </a:ln>
+        </p:spPr>
+        <p:style>
+          <a:lnRef idx="2">
+            <a:schemeClr val="accent1"/>
+          </a:lnRef>
+          <a:fillRef idx="0">
+            <a:schemeClr val="accent1"/>
+          </a:fillRef>
+          <a:effectRef idx="1">
+            <a:schemeClr val="accent1"/>
+          </a:effectRef>
+          <a:fontRef idx="minor">
+            <a:schemeClr val="tx1"/>
+          </a:fontRef>
+        </p:style>
+      </p:cxnSp>
+      <p:cxnSp>
+        <p:nvCxnSpPr>
+          <p:cNvPr id="50" name="Straight Connector 49">
+            <a:extLst>
+              <a:ext uri="{FF2B5EF4-FFF2-40B4-BE49-F238E27FC236}">
+                <a16:creationId xmlns:a16="http://schemas.microsoft.com/office/drawing/2014/main" id="{7A7B00CB-C4DA-B1C3-95F2-7AF3710EB670}"/>
+              </a:ext>
+            </a:extLst>
+          </p:cNvPr>
+          <p:cNvCxnSpPr>
+            <a:cxnSpLocks/>
+            <a:endCxn id="33" idx="0"/>
+          </p:cNvCxnSpPr>
+          <p:nvPr/>
+        </p:nvCxnSpPr>
+        <p:spPr>
+          <a:xfrm>
+            <a:off x="5348560" y="3189538"/>
+            <a:ext cx="2550" cy="206063"/>
+          </a:xfrm>
+          <a:prstGeom prst="line">
+            <a:avLst/>
+          </a:prstGeom>
+          <a:ln>
+            <a:solidFill>
+              <a:srgbClr val="C00000"/>
+            </a:solidFill>
+          </a:ln>
+        </p:spPr>
+        <p:style>
+          <a:lnRef idx="2">
+            <a:schemeClr val="accent1"/>
+          </a:lnRef>
+          <a:fillRef idx="0">
+            <a:schemeClr val="accent1"/>
+          </a:fillRef>
+          <a:effectRef idx="1">
+            <a:schemeClr val="accent1"/>
+          </a:effectRef>
+          <a:fontRef idx="minor">
+            <a:schemeClr val="tx1"/>
+          </a:fontRef>
+        </p:style>
+      </p:cxnSp>
+      <p:cxnSp>
+        <p:nvCxnSpPr>
+          <p:cNvPr id="52" name="Straight Connector 51">
+            <a:extLst>
+              <a:ext uri="{FF2B5EF4-FFF2-40B4-BE49-F238E27FC236}">
+                <a16:creationId xmlns:a16="http://schemas.microsoft.com/office/drawing/2014/main" id="{784AE7D4-4F04-30C0-F703-33C2C1B0FBCD}"/>
+              </a:ext>
+            </a:extLst>
+          </p:cNvPr>
+          <p:cNvCxnSpPr>
+            <a:cxnSpLocks/>
+          </p:cNvCxnSpPr>
+          <p:nvPr/>
+        </p:nvCxnSpPr>
+        <p:spPr>
+          <a:xfrm>
+            <a:off x="7204790" y="3206496"/>
+            <a:ext cx="1" cy="203910"/>
+          </a:xfrm>
+          <a:prstGeom prst="line">
+            <a:avLst/>
+          </a:prstGeom>
+          <a:ln>
+            <a:solidFill>
+              <a:srgbClr val="C00000"/>
+            </a:solidFill>
+          </a:ln>
+        </p:spPr>
+        <p:style>
+          <a:lnRef idx="2">
+            <a:schemeClr val="accent1"/>
+          </a:lnRef>
+          <a:fillRef idx="0">
+            <a:schemeClr val="accent1"/>
+          </a:fillRef>
+          <a:effectRef idx="1">
+            <a:schemeClr val="accent1"/>
+          </a:effectRef>
+          <a:fontRef idx="minor">
+            <a:schemeClr val="tx1"/>
+          </a:fontRef>
+        </p:style>
+      </p:cxnSp>
+      <p:cxnSp>
+        <p:nvCxnSpPr>
+          <p:cNvPr id="53" name="Straight Connector 52">
+            <a:extLst>
+              <a:ext uri="{FF2B5EF4-FFF2-40B4-BE49-F238E27FC236}">
+                <a16:creationId xmlns:a16="http://schemas.microsoft.com/office/drawing/2014/main" id="{FC2DEA7D-41CB-781A-7C3B-839E6CD819E0}"/>
+              </a:ext>
+            </a:extLst>
+          </p:cNvPr>
+          <p:cNvCxnSpPr>
+            <a:cxnSpLocks/>
+          </p:cNvCxnSpPr>
+          <p:nvPr/>
+        </p:nvCxnSpPr>
+        <p:spPr>
+          <a:xfrm>
+            <a:off x="8932586" y="3189538"/>
+            <a:ext cx="0" cy="220868"/>
+          </a:xfrm>
+          <a:prstGeom prst="line">
+            <a:avLst/>
+          </a:prstGeom>
+          <a:ln>
+            <a:solidFill>
+              <a:srgbClr val="C00000"/>
+            </a:solidFill>
+          </a:ln>
+        </p:spPr>
+        <p:style>
+          <a:lnRef idx="2">
+            <a:schemeClr val="accent1"/>
+          </a:lnRef>
+          <a:fillRef idx="0">
+            <a:schemeClr val="accent1"/>
+          </a:fillRef>
+          <a:effectRef idx="1">
+            <a:schemeClr val="accent1"/>
+          </a:effectRef>
+          <a:fontRef idx="minor">
+            <a:schemeClr val="tx1"/>
+          </a:fontRef>
+        </p:style>
+      </p:cxnSp>
+      <p:sp>
+        <p:nvSpPr>
+          <p:cNvPr id="55" name="TextBox 54">
+            <a:extLst>
+              <a:ext uri="{FF2B5EF4-FFF2-40B4-BE49-F238E27FC236}">
+                <a16:creationId xmlns:a16="http://schemas.microsoft.com/office/drawing/2014/main" id="{B8FA6265-0622-57A9-9682-CB3BCECAA32B}"/>
+              </a:ext>
+            </a:extLst>
+          </p:cNvPr>
+          <p:cNvSpPr txBox="1"/>
+          <p:nvPr/>
+        </p:nvSpPr>
+        <p:spPr>
+          <a:xfrm>
+            <a:off x="9909048" y="3893859"/>
+            <a:ext cx="1621515" cy="461665"/>
+          </a:xfrm>
+          <a:prstGeom prst="rect">
+            <a:avLst/>
+          </a:prstGeom>
+          <a:noFill/>
+        </p:spPr>
+        <p:txBody>
+          <a:bodyPr wrap="square">
+            <a:spAutoFit/>
+          </a:bodyPr>
+          <a:lstStyle/>
+          <a:p>
+            <a:r>
+              <a:rPr lang="en-US" sz="1200" b="1" dirty="0">
+                <a:solidFill>
+                  <a:srgbClr val="C00000"/>
+                </a:solidFill>
+              </a:rPr>
+              <a:t>Railway third track 750V DC [Power] </a:t>
+            </a:r>
+            <a:endParaRPr lang="en-SG" sz="1200" b="1" dirty="0">
+              <a:solidFill>
+                <a:srgbClr val="C00000"/>
+              </a:solidFill>
+            </a:endParaRPr>
+          </a:p>
+        </p:txBody>
+      </p:sp>
+      <p:sp>
+        <p:nvSpPr>
+          <p:cNvPr id="56" name="TextBox 55">
+            <a:extLst>
+              <a:ext uri="{FF2B5EF4-FFF2-40B4-BE49-F238E27FC236}">
+                <a16:creationId xmlns:a16="http://schemas.microsoft.com/office/drawing/2014/main" id="{CF55E3B0-1A42-648F-B538-10CF5DCD3BE5}"/>
+              </a:ext>
+            </a:extLst>
+          </p:cNvPr>
+          <p:cNvSpPr txBox="1"/>
+          <p:nvPr/>
+        </p:nvSpPr>
+        <p:spPr>
+          <a:xfrm>
+            <a:off x="580371" y="3918745"/>
+            <a:ext cx="469168" cy="261610"/>
+          </a:xfrm>
+          <a:prstGeom prst="rect">
+            <a:avLst/>
+          </a:prstGeom>
+          <a:noFill/>
+        </p:spPr>
+        <p:txBody>
+          <a:bodyPr wrap="square" rtlCol="0">
+            <a:spAutoFit/>
+          </a:bodyPr>
+          <a:lstStyle/>
+          <a:p>
+            <a:r>
+              <a:rPr lang="en-US" sz="1100" b="1" dirty="0">
+                <a:solidFill>
+                  <a:srgbClr val="C00000"/>
+                </a:solidFill>
+              </a:rPr>
+              <a:t>B01</a:t>
+            </a:r>
+            <a:endParaRPr lang="en-SG" sz="1100" b="1" dirty="0">
+              <a:solidFill>
+                <a:srgbClr val="C00000"/>
+              </a:solidFill>
+            </a:endParaRPr>
+          </a:p>
+        </p:txBody>
+      </p:sp>
+      <p:sp>
+        <p:nvSpPr>
+          <p:cNvPr id="57" name="TextBox 56">
+            <a:extLst>
+              <a:ext uri="{FF2B5EF4-FFF2-40B4-BE49-F238E27FC236}">
+                <a16:creationId xmlns:a16="http://schemas.microsoft.com/office/drawing/2014/main" id="{99A83D4B-4A65-B964-22DD-6E990A16B02D}"/>
+              </a:ext>
+            </a:extLst>
+          </p:cNvPr>
+          <p:cNvSpPr txBox="1"/>
+          <p:nvPr/>
+        </p:nvSpPr>
+        <p:spPr>
+          <a:xfrm>
+            <a:off x="2467253" y="3918745"/>
+            <a:ext cx="469168" cy="261610"/>
+          </a:xfrm>
+          <a:prstGeom prst="rect">
+            <a:avLst/>
+          </a:prstGeom>
+          <a:noFill/>
+        </p:spPr>
+        <p:txBody>
+          <a:bodyPr wrap="square" rtlCol="0">
+            <a:spAutoFit/>
+          </a:bodyPr>
+          <a:lstStyle/>
+          <a:p>
+            <a:r>
+              <a:rPr lang="en-US" sz="1100" b="1" dirty="0">
+                <a:solidFill>
+                  <a:srgbClr val="C00000"/>
+                </a:solidFill>
+              </a:rPr>
+              <a:t>B02</a:t>
+            </a:r>
+            <a:endParaRPr lang="en-SG" sz="1100" b="1" dirty="0">
+              <a:solidFill>
+                <a:srgbClr val="C00000"/>
+              </a:solidFill>
+            </a:endParaRPr>
+          </a:p>
+        </p:txBody>
+      </p:sp>
+      <p:sp>
+        <p:nvSpPr>
+          <p:cNvPr id="58" name="TextBox 57">
+            <a:extLst>
+              <a:ext uri="{FF2B5EF4-FFF2-40B4-BE49-F238E27FC236}">
+                <a16:creationId xmlns:a16="http://schemas.microsoft.com/office/drawing/2014/main" id="{47914E78-3B52-ADA0-FC96-585208000332}"/>
+              </a:ext>
+            </a:extLst>
+          </p:cNvPr>
+          <p:cNvSpPr txBox="1"/>
+          <p:nvPr/>
+        </p:nvSpPr>
+        <p:spPr>
+          <a:xfrm>
+            <a:off x="4391512" y="3928636"/>
+            <a:ext cx="469168" cy="261610"/>
+          </a:xfrm>
+          <a:prstGeom prst="rect">
+            <a:avLst/>
+          </a:prstGeom>
+          <a:noFill/>
+        </p:spPr>
+        <p:txBody>
+          <a:bodyPr wrap="square" rtlCol="0">
+            <a:spAutoFit/>
+          </a:bodyPr>
+          <a:lstStyle/>
+          <a:p>
+            <a:r>
+              <a:rPr lang="en-US" sz="1100" b="1" dirty="0">
+                <a:solidFill>
+                  <a:srgbClr val="C00000"/>
+                </a:solidFill>
+              </a:rPr>
+              <a:t>B03</a:t>
+            </a:r>
+            <a:endParaRPr lang="en-SG" sz="1100" b="1" dirty="0">
+              <a:solidFill>
+                <a:srgbClr val="C00000"/>
+              </a:solidFill>
+            </a:endParaRPr>
+          </a:p>
+        </p:txBody>
+      </p:sp>
+      <p:sp>
+        <p:nvSpPr>
+          <p:cNvPr id="59" name="TextBox 58">
+            <a:extLst>
+              <a:ext uri="{FF2B5EF4-FFF2-40B4-BE49-F238E27FC236}">
+                <a16:creationId xmlns:a16="http://schemas.microsoft.com/office/drawing/2014/main" id="{34781B51-84BE-E753-E1D7-A1BCB964612E}"/>
+              </a:ext>
+            </a:extLst>
+          </p:cNvPr>
+          <p:cNvSpPr txBox="1"/>
+          <p:nvPr/>
+        </p:nvSpPr>
+        <p:spPr>
+          <a:xfrm>
+            <a:off x="6225527" y="3900405"/>
+            <a:ext cx="469168" cy="261610"/>
+          </a:xfrm>
+          <a:prstGeom prst="rect">
+            <a:avLst/>
+          </a:prstGeom>
+          <a:noFill/>
+        </p:spPr>
+        <p:txBody>
+          <a:bodyPr wrap="square" rtlCol="0">
+            <a:spAutoFit/>
+          </a:bodyPr>
+          <a:lstStyle/>
+          <a:p>
+            <a:r>
+              <a:rPr lang="en-US" sz="1100" b="1" dirty="0">
+                <a:solidFill>
+                  <a:srgbClr val="C00000"/>
+                </a:solidFill>
+              </a:rPr>
+              <a:t>B04</a:t>
+            </a:r>
+            <a:endParaRPr lang="en-SG" sz="1100" b="1" dirty="0">
+              <a:solidFill>
+                <a:srgbClr val="C00000"/>
+              </a:solidFill>
+            </a:endParaRPr>
+          </a:p>
+        </p:txBody>
+      </p:sp>
+      <p:sp>
+        <p:nvSpPr>
+          <p:cNvPr id="60" name="TextBox 59">
+            <a:extLst>
+              <a:ext uri="{FF2B5EF4-FFF2-40B4-BE49-F238E27FC236}">
+                <a16:creationId xmlns:a16="http://schemas.microsoft.com/office/drawing/2014/main" id="{A0C68BB2-6827-BA3D-55CA-8610B7C14437}"/>
+              </a:ext>
+            </a:extLst>
+          </p:cNvPr>
+          <p:cNvSpPr txBox="1"/>
+          <p:nvPr/>
+        </p:nvSpPr>
+        <p:spPr>
+          <a:xfrm>
+            <a:off x="8080636" y="3918745"/>
+            <a:ext cx="469168" cy="261610"/>
+          </a:xfrm>
+          <a:prstGeom prst="rect">
+            <a:avLst/>
+          </a:prstGeom>
+          <a:noFill/>
+        </p:spPr>
+        <p:txBody>
+          <a:bodyPr wrap="square" rtlCol="0">
+            <a:spAutoFit/>
+          </a:bodyPr>
+          <a:lstStyle/>
+          <a:p>
+            <a:r>
+              <a:rPr lang="en-US" sz="1100" b="1" dirty="0">
+                <a:solidFill>
+                  <a:srgbClr val="C00000"/>
+                </a:solidFill>
+              </a:rPr>
+              <a:t>B05</a:t>
+            </a:r>
+            <a:endParaRPr lang="en-SG" sz="1100" b="1" dirty="0">
+              <a:solidFill>
+                <a:srgbClr val="C00000"/>
+              </a:solidFill>
+            </a:endParaRPr>
+          </a:p>
+        </p:txBody>
+      </p:sp>
+      <p:pic>
+        <p:nvPicPr>
+          <p:cNvPr id="61" name="Picture 60" descr="TM221CE16R Schneider Electric Modicon M221 PLC CPU Mini USB Interface –  Ralakde Automation">
+            <a:extLst>
+              <a:ext uri="{FF2B5EF4-FFF2-40B4-BE49-F238E27FC236}">
+                <a16:creationId xmlns:a16="http://schemas.microsoft.com/office/drawing/2014/main" id="{E133E8D8-C874-B90A-8CA5-FBBB6D8EB101}"/>
+              </a:ext>
+            </a:extLst>
+          </p:cNvPr>
+          <p:cNvPicPr>
+            <a:picLocks noChangeAspect="1" noChangeArrowheads="1"/>
+          </p:cNvPicPr>
+          <p:nvPr/>
+        </p:nvPicPr>
+        <p:blipFill>
+          <a:blip r:embed="rId6">
+            <a:extLst>
+              <a:ext uri="{28A0092B-C50C-407E-A947-70E740481C1C}">
+                <a14:useLocalDpi xmlns:a14="http://schemas.microsoft.com/office/drawing/2010/main" val="0"/>
+              </a:ext>
+            </a:extLst>
+          </a:blip>
+          <a:srcRect/>
+          <a:stretch>
+            <a:fillRect/>
+          </a:stretch>
+        </p:blipFill>
+        <p:spPr bwMode="auto">
+          <a:xfrm>
+            <a:off x="4646777" y="2035696"/>
+            <a:ext cx="641390" cy="703154"/>
+          </a:xfrm>
+          <a:prstGeom prst="rect">
+            <a:avLst/>
+          </a:prstGeom>
+          <a:noFill/>
+          <a:extLst>
+            <a:ext uri="{909E8E84-426E-40DD-AFC4-6F175D3DCCD1}">
+              <a14:hiddenFill xmlns:a14="http://schemas.microsoft.com/office/drawing/2010/main">
+                <a:solidFill>
+                  <a:srgbClr val="FFFFFF"/>
+                </a:solidFill>
+              </a14:hiddenFill>
+            </a:ext>
+          </a:extLst>
+        </p:spPr>
+      </p:pic>
+      <p:sp>
+        <p:nvSpPr>
+          <p:cNvPr id="62" name="TextBox 61">
+            <a:extLst>
+              <a:ext uri="{FF2B5EF4-FFF2-40B4-BE49-F238E27FC236}">
+                <a16:creationId xmlns:a16="http://schemas.microsoft.com/office/drawing/2014/main" id="{B0838A49-8446-132A-F45F-7533F46CDF5C}"/>
+              </a:ext>
+            </a:extLst>
+          </p:cNvPr>
+          <p:cNvSpPr txBox="1"/>
+          <p:nvPr/>
+        </p:nvSpPr>
+        <p:spPr>
+          <a:xfrm>
+            <a:off x="4151462" y="1576752"/>
+            <a:ext cx="1484286" cy="461665"/>
+          </a:xfrm>
+          <a:prstGeom prst="rect">
+            <a:avLst/>
+          </a:prstGeom>
+          <a:noFill/>
+        </p:spPr>
+        <p:txBody>
+          <a:bodyPr wrap="square">
+            <a:spAutoFit/>
+          </a:bodyPr>
+          <a:lstStyle/>
+          <a:p>
+            <a:r>
+              <a:rPr lang="en-US" sz="1200" b="1" dirty="0"/>
+              <a:t>Third track block power control PLC</a:t>
+            </a:r>
+            <a:endParaRPr lang="en-SG" sz="1200" b="1" dirty="0"/>
+          </a:p>
+        </p:txBody>
+      </p:sp>
+      <p:cxnSp>
+        <p:nvCxnSpPr>
+          <p:cNvPr id="64" name="Straight Connector 63">
+            <a:extLst>
+              <a:ext uri="{FF2B5EF4-FFF2-40B4-BE49-F238E27FC236}">
+                <a16:creationId xmlns:a16="http://schemas.microsoft.com/office/drawing/2014/main" id="{6E3E4967-54E5-416D-D4F1-2628D0B1F7BC}"/>
+              </a:ext>
+            </a:extLst>
+          </p:cNvPr>
+          <p:cNvCxnSpPr>
+            <a:cxnSpLocks/>
+          </p:cNvCxnSpPr>
+          <p:nvPr/>
+        </p:nvCxnSpPr>
+        <p:spPr>
+          <a:xfrm>
+            <a:off x="2300830" y="3008376"/>
+            <a:ext cx="6166514" cy="0"/>
+          </a:xfrm>
+          <a:prstGeom prst="line">
+            <a:avLst/>
+          </a:prstGeom>
+        </p:spPr>
+        <p:style>
+          <a:lnRef idx="2">
+            <a:schemeClr val="accent1"/>
+          </a:lnRef>
+          <a:fillRef idx="0">
+            <a:schemeClr val="accent1"/>
+          </a:fillRef>
+          <a:effectRef idx="1">
+            <a:schemeClr val="accent1"/>
+          </a:effectRef>
+          <a:fontRef idx="minor">
+            <a:schemeClr val="tx1"/>
+          </a:fontRef>
+        </p:style>
+      </p:cxnSp>
+      <p:cxnSp>
+        <p:nvCxnSpPr>
+          <p:cNvPr id="67" name="Connector: Elbow 66">
+            <a:extLst>
+              <a:ext uri="{FF2B5EF4-FFF2-40B4-BE49-F238E27FC236}">
+                <a16:creationId xmlns:a16="http://schemas.microsoft.com/office/drawing/2014/main" id="{4F6901F7-96D8-0482-75A1-D408CF0F16F3}"/>
+              </a:ext>
+            </a:extLst>
+          </p:cNvPr>
+          <p:cNvCxnSpPr>
+            <a:cxnSpLocks/>
+            <a:endCxn id="32" idx="3"/>
+          </p:cNvCxnSpPr>
+          <p:nvPr/>
+        </p:nvCxnSpPr>
+        <p:spPr>
+          <a:xfrm rot="5400000">
+            <a:off x="3313450" y="3115257"/>
+            <a:ext cx="612039" cy="382297"/>
+          </a:xfrm>
+          <a:prstGeom prst="bentConnector2">
+            <a:avLst/>
+          </a:prstGeom>
+        </p:spPr>
+        <p:style>
+          <a:lnRef idx="2">
+            <a:schemeClr val="accent1"/>
+          </a:lnRef>
+          <a:fillRef idx="0">
+            <a:schemeClr val="accent1"/>
+          </a:fillRef>
+          <a:effectRef idx="1">
+            <a:schemeClr val="accent1"/>
+          </a:effectRef>
+          <a:fontRef idx="minor">
+            <a:schemeClr val="tx1"/>
+          </a:fontRef>
+        </p:style>
+      </p:cxnSp>
+      <p:cxnSp>
+        <p:nvCxnSpPr>
+          <p:cNvPr id="72" name="Connector: Elbow 71">
+            <a:extLst>
+              <a:ext uri="{FF2B5EF4-FFF2-40B4-BE49-F238E27FC236}">
+                <a16:creationId xmlns:a16="http://schemas.microsoft.com/office/drawing/2014/main" id="{F521A548-58E7-C5C0-A6F9-6F2063192A38}"/>
+              </a:ext>
+            </a:extLst>
+          </p:cNvPr>
+          <p:cNvCxnSpPr>
+            <a:cxnSpLocks/>
+          </p:cNvCxnSpPr>
+          <p:nvPr/>
+        </p:nvCxnSpPr>
+        <p:spPr>
+          <a:xfrm rot="5400000">
+            <a:off x="1801336" y="3078658"/>
+            <a:ext cx="596058" cy="426443"/>
+          </a:xfrm>
+          <a:prstGeom prst="bentConnector2">
+            <a:avLst/>
+          </a:prstGeom>
+        </p:spPr>
+        <p:style>
+          <a:lnRef idx="2">
+            <a:schemeClr val="accent1"/>
+          </a:lnRef>
+          <a:fillRef idx="0">
+            <a:schemeClr val="accent1"/>
+          </a:fillRef>
+          <a:effectRef idx="1">
+            <a:schemeClr val="accent1"/>
+          </a:effectRef>
+          <a:fontRef idx="minor">
+            <a:schemeClr val="tx1"/>
+          </a:fontRef>
+        </p:style>
+      </p:cxnSp>
+      <p:cxnSp>
+        <p:nvCxnSpPr>
+          <p:cNvPr id="75" name="Connector: Elbow 74">
+            <a:extLst>
+              <a:ext uri="{FF2B5EF4-FFF2-40B4-BE49-F238E27FC236}">
+                <a16:creationId xmlns:a16="http://schemas.microsoft.com/office/drawing/2014/main" id="{F9511936-9A1F-1A92-170A-5D6B2980BAA5}"/>
+              </a:ext>
+            </a:extLst>
+          </p:cNvPr>
+          <p:cNvCxnSpPr>
+            <a:cxnSpLocks/>
+          </p:cNvCxnSpPr>
+          <p:nvPr/>
+        </p:nvCxnSpPr>
+        <p:spPr>
+          <a:xfrm rot="5400000">
+            <a:off x="5345962" y="3123247"/>
+            <a:ext cx="612039" cy="382297"/>
+          </a:xfrm>
+          <a:prstGeom prst="bentConnector2">
+            <a:avLst/>
+          </a:prstGeom>
+        </p:spPr>
+        <p:style>
+          <a:lnRef idx="2">
+            <a:schemeClr val="accent1"/>
+          </a:lnRef>
+          <a:fillRef idx="0">
+            <a:schemeClr val="accent1"/>
+          </a:fillRef>
+          <a:effectRef idx="1">
+            <a:schemeClr val="accent1"/>
+          </a:effectRef>
+          <a:fontRef idx="minor">
+            <a:schemeClr val="tx1"/>
+          </a:fontRef>
+        </p:style>
+      </p:cxnSp>
+      <p:cxnSp>
+        <p:nvCxnSpPr>
+          <p:cNvPr id="76" name="Connector: Elbow 75">
+            <a:extLst>
+              <a:ext uri="{FF2B5EF4-FFF2-40B4-BE49-F238E27FC236}">
+                <a16:creationId xmlns:a16="http://schemas.microsoft.com/office/drawing/2014/main" id="{EAFCED09-AA27-AE16-FECD-3B9F90718E4E}"/>
+              </a:ext>
+            </a:extLst>
+          </p:cNvPr>
+          <p:cNvCxnSpPr>
+            <a:cxnSpLocks/>
+            <a:endCxn id="34" idx="3"/>
+          </p:cNvCxnSpPr>
+          <p:nvPr/>
+        </p:nvCxnSpPr>
+        <p:spPr>
+          <a:xfrm rot="5400000">
+            <a:off x="7251920" y="3107423"/>
+            <a:ext cx="578497" cy="380405"/>
+          </a:xfrm>
+          <a:prstGeom prst="bentConnector2">
+            <a:avLst/>
+          </a:prstGeom>
+        </p:spPr>
+        <p:style>
+          <a:lnRef idx="2">
+            <a:schemeClr val="accent1"/>
+          </a:lnRef>
+          <a:fillRef idx="0">
+            <a:schemeClr val="accent1"/>
+          </a:fillRef>
+          <a:effectRef idx="1">
+            <a:schemeClr val="accent1"/>
+          </a:effectRef>
+          <a:fontRef idx="minor">
+            <a:schemeClr val="tx1"/>
+          </a:fontRef>
+        </p:style>
+      </p:cxnSp>
+      <p:cxnSp>
+        <p:nvCxnSpPr>
+          <p:cNvPr id="79" name="Connector: Elbow 78">
+            <a:extLst>
+              <a:ext uri="{FF2B5EF4-FFF2-40B4-BE49-F238E27FC236}">
+                <a16:creationId xmlns:a16="http://schemas.microsoft.com/office/drawing/2014/main" id="{9E54BD4F-05D2-464E-1422-EF92CA04D26D}"/>
+              </a:ext>
+            </a:extLst>
+          </p:cNvPr>
+          <p:cNvCxnSpPr>
+            <a:cxnSpLocks/>
+            <a:endCxn id="35" idx="1"/>
+          </p:cNvCxnSpPr>
+          <p:nvPr/>
+        </p:nvCxnSpPr>
+        <p:spPr>
+          <a:xfrm rot="16200000" flipH="1">
+            <a:off x="8329747" y="3120404"/>
+            <a:ext cx="576960" cy="336372"/>
+          </a:xfrm>
+          <a:prstGeom prst="bentConnector2">
+            <a:avLst/>
+          </a:prstGeom>
+        </p:spPr>
+        <p:style>
+          <a:lnRef idx="2">
+            <a:schemeClr val="accent1"/>
+          </a:lnRef>
+          <a:fillRef idx="0">
+            <a:schemeClr val="accent1"/>
+          </a:fillRef>
+          <a:effectRef idx="1">
+            <a:schemeClr val="accent1"/>
+          </a:effectRef>
+          <a:fontRef idx="minor">
+            <a:schemeClr val="tx1"/>
+          </a:fontRef>
+        </p:style>
+      </p:cxnSp>
+      <p:cxnSp>
+        <p:nvCxnSpPr>
+          <p:cNvPr id="82" name="Straight Connector 81">
+            <a:extLst>
+              <a:ext uri="{FF2B5EF4-FFF2-40B4-BE49-F238E27FC236}">
+                <a16:creationId xmlns:a16="http://schemas.microsoft.com/office/drawing/2014/main" id="{4D18D944-6C4D-5B11-6097-AD11FD11E7E0}"/>
+              </a:ext>
+            </a:extLst>
+          </p:cNvPr>
+          <p:cNvCxnSpPr>
+            <a:stCxn id="61" idx="2"/>
+          </p:cNvCxnSpPr>
+          <p:nvPr/>
+        </p:nvCxnSpPr>
+        <p:spPr>
+          <a:xfrm>
+            <a:off x="4967472" y="2738850"/>
+            <a:ext cx="0" cy="269526"/>
+          </a:xfrm>
+          <a:prstGeom prst="line">
+            <a:avLst/>
+          </a:prstGeom>
+        </p:spPr>
+        <p:style>
+          <a:lnRef idx="2">
+            <a:schemeClr val="accent1"/>
+          </a:lnRef>
+          <a:fillRef idx="0">
+            <a:schemeClr val="accent1"/>
+          </a:fillRef>
+          <a:effectRef idx="1">
+            <a:schemeClr val="accent1"/>
+          </a:effectRef>
+          <a:fontRef idx="minor">
+            <a:schemeClr val="tx1"/>
+          </a:fontRef>
+        </p:style>
+      </p:cxnSp>
+      <p:sp>
+        <p:nvSpPr>
+          <p:cNvPr id="83" name="TextBox 82">
+            <a:extLst>
+              <a:ext uri="{FF2B5EF4-FFF2-40B4-BE49-F238E27FC236}">
+                <a16:creationId xmlns:a16="http://schemas.microsoft.com/office/drawing/2014/main" id="{EEAD9B22-88C0-AEF1-DE60-7D319549D932}"/>
+              </a:ext>
+            </a:extLst>
+          </p:cNvPr>
+          <p:cNvSpPr txBox="1"/>
+          <p:nvPr/>
+        </p:nvSpPr>
+        <p:spPr>
+          <a:xfrm>
+            <a:off x="2738158" y="2719970"/>
+            <a:ext cx="2108166" cy="276999"/>
+          </a:xfrm>
+          <a:prstGeom prst="rect">
+            <a:avLst/>
+          </a:prstGeom>
+          <a:noFill/>
+        </p:spPr>
+        <p:txBody>
+          <a:bodyPr wrap="square" rtlCol="0">
+            <a:spAutoFit/>
+          </a:bodyPr>
+          <a:lstStyle/>
+          <a:p>
+            <a:r>
+              <a:rPr lang="en-US" sz="1200" b="1" dirty="0"/>
+              <a:t>48V one to one control link</a:t>
+            </a:r>
+            <a:endParaRPr lang="en-SG" sz="1200" b="1" dirty="0"/>
+          </a:p>
+        </p:txBody>
+      </p:sp>
+      <p:sp>
+        <p:nvSpPr>
+          <p:cNvPr id="84" name="TextBox 83">
+            <a:extLst>
+              <a:ext uri="{FF2B5EF4-FFF2-40B4-BE49-F238E27FC236}">
+                <a16:creationId xmlns:a16="http://schemas.microsoft.com/office/drawing/2014/main" id="{40719B34-6E87-332A-3013-D4DC654E92CE}"/>
+              </a:ext>
+            </a:extLst>
+          </p:cNvPr>
+          <p:cNvSpPr txBox="1"/>
+          <p:nvPr/>
+        </p:nvSpPr>
+        <p:spPr>
+          <a:xfrm>
+            <a:off x="1862211" y="3604434"/>
+            <a:ext cx="634949" cy="261610"/>
+          </a:xfrm>
+          <a:prstGeom prst="rect">
+            <a:avLst/>
+          </a:prstGeom>
+          <a:noFill/>
+        </p:spPr>
+        <p:txBody>
+          <a:bodyPr wrap="square" rtlCol="0">
+            <a:spAutoFit/>
+          </a:bodyPr>
+          <a:lstStyle/>
+          <a:p>
+            <a:r>
+              <a:rPr lang="en-US" sz="1100" b="1" dirty="0">
+                <a:solidFill>
+                  <a:schemeClr val="accent1"/>
+                </a:solidFill>
+              </a:rPr>
+              <a:t>CR01</a:t>
+            </a:r>
+            <a:endParaRPr lang="en-SG" sz="1100" b="1" dirty="0">
+              <a:solidFill>
+                <a:schemeClr val="accent1"/>
+              </a:solidFill>
+            </a:endParaRPr>
+          </a:p>
+        </p:txBody>
+      </p:sp>
+      <p:sp>
+        <p:nvSpPr>
+          <p:cNvPr id="85" name="TextBox 84">
+            <a:extLst>
+              <a:ext uri="{FF2B5EF4-FFF2-40B4-BE49-F238E27FC236}">
+                <a16:creationId xmlns:a16="http://schemas.microsoft.com/office/drawing/2014/main" id="{8C20DD13-8565-A535-E1D5-57D48A8BBB35}"/>
+              </a:ext>
+            </a:extLst>
+          </p:cNvPr>
+          <p:cNvSpPr txBox="1"/>
+          <p:nvPr/>
+        </p:nvSpPr>
+        <p:spPr>
+          <a:xfrm>
+            <a:off x="3394639" y="3620341"/>
+            <a:ext cx="634949" cy="261610"/>
+          </a:xfrm>
+          <a:prstGeom prst="rect">
+            <a:avLst/>
+          </a:prstGeom>
+          <a:noFill/>
+        </p:spPr>
+        <p:txBody>
+          <a:bodyPr wrap="square" rtlCol="0">
+            <a:spAutoFit/>
+          </a:bodyPr>
+          <a:lstStyle/>
+          <a:p>
+            <a:r>
+              <a:rPr lang="en-US" sz="1100" b="1" dirty="0">
+                <a:solidFill>
+                  <a:schemeClr val="accent1"/>
+                </a:solidFill>
+              </a:rPr>
+              <a:t>CR02</a:t>
+            </a:r>
+            <a:endParaRPr lang="en-SG" sz="1100" b="1" dirty="0">
+              <a:solidFill>
+                <a:schemeClr val="accent1"/>
+              </a:solidFill>
+            </a:endParaRPr>
+          </a:p>
+        </p:txBody>
+      </p:sp>
+      <p:sp>
+        <p:nvSpPr>
+          <p:cNvPr id="86" name="TextBox 85">
+            <a:extLst>
+              <a:ext uri="{FF2B5EF4-FFF2-40B4-BE49-F238E27FC236}">
+                <a16:creationId xmlns:a16="http://schemas.microsoft.com/office/drawing/2014/main" id="{BEECC0DB-3772-32DB-C471-890792ACEBE8}"/>
+              </a:ext>
+            </a:extLst>
+          </p:cNvPr>
+          <p:cNvSpPr txBox="1"/>
+          <p:nvPr/>
+        </p:nvSpPr>
+        <p:spPr>
+          <a:xfrm>
+            <a:off x="5452868" y="3600441"/>
+            <a:ext cx="634949" cy="261610"/>
+          </a:xfrm>
+          <a:prstGeom prst="rect">
+            <a:avLst/>
+          </a:prstGeom>
+          <a:noFill/>
+        </p:spPr>
+        <p:txBody>
+          <a:bodyPr wrap="square" rtlCol="0">
+            <a:spAutoFit/>
+          </a:bodyPr>
+          <a:lstStyle/>
+          <a:p>
+            <a:r>
+              <a:rPr lang="en-US" sz="1100" b="1" dirty="0">
+                <a:solidFill>
+                  <a:schemeClr val="accent1"/>
+                </a:solidFill>
+              </a:rPr>
+              <a:t>CR03</a:t>
+            </a:r>
+            <a:endParaRPr lang="en-SG" sz="1100" b="1" dirty="0">
+              <a:solidFill>
+                <a:schemeClr val="accent1"/>
+              </a:solidFill>
+            </a:endParaRPr>
+          </a:p>
+        </p:txBody>
+      </p:sp>
+      <p:sp>
+        <p:nvSpPr>
+          <p:cNvPr id="87" name="TextBox 86">
+            <a:extLst>
+              <a:ext uri="{FF2B5EF4-FFF2-40B4-BE49-F238E27FC236}">
+                <a16:creationId xmlns:a16="http://schemas.microsoft.com/office/drawing/2014/main" id="{8CEB9F9D-A775-8EA2-9DD7-CE2AD02A95AF}"/>
+              </a:ext>
+            </a:extLst>
+          </p:cNvPr>
+          <p:cNvSpPr txBox="1"/>
+          <p:nvPr/>
+        </p:nvSpPr>
+        <p:spPr>
+          <a:xfrm>
+            <a:off x="7336613" y="3599332"/>
+            <a:ext cx="634949" cy="261610"/>
+          </a:xfrm>
+          <a:prstGeom prst="rect">
+            <a:avLst/>
+          </a:prstGeom>
+          <a:noFill/>
+        </p:spPr>
+        <p:txBody>
+          <a:bodyPr wrap="square" rtlCol="0">
+            <a:spAutoFit/>
+          </a:bodyPr>
+          <a:lstStyle/>
+          <a:p>
+            <a:r>
+              <a:rPr lang="en-US" sz="1100" b="1" dirty="0">
+                <a:solidFill>
+                  <a:schemeClr val="accent1"/>
+                </a:solidFill>
+              </a:rPr>
+              <a:t>CR04</a:t>
+            </a:r>
+            <a:endParaRPr lang="en-SG" sz="1100" b="1" dirty="0">
+              <a:solidFill>
+                <a:schemeClr val="accent1"/>
+              </a:solidFill>
+            </a:endParaRPr>
+          </a:p>
+        </p:txBody>
+      </p:sp>
+      <p:sp>
+        <p:nvSpPr>
+          <p:cNvPr id="88" name="TextBox 87">
+            <a:extLst>
+              <a:ext uri="{FF2B5EF4-FFF2-40B4-BE49-F238E27FC236}">
+                <a16:creationId xmlns:a16="http://schemas.microsoft.com/office/drawing/2014/main" id="{21130E5D-7E81-947D-EB8C-8B5680EF735B}"/>
+              </a:ext>
+            </a:extLst>
+          </p:cNvPr>
+          <p:cNvSpPr txBox="1"/>
+          <p:nvPr/>
+        </p:nvSpPr>
+        <p:spPr>
+          <a:xfrm>
+            <a:off x="9055527" y="3567639"/>
+            <a:ext cx="634949" cy="261610"/>
+          </a:xfrm>
+          <a:prstGeom prst="rect">
+            <a:avLst/>
+          </a:prstGeom>
+          <a:noFill/>
+        </p:spPr>
+        <p:txBody>
+          <a:bodyPr wrap="square" rtlCol="0">
+            <a:spAutoFit/>
+          </a:bodyPr>
+          <a:lstStyle/>
+          <a:p>
+            <a:r>
+              <a:rPr lang="en-US" sz="1100" b="1" dirty="0">
+                <a:solidFill>
+                  <a:schemeClr val="accent1"/>
+                </a:solidFill>
+              </a:rPr>
+              <a:t>CR05</a:t>
+            </a:r>
+            <a:endParaRPr lang="en-SG" sz="1100" b="1" dirty="0">
+              <a:solidFill>
+                <a:schemeClr val="accent1"/>
+              </a:solidFill>
+            </a:endParaRPr>
+          </a:p>
+        </p:txBody>
+      </p:sp>
+      <p:cxnSp>
+        <p:nvCxnSpPr>
+          <p:cNvPr id="90" name="Straight Connector 89">
+            <a:extLst>
+              <a:ext uri="{FF2B5EF4-FFF2-40B4-BE49-F238E27FC236}">
+                <a16:creationId xmlns:a16="http://schemas.microsoft.com/office/drawing/2014/main" id="{F4A88B5B-9465-B459-1AA4-A78FB38AC20A}"/>
+              </a:ext>
+            </a:extLst>
+          </p:cNvPr>
+          <p:cNvCxnSpPr>
+            <a:cxnSpLocks/>
+            <a:stCxn id="61" idx="3"/>
+          </p:cNvCxnSpPr>
+          <p:nvPr/>
+        </p:nvCxnSpPr>
+        <p:spPr>
+          <a:xfrm>
+            <a:off x="5288167" y="2387273"/>
+            <a:ext cx="1476763" cy="0"/>
+          </a:xfrm>
+          <a:prstGeom prst="line">
+            <a:avLst/>
+          </a:prstGeom>
+          <a:ln>
+            <a:prstDash val="sysDash"/>
+          </a:ln>
+        </p:spPr>
+        <p:style>
+          <a:lnRef idx="2">
+            <a:schemeClr val="accent1"/>
+          </a:lnRef>
+          <a:fillRef idx="0">
+            <a:schemeClr val="accent1"/>
+          </a:fillRef>
+          <a:effectRef idx="1">
+            <a:schemeClr val="accent1"/>
+          </a:effectRef>
+          <a:fontRef idx="minor">
+            <a:schemeClr val="tx1"/>
+          </a:fontRef>
+        </p:style>
+      </p:cxnSp>
+      <p:sp>
+        <p:nvSpPr>
+          <p:cNvPr id="91" name="TextBox 90">
+            <a:extLst>
+              <a:ext uri="{FF2B5EF4-FFF2-40B4-BE49-F238E27FC236}">
+                <a16:creationId xmlns:a16="http://schemas.microsoft.com/office/drawing/2014/main" id="{ABDFA732-E1B5-1B82-2332-0F9F74FE8BD9}"/>
+              </a:ext>
+            </a:extLst>
+          </p:cNvPr>
+          <p:cNvSpPr txBox="1"/>
+          <p:nvPr/>
+        </p:nvSpPr>
+        <p:spPr>
+          <a:xfrm>
+            <a:off x="1357222" y="5408193"/>
+            <a:ext cx="1484286" cy="461665"/>
+          </a:xfrm>
+          <a:prstGeom prst="rect">
+            <a:avLst/>
+          </a:prstGeom>
+          <a:noFill/>
+        </p:spPr>
+        <p:txBody>
+          <a:bodyPr wrap="square">
+            <a:spAutoFit/>
+          </a:bodyPr>
+          <a:lstStyle/>
+          <a:p>
+            <a:r>
+              <a:rPr lang="en-US" sz="1200" b="1" dirty="0"/>
+              <a:t>Radio Antenna Next to the Track </a:t>
+            </a:r>
+            <a:endParaRPr lang="en-SG" sz="1200" b="1" dirty="0"/>
+          </a:p>
+        </p:txBody>
+      </p:sp>
+      <p:pic>
+        <p:nvPicPr>
+          <p:cNvPr id="92" name="Picture 91" descr="Radio tower - Free communications icons">
+            <a:extLst>
+              <a:ext uri="{FF2B5EF4-FFF2-40B4-BE49-F238E27FC236}">
+                <a16:creationId xmlns:a16="http://schemas.microsoft.com/office/drawing/2014/main" id="{0B372284-DF50-56BB-F64C-9DB2098A1A89}"/>
+              </a:ext>
+            </a:extLst>
+          </p:cNvPr>
+          <p:cNvPicPr>
+            <a:picLocks noChangeAspect="1"/>
+          </p:cNvPicPr>
+          <p:nvPr/>
+        </p:nvPicPr>
+        <p:blipFill>
+          <a:blip r:embed="rId3"/>
+          <a:stretch>
+            <a:fillRect/>
+          </a:stretch>
+        </p:blipFill>
+        <p:spPr>
+          <a:xfrm>
+            <a:off x="887601" y="5238821"/>
+            <a:ext cx="656160" cy="656160"/>
+          </a:xfrm>
+          <a:prstGeom prst="rect">
+            <a:avLst/>
+          </a:prstGeom>
+        </p:spPr>
+      </p:pic>
+      <p:pic>
+        <p:nvPicPr>
+          <p:cNvPr id="94" name="Graphic 93" descr="Wi-Fi with solid fill">
+            <a:extLst>
+              <a:ext uri="{FF2B5EF4-FFF2-40B4-BE49-F238E27FC236}">
+                <a16:creationId xmlns:a16="http://schemas.microsoft.com/office/drawing/2014/main" id="{A52C51AE-AB42-388A-E0F0-69919AF73CB4}"/>
+              </a:ext>
+            </a:extLst>
+          </p:cNvPr>
+          <p:cNvPicPr>
+            <a:picLocks noChangeAspect="1"/>
+          </p:cNvPicPr>
+          <p:nvPr/>
+        </p:nvPicPr>
+        <p:blipFill>
+          <a:blip>
+            <a:extLst>
+              <a:ext uri="{96DAC541-7B7A-43D3-8B79-37D633B846F1}">
+                <asvg:svgBlip xmlns:asvg="http://schemas.microsoft.com/office/drawing/2016/SVG/main" r:embed="rId7"/>
+              </a:ext>
+            </a:extLst>
+          </a:blip>
+          <a:stretch>
+            <a:fillRect/>
+          </a:stretch>
+        </p:blipFill>
+        <p:spPr>
+          <a:xfrm>
+            <a:off x="4042689" y="4223369"/>
+            <a:ext cx="481011" cy="481011"/>
+          </a:xfrm>
+          <a:prstGeom prst="rect">
+            <a:avLst/>
+          </a:prstGeom>
+        </p:spPr>
+      </p:pic>
+      <p:sp>
+        <p:nvSpPr>
+          <p:cNvPr id="95" name="TextBox 94">
+            <a:extLst>
+              <a:ext uri="{FF2B5EF4-FFF2-40B4-BE49-F238E27FC236}">
+                <a16:creationId xmlns:a16="http://schemas.microsoft.com/office/drawing/2014/main" id="{95910EFF-ED7F-CCC6-0821-FA1FB6375FDA}"/>
+              </a:ext>
+            </a:extLst>
+          </p:cNvPr>
+          <p:cNvSpPr txBox="1"/>
+          <p:nvPr/>
+        </p:nvSpPr>
+        <p:spPr>
+          <a:xfrm>
+            <a:off x="3988383" y="3494500"/>
+            <a:ext cx="1042877" cy="461665"/>
+          </a:xfrm>
+          <a:prstGeom prst="rect">
+            <a:avLst/>
+          </a:prstGeom>
+          <a:noFill/>
+        </p:spPr>
+        <p:txBody>
+          <a:bodyPr wrap="square">
+            <a:spAutoFit/>
+          </a:bodyPr>
+          <a:lstStyle/>
+          <a:p>
+            <a:r>
+              <a:rPr lang="en-US" sz="1200" b="1" dirty="0"/>
+              <a:t>Train Radio Antenna </a:t>
+            </a:r>
+            <a:endParaRPr lang="en-SG" sz="1200" b="1" dirty="0"/>
+          </a:p>
+        </p:txBody>
+      </p:sp>
+      <p:cxnSp>
+        <p:nvCxnSpPr>
+          <p:cNvPr id="97" name="Straight Arrow Connector 96">
+            <a:extLst>
+              <a:ext uri="{FF2B5EF4-FFF2-40B4-BE49-F238E27FC236}">
+                <a16:creationId xmlns:a16="http://schemas.microsoft.com/office/drawing/2014/main" id="{1C5F4C25-88E5-3505-9DD4-50E67F4CC5C4}"/>
+              </a:ext>
+            </a:extLst>
+          </p:cNvPr>
+          <p:cNvCxnSpPr>
+            <a:cxnSpLocks/>
+          </p:cNvCxnSpPr>
+          <p:nvPr/>
+        </p:nvCxnSpPr>
+        <p:spPr>
+          <a:xfrm>
+            <a:off x="4409463" y="4591845"/>
+            <a:ext cx="558009" cy="728596"/>
+          </a:xfrm>
+          <a:prstGeom prst="straightConnector1">
+            <a:avLst/>
+          </a:prstGeom>
+          <a:ln>
+            <a:solidFill>
+              <a:schemeClr val="accent6">
+                <a:lumMod val="75000"/>
+              </a:schemeClr>
+            </a:solidFill>
+            <a:prstDash val="sysDash"/>
+            <a:tailEnd type="triangle"/>
+          </a:ln>
+        </p:spPr>
+        <p:style>
+          <a:lnRef idx="2">
+            <a:schemeClr val="accent1"/>
+          </a:lnRef>
+          <a:fillRef idx="0">
+            <a:schemeClr val="accent1"/>
+          </a:fillRef>
+          <a:effectRef idx="1">
+            <a:schemeClr val="accent1"/>
+          </a:effectRef>
+          <a:fontRef idx="minor">
+            <a:schemeClr val="tx1"/>
+          </a:fontRef>
+        </p:style>
+      </p:cxnSp>
+      <p:cxnSp>
+        <p:nvCxnSpPr>
+          <p:cNvPr id="101" name="Straight Connector 100">
+            <a:extLst>
+              <a:ext uri="{FF2B5EF4-FFF2-40B4-BE49-F238E27FC236}">
+                <a16:creationId xmlns:a16="http://schemas.microsoft.com/office/drawing/2014/main" id="{5689B53D-C5BA-8384-CD4E-F2184CDC6096}"/>
+              </a:ext>
+            </a:extLst>
+          </p:cNvPr>
+          <p:cNvCxnSpPr>
+            <a:stCxn id="92" idx="2"/>
+          </p:cNvCxnSpPr>
+          <p:nvPr/>
+        </p:nvCxnSpPr>
+        <p:spPr>
+          <a:xfrm>
+            <a:off x="1215681" y="5894981"/>
+            <a:ext cx="0" cy="158347"/>
+          </a:xfrm>
+          <a:prstGeom prst="line">
+            <a:avLst/>
+          </a:prstGeom>
+          <a:ln>
+            <a:solidFill>
+              <a:schemeClr val="tx1"/>
+            </a:solidFill>
+          </a:ln>
+        </p:spPr>
+        <p:style>
+          <a:lnRef idx="2">
+            <a:schemeClr val="accent1"/>
+          </a:lnRef>
+          <a:fillRef idx="0">
+            <a:schemeClr val="accent1"/>
+          </a:fillRef>
+          <a:effectRef idx="1">
+            <a:schemeClr val="accent1"/>
+          </a:effectRef>
+          <a:fontRef idx="minor">
+            <a:schemeClr val="tx1"/>
+          </a:fontRef>
+        </p:style>
+      </p:cxnSp>
+      <p:sp>
+        <p:nvSpPr>
+          <p:cNvPr id="102" name="TextBox 101">
+            <a:extLst>
+              <a:ext uri="{FF2B5EF4-FFF2-40B4-BE49-F238E27FC236}">
+                <a16:creationId xmlns:a16="http://schemas.microsoft.com/office/drawing/2014/main" id="{691C67F9-6639-D036-3048-E239015406A5}"/>
+              </a:ext>
+            </a:extLst>
+          </p:cNvPr>
+          <p:cNvSpPr txBox="1"/>
+          <p:nvPr/>
+        </p:nvSpPr>
+        <p:spPr>
+          <a:xfrm>
+            <a:off x="4595623" y="4420804"/>
+            <a:ext cx="1803319" cy="461665"/>
+          </a:xfrm>
+          <a:prstGeom prst="rect">
+            <a:avLst/>
+          </a:prstGeom>
+          <a:noFill/>
+        </p:spPr>
+        <p:txBody>
+          <a:bodyPr wrap="square">
+            <a:spAutoFit/>
+          </a:bodyPr>
+          <a:lstStyle/>
+          <a:p>
+            <a:r>
+              <a:rPr lang="en-US" sz="1200" b="1" dirty="0">
+                <a:solidFill>
+                  <a:schemeClr val="accent6">
+                    <a:lumMod val="75000"/>
+                  </a:schemeClr>
+                </a:solidFill>
+              </a:rPr>
+              <a:t>Train Broadcast  Operation Information </a:t>
+            </a:r>
+            <a:endParaRPr lang="en-SG" sz="1200" b="1" dirty="0">
+              <a:solidFill>
+                <a:schemeClr val="accent6">
+                  <a:lumMod val="75000"/>
+                </a:schemeClr>
+              </a:solidFill>
+            </a:endParaRPr>
+          </a:p>
+        </p:txBody>
+      </p:sp>
+      <p:cxnSp>
+        <p:nvCxnSpPr>
+          <p:cNvPr id="103" name="Straight Arrow Connector 102">
+            <a:extLst>
+              <a:ext uri="{FF2B5EF4-FFF2-40B4-BE49-F238E27FC236}">
+                <a16:creationId xmlns:a16="http://schemas.microsoft.com/office/drawing/2014/main" id="{39D93B72-2ECD-2420-38E2-74F22A65A4E4}"/>
+              </a:ext>
+            </a:extLst>
+          </p:cNvPr>
+          <p:cNvCxnSpPr>
+            <a:cxnSpLocks/>
+          </p:cNvCxnSpPr>
+          <p:nvPr/>
+        </p:nvCxnSpPr>
+        <p:spPr>
+          <a:xfrm>
+            <a:off x="4387818" y="3938006"/>
+            <a:ext cx="2495" cy="349402"/>
+          </a:xfrm>
+          <a:prstGeom prst="straightConnector1">
+            <a:avLst/>
+          </a:prstGeom>
+          <a:ln w="19050">
+            <a:prstDash val="solid"/>
+            <a:tailEnd type="triangle"/>
+          </a:ln>
+        </p:spPr>
+        <p:style>
+          <a:lnRef idx="1">
+            <a:schemeClr val="dk1"/>
+          </a:lnRef>
+          <a:fillRef idx="0">
+            <a:schemeClr val="dk1"/>
+          </a:fillRef>
+          <a:effectRef idx="0">
+            <a:schemeClr val="dk1"/>
+          </a:effectRef>
+          <a:fontRef idx="minor">
+            <a:schemeClr val="tx1"/>
+          </a:fontRef>
+        </p:style>
+      </p:cxnSp>
+      <p:cxnSp>
+        <p:nvCxnSpPr>
+          <p:cNvPr id="105" name="Straight Arrow Connector 104">
+            <a:extLst>
+              <a:ext uri="{FF2B5EF4-FFF2-40B4-BE49-F238E27FC236}">
+                <a16:creationId xmlns:a16="http://schemas.microsoft.com/office/drawing/2014/main" id="{0772F9F2-766E-0297-5011-CC3AA22180EC}"/>
+              </a:ext>
+            </a:extLst>
+          </p:cNvPr>
+          <p:cNvCxnSpPr>
+            <a:cxnSpLocks/>
+          </p:cNvCxnSpPr>
+          <p:nvPr/>
+        </p:nvCxnSpPr>
+        <p:spPr>
+          <a:xfrm flipH="1">
+            <a:off x="1421343" y="4463874"/>
+            <a:ext cx="2733637" cy="868716"/>
+          </a:xfrm>
+          <a:prstGeom prst="straightConnector1">
+            <a:avLst/>
+          </a:prstGeom>
+          <a:ln>
+            <a:solidFill>
+              <a:schemeClr val="accent6">
+                <a:lumMod val="75000"/>
+              </a:schemeClr>
+            </a:solidFill>
+            <a:prstDash val="sysDash"/>
+            <a:tailEnd type="triangle"/>
+          </a:ln>
+        </p:spPr>
+        <p:style>
+          <a:lnRef idx="2">
+            <a:schemeClr val="accent1"/>
+          </a:lnRef>
+          <a:fillRef idx="0">
+            <a:schemeClr val="accent1"/>
+          </a:fillRef>
+          <a:effectRef idx="1">
+            <a:schemeClr val="accent1"/>
+          </a:effectRef>
+          <a:fontRef idx="minor">
+            <a:schemeClr val="tx1"/>
+          </a:fontRef>
+        </p:style>
+      </p:cxnSp>
+      <p:sp>
+        <p:nvSpPr>
+          <p:cNvPr id="108" name="TextBox 107">
+            <a:extLst>
+              <a:ext uri="{FF2B5EF4-FFF2-40B4-BE49-F238E27FC236}">
+                <a16:creationId xmlns:a16="http://schemas.microsoft.com/office/drawing/2014/main" id="{C2B8FDCD-993E-ACD7-4635-90BF67914C0F}"/>
+              </a:ext>
+            </a:extLst>
+          </p:cNvPr>
+          <p:cNvSpPr txBox="1"/>
+          <p:nvPr/>
+        </p:nvSpPr>
+        <p:spPr>
+          <a:xfrm>
+            <a:off x="675970" y="5647890"/>
+            <a:ext cx="469168" cy="261610"/>
+          </a:xfrm>
+          <a:prstGeom prst="rect">
+            <a:avLst/>
+          </a:prstGeom>
+          <a:noFill/>
+        </p:spPr>
+        <p:txBody>
+          <a:bodyPr wrap="square" rtlCol="0">
+            <a:spAutoFit/>
+          </a:bodyPr>
+          <a:lstStyle/>
+          <a:p>
+            <a:r>
+              <a:rPr lang="en-US" sz="1100" b="1" dirty="0">
+                <a:solidFill>
+                  <a:schemeClr val="accent6">
+                    <a:lumMod val="75000"/>
+                  </a:schemeClr>
+                </a:solidFill>
+              </a:rPr>
+              <a:t>T01</a:t>
+            </a:r>
+            <a:endParaRPr lang="en-SG" sz="1100" b="1" dirty="0">
+              <a:solidFill>
+                <a:schemeClr val="accent6">
+                  <a:lumMod val="75000"/>
+                </a:schemeClr>
+              </a:solidFill>
+            </a:endParaRPr>
+          </a:p>
+        </p:txBody>
+      </p:sp>
+      <p:sp>
+        <p:nvSpPr>
+          <p:cNvPr id="109" name="TextBox 108">
+            <a:extLst>
+              <a:ext uri="{FF2B5EF4-FFF2-40B4-BE49-F238E27FC236}">
+                <a16:creationId xmlns:a16="http://schemas.microsoft.com/office/drawing/2014/main" id="{F427ECE8-8904-9967-4774-7260A4A40A93}"/>
+              </a:ext>
+            </a:extLst>
+          </p:cNvPr>
+          <p:cNvSpPr txBox="1"/>
+          <p:nvPr/>
+        </p:nvSpPr>
+        <p:spPr>
+          <a:xfrm>
+            <a:off x="4595623" y="5635090"/>
+            <a:ext cx="469168" cy="261610"/>
+          </a:xfrm>
+          <a:prstGeom prst="rect">
+            <a:avLst/>
+          </a:prstGeom>
+          <a:noFill/>
+        </p:spPr>
+        <p:txBody>
+          <a:bodyPr wrap="square" rtlCol="0">
+            <a:spAutoFit/>
+          </a:bodyPr>
+          <a:lstStyle/>
+          <a:p>
+            <a:r>
+              <a:rPr lang="en-US" sz="1100" b="1" dirty="0">
+                <a:solidFill>
+                  <a:schemeClr val="accent6">
+                    <a:lumMod val="75000"/>
+                  </a:schemeClr>
+                </a:solidFill>
+              </a:rPr>
+              <a:t>T02</a:t>
+            </a:r>
+            <a:endParaRPr lang="en-SG" sz="1100" b="1" dirty="0">
+              <a:solidFill>
+                <a:schemeClr val="accent6">
+                  <a:lumMod val="75000"/>
+                </a:schemeClr>
+              </a:solidFill>
+            </a:endParaRPr>
+          </a:p>
+        </p:txBody>
+      </p:sp>
+      <p:sp>
+        <p:nvSpPr>
+          <p:cNvPr id="110" name="TextBox 109">
+            <a:extLst>
+              <a:ext uri="{FF2B5EF4-FFF2-40B4-BE49-F238E27FC236}">
+                <a16:creationId xmlns:a16="http://schemas.microsoft.com/office/drawing/2014/main" id="{5DAB2D25-9105-730D-10D2-E61A62C56248}"/>
+              </a:ext>
+            </a:extLst>
+          </p:cNvPr>
+          <p:cNvSpPr txBox="1"/>
+          <p:nvPr/>
+        </p:nvSpPr>
+        <p:spPr>
+          <a:xfrm>
+            <a:off x="8330678" y="5663354"/>
+            <a:ext cx="469168" cy="261610"/>
+          </a:xfrm>
+          <a:prstGeom prst="rect">
+            <a:avLst/>
+          </a:prstGeom>
+          <a:noFill/>
+        </p:spPr>
+        <p:txBody>
+          <a:bodyPr wrap="square" rtlCol="0">
+            <a:spAutoFit/>
+          </a:bodyPr>
+          <a:lstStyle/>
+          <a:p>
+            <a:r>
+              <a:rPr lang="en-US" sz="1100" b="1" dirty="0">
+                <a:solidFill>
+                  <a:schemeClr val="accent6">
+                    <a:lumMod val="75000"/>
+                  </a:schemeClr>
+                </a:solidFill>
+              </a:rPr>
+              <a:t>T03</a:t>
+            </a:r>
+            <a:endParaRPr lang="en-SG" sz="1100" b="1" dirty="0">
+              <a:solidFill>
+                <a:schemeClr val="accent6">
+                  <a:lumMod val="75000"/>
+                </a:schemeClr>
+              </a:solidFill>
+            </a:endParaRPr>
+          </a:p>
+        </p:txBody>
+      </p:sp>
+      <p:cxnSp>
+        <p:nvCxnSpPr>
+          <p:cNvPr id="111" name="Straight Connector 110">
+            <a:extLst>
+              <a:ext uri="{FF2B5EF4-FFF2-40B4-BE49-F238E27FC236}">
+                <a16:creationId xmlns:a16="http://schemas.microsoft.com/office/drawing/2014/main" id="{23F9DF69-742C-8FA8-A2B0-F691330380A6}"/>
+              </a:ext>
+            </a:extLst>
+          </p:cNvPr>
+          <p:cNvCxnSpPr>
+            <a:cxnSpLocks/>
+          </p:cNvCxnSpPr>
+          <p:nvPr/>
+        </p:nvCxnSpPr>
+        <p:spPr>
+          <a:xfrm>
+            <a:off x="1206537" y="6056885"/>
+            <a:ext cx="8166464" cy="50241"/>
+          </a:xfrm>
+          <a:prstGeom prst="line">
+            <a:avLst/>
+          </a:prstGeom>
+          <a:ln>
+            <a:solidFill>
+              <a:schemeClr val="tx1"/>
+            </a:solidFill>
+          </a:ln>
+        </p:spPr>
+        <p:style>
+          <a:lnRef idx="2">
+            <a:schemeClr val="accent1"/>
+          </a:lnRef>
+          <a:fillRef idx="0">
+            <a:schemeClr val="accent1"/>
+          </a:fillRef>
+          <a:effectRef idx="1">
+            <a:schemeClr val="accent1"/>
+          </a:effectRef>
+          <a:fontRef idx="minor">
+            <a:schemeClr val="tx1"/>
+          </a:fontRef>
+        </p:style>
+      </p:cxnSp>
+      <p:cxnSp>
+        <p:nvCxnSpPr>
+          <p:cNvPr id="115" name="Straight Connector 114">
+            <a:extLst>
+              <a:ext uri="{FF2B5EF4-FFF2-40B4-BE49-F238E27FC236}">
+                <a16:creationId xmlns:a16="http://schemas.microsoft.com/office/drawing/2014/main" id="{AC1CFFAC-0BE6-E4D6-47C9-94BBC23FDD1E}"/>
+              </a:ext>
+            </a:extLst>
+          </p:cNvPr>
+          <p:cNvCxnSpPr>
+            <a:cxnSpLocks/>
+          </p:cNvCxnSpPr>
+          <p:nvPr/>
+        </p:nvCxnSpPr>
+        <p:spPr>
+          <a:xfrm>
+            <a:off x="5171803" y="5909500"/>
+            <a:ext cx="0" cy="178962"/>
+          </a:xfrm>
+          <a:prstGeom prst="line">
+            <a:avLst/>
+          </a:prstGeom>
+          <a:ln>
+            <a:solidFill>
+              <a:schemeClr val="tx1"/>
+            </a:solidFill>
+          </a:ln>
+        </p:spPr>
+        <p:style>
+          <a:lnRef idx="2">
+            <a:schemeClr val="accent1"/>
+          </a:lnRef>
+          <a:fillRef idx="0">
+            <a:schemeClr val="accent1"/>
+          </a:fillRef>
+          <a:effectRef idx="1">
+            <a:schemeClr val="accent1"/>
+          </a:effectRef>
+          <a:fontRef idx="minor">
+            <a:schemeClr val="tx1"/>
+          </a:fontRef>
+        </p:style>
+      </p:cxnSp>
+      <p:cxnSp>
+        <p:nvCxnSpPr>
+          <p:cNvPr id="118" name="Straight Connector 117">
+            <a:extLst>
+              <a:ext uri="{FF2B5EF4-FFF2-40B4-BE49-F238E27FC236}">
+                <a16:creationId xmlns:a16="http://schemas.microsoft.com/office/drawing/2014/main" id="{19449C96-6147-DDE7-21D8-CF2155EF5E6D}"/>
+              </a:ext>
+            </a:extLst>
+          </p:cNvPr>
+          <p:cNvCxnSpPr>
+            <a:cxnSpLocks/>
+          </p:cNvCxnSpPr>
+          <p:nvPr/>
+        </p:nvCxnSpPr>
+        <p:spPr>
+          <a:xfrm>
+            <a:off x="8881938" y="5924964"/>
+            <a:ext cx="0" cy="178962"/>
+          </a:xfrm>
+          <a:prstGeom prst="line">
+            <a:avLst/>
+          </a:prstGeom>
+          <a:ln>
+            <a:solidFill>
+              <a:schemeClr val="tx1"/>
+            </a:solidFill>
+          </a:ln>
+        </p:spPr>
+        <p:style>
+          <a:lnRef idx="2">
+            <a:schemeClr val="accent1"/>
+          </a:lnRef>
+          <a:fillRef idx="0">
+            <a:schemeClr val="accent1"/>
+          </a:fillRef>
+          <a:effectRef idx="1">
+            <a:schemeClr val="accent1"/>
+          </a:effectRef>
+          <a:fontRef idx="minor">
+            <a:schemeClr val="tx1"/>
+          </a:fontRef>
+        </p:style>
+      </p:cxnSp>
+      <p:sp>
+        <p:nvSpPr>
+          <p:cNvPr id="122" name="TextBox 121">
+            <a:extLst>
+              <a:ext uri="{FF2B5EF4-FFF2-40B4-BE49-F238E27FC236}">
+                <a16:creationId xmlns:a16="http://schemas.microsoft.com/office/drawing/2014/main" id="{6F8FCD0D-711B-E88D-4C0C-7EBB52E432C7}"/>
+              </a:ext>
+            </a:extLst>
+          </p:cNvPr>
+          <p:cNvSpPr txBox="1"/>
+          <p:nvPr/>
+        </p:nvSpPr>
+        <p:spPr>
+          <a:xfrm>
+            <a:off x="5452868" y="5747617"/>
+            <a:ext cx="2958272" cy="276999"/>
+          </a:xfrm>
+          <a:prstGeom prst="rect">
+            <a:avLst/>
+          </a:prstGeom>
+          <a:noFill/>
+        </p:spPr>
+        <p:txBody>
+          <a:bodyPr wrap="square" rtlCol="0">
+            <a:spAutoFit/>
+          </a:bodyPr>
+          <a:lstStyle/>
+          <a:p>
+            <a:r>
+              <a:rPr lang="en-US" sz="1200" b="1" dirty="0"/>
+              <a:t>Train Operation Information Data Bus </a:t>
+            </a:r>
+            <a:endParaRPr lang="en-SG" sz="1200" b="1" dirty="0"/>
+          </a:p>
+        </p:txBody>
+      </p:sp>
+      <p:pic>
+        <p:nvPicPr>
+          <p:cNvPr id="123" name="Picture 122">
+            <a:extLst>
+              <a:ext uri="{FF2B5EF4-FFF2-40B4-BE49-F238E27FC236}">
+                <a16:creationId xmlns:a16="http://schemas.microsoft.com/office/drawing/2014/main" id="{81536D14-EE1F-8C8F-7DA5-4F86A10551CD}"/>
+              </a:ext>
+            </a:extLst>
+          </p:cNvPr>
+          <p:cNvPicPr>
+            <a:picLocks noChangeAspect="1"/>
+          </p:cNvPicPr>
+          <p:nvPr/>
+        </p:nvPicPr>
+        <p:blipFill>
+          <a:blip r:embed="rId8"/>
+          <a:stretch>
+            <a:fillRect/>
+          </a:stretch>
+        </p:blipFill>
+        <p:spPr>
+          <a:xfrm>
+            <a:off x="9373000" y="5694044"/>
+            <a:ext cx="720873" cy="512621"/>
+          </a:xfrm>
+          <a:prstGeom prst="rect">
+            <a:avLst/>
+          </a:prstGeom>
+        </p:spPr>
+      </p:pic>
+      <p:sp>
+        <p:nvSpPr>
+          <p:cNvPr id="124" name="TextBox 123">
+            <a:extLst>
+              <a:ext uri="{FF2B5EF4-FFF2-40B4-BE49-F238E27FC236}">
+                <a16:creationId xmlns:a16="http://schemas.microsoft.com/office/drawing/2014/main" id="{452302C9-8EC4-9598-961F-3CB1485C980F}"/>
+              </a:ext>
+            </a:extLst>
+          </p:cNvPr>
+          <p:cNvSpPr txBox="1"/>
+          <p:nvPr/>
+        </p:nvSpPr>
+        <p:spPr>
+          <a:xfrm>
+            <a:off x="10141770" y="5713625"/>
+            <a:ext cx="1484286" cy="461665"/>
+          </a:xfrm>
+          <a:prstGeom prst="rect">
+            <a:avLst/>
+          </a:prstGeom>
+          <a:noFill/>
+        </p:spPr>
+        <p:txBody>
+          <a:bodyPr wrap="square">
+            <a:spAutoFit/>
+          </a:bodyPr>
+          <a:lstStyle/>
+          <a:p>
+            <a:r>
+              <a:rPr lang="en-US" sz="1200" b="1" dirty="0"/>
+              <a:t>Radio Link Data Management RTU</a:t>
+            </a:r>
+            <a:endParaRPr lang="en-SG" sz="1200" b="1" dirty="0"/>
+          </a:p>
+        </p:txBody>
+      </p:sp>
+      <p:cxnSp>
+        <p:nvCxnSpPr>
+          <p:cNvPr id="125" name="Straight Connector 124">
+            <a:extLst>
+              <a:ext uri="{FF2B5EF4-FFF2-40B4-BE49-F238E27FC236}">
+                <a16:creationId xmlns:a16="http://schemas.microsoft.com/office/drawing/2014/main" id="{45562723-03B4-3277-BBE2-6F8DC7626F79}"/>
+              </a:ext>
+            </a:extLst>
+          </p:cNvPr>
+          <p:cNvCxnSpPr>
+            <a:cxnSpLocks/>
+            <a:endCxn id="123" idx="0"/>
+          </p:cNvCxnSpPr>
+          <p:nvPr/>
+        </p:nvCxnSpPr>
+        <p:spPr>
+          <a:xfrm>
+            <a:off x="9733437" y="2678598"/>
+            <a:ext cx="0" cy="3015446"/>
+          </a:xfrm>
+          <a:prstGeom prst="line">
+            <a:avLst/>
+          </a:prstGeom>
+          <a:ln>
+            <a:solidFill>
+              <a:schemeClr val="tx1"/>
+            </a:solidFill>
+            <a:prstDash val="sysDash"/>
+          </a:ln>
+        </p:spPr>
+        <p:style>
+          <a:lnRef idx="2">
+            <a:schemeClr val="accent1"/>
+          </a:lnRef>
+          <a:fillRef idx="0">
+            <a:schemeClr val="accent1"/>
+          </a:fillRef>
+          <a:effectRef idx="1">
+            <a:schemeClr val="accent1"/>
+          </a:effectRef>
+          <a:fontRef idx="minor">
+            <a:schemeClr val="tx1"/>
+          </a:fontRef>
+        </p:style>
+      </p:cxnSp>
+      <p:pic>
+        <p:nvPicPr>
+          <p:cNvPr id="129" name="Picture 128">
+            <a:extLst>
+              <a:ext uri="{FF2B5EF4-FFF2-40B4-BE49-F238E27FC236}">
+                <a16:creationId xmlns:a16="http://schemas.microsoft.com/office/drawing/2014/main" id="{5C34A02D-35ED-0B00-5046-4CCFF23C3347}"/>
+              </a:ext>
+            </a:extLst>
+          </p:cNvPr>
+          <p:cNvPicPr>
+            <a:picLocks noChangeAspect="1"/>
+          </p:cNvPicPr>
+          <p:nvPr/>
+        </p:nvPicPr>
+        <p:blipFill>
+          <a:blip r:embed="rId9"/>
+          <a:stretch>
+            <a:fillRect/>
+          </a:stretch>
+        </p:blipFill>
+        <p:spPr>
+          <a:xfrm>
+            <a:off x="8724985" y="990693"/>
+            <a:ext cx="2983277" cy="1603511"/>
+          </a:xfrm>
+          <a:prstGeom prst="rect">
+            <a:avLst/>
+          </a:prstGeom>
+          <a:ln w="9525">
+            <a:solidFill>
+              <a:schemeClr val="tx1"/>
+            </a:solidFill>
+          </a:ln>
+        </p:spPr>
+      </p:pic>
+      <p:sp>
+        <p:nvSpPr>
+          <p:cNvPr id="134" name="TextBox 133">
+            <a:extLst>
+              <a:ext uri="{FF2B5EF4-FFF2-40B4-BE49-F238E27FC236}">
+                <a16:creationId xmlns:a16="http://schemas.microsoft.com/office/drawing/2014/main" id="{047910D8-B3FA-2DB5-DE81-4C29EEB9C32B}"/>
+              </a:ext>
+            </a:extLst>
+          </p:cNvPr>
+          <p:cNvSpPr txBox="1"/>
+          <p:nvPr/>
+        </p:nvSpPr>
+        <p:spPr>
+          <a:xfrm>
+            <a:off x="5321391" y="2029346"/>
+            <a:ext cx="1484286" cy="276999"/>
+          </a:xfrm>
+          <a:prstGeom prst="rect">
+            <a:avLst/>
+          </a:prstGeom>
+          <a:noFill/>
+        </p:spPr>
+        <p:txBody>
+          <a:bodyPr wrap="square">
+            <a:spAutoFit/>
+          </a:bodyPr>
+          <a:lstStyle/>
+          <a:p>
+            <a:r>
+              <a:rPr lang="en-US" sz="1200" b="1" dirty="0"/>
+              <a:t>Modbus-TCP Bus </a:t>
+            </a:r>
+            <a:endParaRPr lang="en-SG" sz="1200" b="1" dirty="0"/>
+          </a:p>
+        </p:txBody>
+      </p:sp>
+      <p:sp>
+        <p:nvSpPr>
+          <p:cNvPr id="135" name="TextBox 134">
+            <a:extLst>
+              <a:ext uri="{FF2B5EF4-FFF2-40B4-BE49-F238E27FC236}">
+                <a16:creationId xmlns:a16="http://schemas.microsoft.com/office/drawing/2014/main" id="{F018FE10-AA12-9EA8-39B4-C695AF1C7303}"/>
+              </a:ext>
+            </a:extLst>
+          </p:cNvPr>
+          <p:cNvSpPr txBox="1"/>
+          <p:nvPr/>
+        </p:nvSpPr>
+        <p:spPr>
+          <a:xfrm>
+            <a:off x="9909048" y="2993850"/>
+            <a:ext cx="1304813" cy="461665"/>
+          </a:xfrm>
+          <a:prstGeom prst="rect">
+            <a:avLst/>
+          </a:prstGeom>
+          <a:noFill/>
+        </p:spPr>
+        <p:txBody>
+          <a:bodyPr wrap="square">
+            <a:spAutoFit/>
+          </a:bodyPr>
+          <a:lstStyle/>
+          <a:p>
+            <a:r>
+              <a:rPr lang="en-US" sz="1200" b="1" dirty="0">
+                <a:solidFill>
+                  <a:schemeClr val="accent6">
+                    <a:lumMod val="75000"/>
+                  </a:schemeClr>
+                </a:solidFill>
+              </a:rPr>
+              <a:t>Siemens</a:t>
+            </a:r>
+          </a:p>
+          <a:p>
+            <a:r>
+              <a:rPr lang="en-US" sz="1200" b="1" dirty="0">
+                <a:solidFill>
+                  <a:schemeClr val="accent6">
+                    <a:lumMod val="75000"/>
+                  </a:schemeClr>
+                </a:solidFill>
+              </a:rPr>
+              <a:t>S7Comm Bus </a:t>
+            </a:r>
+            <a:endParaRPr lang="en-SG" sz="1200" b="1" dirty="0">
+              <a:solidFill>
+                <a:schemeClr val="accent6">
+                  <a:lumMod val="75000"/>
+                </a:schemeClr>
+              </a:solidFill>
+            </a:endParaRPr>
+          </a:p>
+        </p:txBody>
+      </p:sp>
+      <p:pic>
+        <p:nvPicPr>
+          <p:cNvPr id="137" name="Picture 136">
+            <a:extLst>
+              <a:ext uri="{FF2B5EF4-FFF2-40B4-BE49-F238E27FC236}">
+                <a16:creationId xmlns:a16="http://schemas.microsoft.com/office/drawing/2014/main" id="{2DC11778-A5D4-624E-1865-C59CD7B983E0}"/>
+              </a:ext>
+            </a:extLst>
+          </p:cNvPr>
+          <p:cNvPicPr>
+            <a:picLocks noChangeAspect="1"/>
+          </p:cNvPicPr>
+          <p:nvPr/>
+        </p:nvPicPr>
+        <p:blipFill>
+          <a:blip r:embed="rId10"/>
+          <a:stretch>
+            <a:fillRect/>
+          </a:stretch>
+        </p:blipFill>
+        <p:spPr>
+          <a:xfrm>
+            <a:off x="6764930" y="1029598"/>
+            <a:ext cx="1784873" cy="1761389"/>
+          </a:xfrm>
+          <a:prstGeom prst="rect">
+            <a:avLst/>
+          </a:prstGeom>
+          <a:ln w="19050">
+            <a:solidFill>
+              <a:schemeClr val="tx1"/>
+            </a:solidFill>
+          </a:ln>
+        </p:spPr>
+      </p:pic>
+      <p:sp>
+        <p:nvSpPr>
+          <p:cNvPr id="139" name="TextBox 138">
+            <a:extLst>
+              <a:ext uri="{FF2B5EF4-FFF2-40B4-BE49-F238E27FC236}">
+                <a16:creationId xmlns:a16="http://schemas.microsoft.com/office/drawing/2014/main" id="{E73FB760-2CEE-8D0B-86CC-0A11E515DA0E}"/>
+              </a:ext>
+            </a:extLst>
+          </p:cNvPr>
+          <p:cNvSpPr txBox="1"/>
+          <p:nvPr/>
+        </p:nvSpPr>
+        <p:spPr>
+          <a:xfrm>
+            <a:off x="6705281" y="742948"/>
+            <a:ext cx="1484286" cy="276999"/>
+          </a:xfrm>
+          <a:prstGeom prst="rect">
+            <a:avLst/>
+          </a:prstGeom>
+          <a:noFill/>
+        </p:spPr>
+        <p:txBody>
+          <a:bodyPr wrap="square">
+            <a:spAutoFit/>
+          </a:bodyPr>
+          <a:lstStyle/>
+          <a:p>
+            <a:r>
+              <a:rPr lang="en-US" sz="1200" b="1" dirty="0"/>
+              <a:t>Railway OCC</a:t>
+            </a:r>
+            <a:endParaRPr lang="en-SG" sz="1200" b="1" dirty="0"/>
+          </a:p>
+        </p:txBody>
+      </p:sp>
+      <p:cxnSp>
+        <p:nvCxnSpPr>
+          <p:cNvPr id="143" name="Straight Connector 142">
+            <a:extLst>
+              <a:ext uri="{FF2B5EF4-FFF2-40B4-BE49-F238E27FC236}">
+                <a16:creationId xmlns:a16="http://schemas.microsoft.com/office/drawing/2014/main" id="{BF5A3B86-893F-2E2A-7424-25B38B022C3B}"/>
+              </a:ext>
+            </a:extLst>
+          </p:cNvPr>
+          <p:cNvCxnSpPr>
+            <a:cxnSpLocks/>
+          </p:cNvCxnSpPr>
+          <p:nvPr/>
+        </p:nvCxnSpPr>
+        <p:spPr>
+          <a:xfrm>
+            <a:off x="8565262" y="2678598"/>
+            <a:ext cx="1178057" cy="0"/>
+          </a:xfrm>
+          <a:prstGeom prst="line">
+            <a:avLst/>
+          </a:prstGeom>
+          <a:ln>
+            <a:solidFill>
+              <a:schemeClr val="tx1"/>
+            </a:solidFill>
+            <a:prstDash val="sysDash"/>
+          </a:ln>
+        </p:spPr>
+        <p:style>
+          <a:lnRef idx="2">
+            <a:schemeClr val="accent1"/>
+          </a:lnRef>
+          <a:fillRef idx="0">
+            <a:schemeClr val="accent1"/>
+          </a:fillRef>
+          <a:effectRef idx="1">
+            <a:schemeClr val="accent1"/>
+          </a:effectRef>
+          <a:fontRef idx="minor">
+            <a:schemeClr val="tx1"/>
+          </a:fontRef>
+        </p:style>
+      </p:cxnSp>
+      <p:sp>
+        <p:nvSpPr>
+          <p:cNvPr id="151" name="Rectangle: Rounded Corners 150">
+            <a:extLst>
+              <a:ext uri="{FF2B5EF4-FFF2-40B4-BE49-F238E27FC236}">
+                <a16:creationId xmlns:a16="http://schemas.microsoft.com/office/drawing/2014/main" id="{22695CFB-722C-5B5C-F3C6-E0DBCC809EF2}"/>
+              </a:ext>
+            </a:extLst>
+          </p:cNvPr>
+          <p:cNvSpPr/>
+          <p:nvPr/>
+        </p:nvSpPr>
+        <p:spPr>
+          <a:xfrm>
+            <a:off x="7006060" y="1699922"/>
+            <a:ext cx="493462" cy="648065"/>
+          </a:xfrm>
+          <a:prstGeom prst="roundRect">
+            <a:avLst/>
+          </a:prstGeom>
+          <a:noFill/>
+          <a:ln>
+            <a:solidFill>
+              <a:srgbClr val="FF0000"/>
+            </a:solidFill>
+          </a:ln>
+        </p:spPr>
+        <p:style>
+          <a:lnRef idx="2">
+            <a:schemeClr val="accent1">
+              <a:shade val="15000"/>
+            </a:schemeClr>
+          </a:lnRef>
+          <a:fillRef idx="1">
+            <a:schemeClr val="accent1"/>
+          </a:fillRef>
+          <a:effectRef idx="0">
+            <a:schemeClr val="accent1"/>
+          </a:effectRef>
+          <a:fontRef idx="minor">
+            <a:schemeClr val="lt1"/>
+          </a:fontRef>
+        </p:style>
+        <p:txBody>
+          <a:bodyPr rtlCol="0" anchor="ctr"/>
+          <a:lstStyle/>
+          <a:p>
+            <a:pPr algn="ctr"/>
+            <a:endParaRPr lang="en-SG" dirty="0">
+              <a:noFill/>
+            </a:endParaRPr>
+          </a:p>
+        </p:txBody>
+      </p:sp>
+      <p:cxnSp>
+        <p:nvCxnSpPr>
+          <p:cNvPr id="155" name="Connector: Elbow 154">
+            <a:extLst>
+              <a:ext uri="{FF2B5EF4-FFF2-40B4-BE49-F238E27FC236}">
+                <a16:creationId xmlns:a16="http://schemas.microsoft.com/office/drawing/2014/main" id="{1D0AFD3D-3081-9C8A-7C95-DAA92E3ABFA1}"/>
+              </a:ext>
+            </a:extLst>
+          </p:cNvPr>
+          <p:cNvCxnSpPr>
+            <a:cxnSpLocks/>
+            <a:stCxn id="151" idx="0"/>
+          </p:cNvCxnSpPr>
+          <p:nvPr/>
+        </p:nvCxnSpPr>
+        <p:spPr>
+          <a:xfrm rot="5400000" flipH="1" flipV="1">
+            <a:off x="7960257" y="935194"/>
+            <a:ext cx="57262" cy="1472194"/>
+          </a:xfrm>
+          <a:prstGeom prst="bentConnector2">
+            <a:avLst/>
+          </a:prstGeom>
+          <a:ln>
+            <a:solidFill>
+              <a:srgbClr val="FF0000"/>
+            </a:solidFill>
+            <a:prstDash val="sysDash"/>
+            <a:tailEnd type="triangle"/>
+          </a:ln>
+        </p:spPr>
+        <p:style>
+          <a:lnRef idx="2">
+            <a:schemeClr val="accent1"/>
+          </a:lnRef>
+          <a:fillRef idx="0">
+            <a:schemeClr val="accent1"/>
+          </a:fillRef>
+          <a:effectRef idx="1">
+            <a:schemeClr val="accent1"/>
+          </a:effectRef>
+          <a:fontRef idx="minor">
+            <a:schemeClr val="tx1"/>
+          </a:fontRef>
+        </p:style>
+      </p:cxnSp>
+      <p:sp>
+        <p:nvSpPr>
+          <p:cNvPr id="159" name="TextBox 158">
+            <a:extLst>
+              <a:ext uri="{FF2B5EF4-FFF2-40B4-BE49-F238E27FC236}">
+                <a16:creationId xmlns:a16="http://schemas.microsoft.com/office/drawing/2014/main" id="{0E57FD4C-200A-D9CA-D697-17738A2E6F5F}"/>
+              </a:ext>
+            </a:extLst>
+          </p:cNvPr>
+          <p:cNvSpPr txBox="1"/>
+          <p:nvPr/>
+        </p:nvSpPr>
+        <p:spPr>
+          <a:xfrm>
+            <a:off x="8650831" y="703019"/>
+            <a:ext cx="1912328" cy="276999"/>
+          </a:xfrm>
+          <a:prstGeom prst="rect">
+            <a:avLst/>
+          </a:prstGeom>
+          <a:noFill/>
+        </p:spPr>
+        <p:txBody>
+          <a:bodyPr wrap="square">
+            <a:spAutoFit/>
+          </a:bodyPr>
+          <a:lstStyle/>
+          <a:p>
+            <a:r>
+              <a:rPr lang="en-US" sz="1200" b="1" dirty="0"/>
+              <a:t>OCC Train Monitor HMI</a:t>
+            </a:r>
+            <a:endParaRPr lang="en-SG" sz="1200" b="1" dirty="0"/>
+          </a:p>
+        </p:txBody>
+      </p:sp>
+      <p:sp>
+        <p:nvSpPr>
+          <p:cNvPr id="160" name="TextBox 159">
+            <a:extLst>
+              <a:ext uri="{FF2B5EF4-FFF2-40B4-BE49-F238E27FC236}">
+                <a16:creationId xmlns:a16="http://schemas.microsoft.com/office/drawing/2014/main" id="{34A495F4-478A-7353-7FF4-24A85FBCEB11}"/>
+              </a:ext>
+            </a:extLst>
+          </p:cNvPr>
+          <p:cNvSpPr txBox="1"/>
+          <p:nvPr/>
+        </p:nvSpPr>
+        <p:spPr>
+          <a:xfrm>
+            <a:off x="701631" y="789952"/>
+            <a:ext cx="5697311" cy="646331"/>
+          </a:xfrm>
+          <a:prstGeom prst="rect">
+            <a:avLst/>
+          </a:prstGeom>
+          <a:noFill/>
+        </p:spPr>
+        <p:txBody>
+          <a:bodyPr wrap="square">
+            <a:spAutoFit/>
+          </a:bodyPr>
+          <a:lstStyle/>
+          <a:p>
+            <a:r>
+              <a:rPr lang="en-US" b="1" dirty="0"/>
+              <a:t>Radio Communication System and Remote Power Control in  Land-Based Railway Cyber Twin platform</a:t>
+            </a:r>
+            <a:endParaRPr lang="en-SG" b="1" dirty="0"/>
+          </a:p>
+        </p:txBody>
+      </p:sp>
+      <p:cxnSp>
+        <p:nvCxnSpPr>
+          <p:cNvPr id="161" name="Straight Arrow Connector 160">
+            <a:extLst>
+              <a:ext uri="{FF2B5EF4-FFF2-40B4-BE49-F238E27FC236}">
+                <a16:creationId xmlns:a16="http://schemas.microsoft.com/office/drawing/2014/main" id="{89596FE9-7F56-FD1C-42E9-6F38EADBFF8D}"/>
+              </a:ext>
+            </a:extLst>
+          </p:cNvPr>
+          <p:cNvCxnSpPr>
+            <a:cxnSpLocks/>
+          </p:cNvCxnSpPr>
+          <p:nvPr/>
+        </p:nvCxnSpPr>
+        <p:spPr>
+          <a:xfrm>
+            <a:off x="5284569" y="5974154"/>
+            <a:ext cx="0" cy="232511"/>
+          </a:xfrm>
+          <a:prstGeom prst="straightConnector1">
+            <a:avLst/>
+          </a:prstGeom>
+          <a:ln>
+            <a:solidFill>
+              <a:schemeClr val="accent6">
+                <a:lumMod val="75000"/>
+              </a:schemeClr>
+            </a:solidFill>
+            <a:prstDash val="sysDash"/>
+            <a:tailEnd type="triangle"/>
+          </a:ln>
+        </p:spPr>
+        <p:style>
+          <a:lnRef idx="2">
+            <a:schemeClr val="accent1"/>
+          </a:lnRef>
+          <a:fillRef idx="0">
+            <a:schemeClr val="accent1"/>
+          </a:fillRef>
+          <a:effectRef idx="1">
+            <a:schemeClr val="accent1"/>
+          </a:effectRef>
+          <a:fontRef idx="minor">
+            <a:schemeClr val="tx1"/>
+          </a:fontRef>
+        </p:style>
+      </p:cxnSp>
+      <p:cxnSp>
+        <p:nvCxnSpPr>
+          <p:cNvPr id="164" name="Straight Arrow Connector 163">
+            <a:extLst>
+              <a:ext uri="{FF2B5EF4-FFF2-40B4-BE49-F238E27FC236}">
+                <a16:creationId xmlns:a16="http://schemas.microsoft.com/office/drawing/2014/main" id="{0059E56C-F292-792E-1A06-F8B43304EF35}"/>
+              </a:ext>
+            </a:extLst>
+          </p:cNvPr>
+          <p:cNvCxnSpPr>
+            <a:cxnSpLocks/>
+          </p:cNvCxnSpPr>
+          <p:nvPr/>
+        </p:nvCxnSpPr>
+        <p:spPr>
+          <a:xfrm>
+            <a:off x="5306455" y="6193327"/>
+            <a:ext cx="4018648" cy="0"/>
+          </a:xfrm>
+          <a:prstGeom prst="straightConnector1">
+            <a:avLst/>
+          </a:prstGeom>
+          <a:ln>
+            <a:solidFill>
+              <a:schemeClr val="accent6">
+                <a:lumMod val="75000"/>
+              </a:schemeClr>
+            </a:solidFill>
+            <a:prstDash val="sysDash"/>
+            <a:tailEnd type="triangle"/>
+          </a:ln>
+        </p:spPr>
+        <p:style>
+          <a:lnRef idx="2">
+            <a:schemeClr val="accent1"/>
+          </a:lnRef>
+          <a:fillRef idx="0">
+            <a:schemeClr val="accent1"/>
+          </a:fillRef>
+          <a:effectRef idx="1">
+            <a:schemeClr val="accent1"/>
+          </a:effectRef>
+          <a:fontRef idx="minor">
+            <a:schemeClr val="tx1"/>
+          </a:fontRef>
+        </p:style>
+      </p:cxnSp>
+      <p:cxnSp>
+        <p:nvCxnSpPr>
+          <p:cNvPr id="168" name="Straight Arrow Connector 167">
+            <a:extLst>
+              <a:ext uri="{FF2B5EF4-FFF2-40B4-BE49-F238E27FC236}">
+                <a16:creationId xmlns:a16="http://schemas.microsoft.com/office/drawing/2014/main" id="{0DEBA0F9-FDB0-B5CA-DD0D-AA798E936D08}"/>
+              </a:ext>
+            </a:extLst>
+          </p:cNvPr>
+          <p:cNvCxnSpPr>
+            <a:cxnSpLocks/>
+          </p:cNvCxnSpPr>
+          <p:nvPr/>
+        </p:nvCxnSpPr>
+        <p:spPr>
+          <a:xfrm flipV="1">
+            <a:off x="9859839" y="2670902"/>
+            <a:ext cx="24969" cy="2943384"/>
+          </a:xfrm>
+          <a:prstGeom prst="straightConnector1">
+            <a:avLst/>
+          </a:prstGeom>
+          <a:ln>
+            <a:solidFill>
+              <a:schemeClr val="accent6">
+                <a:lumMod val="75000"/>
+              </a:schemeClr>
+            </a:solidFill>
+            <a:prstDash val="sysDash"/>
+            <a:tailEnd type="triangle"/>
+          </a:ln>
+        </p:spPr>
+        <p:style>
+          <a:lnRef idx="2">
+            <a:schemeClr val="accent1"/>
+          </a:lnRef>
+          <a:fillRef idx="0">
+            <a:schemeClr val="accent1"/>
+          </a:fillRef>
+          <a:effectRef idx="1">
+            <a:schemeClr val="accent1"/>
+          </a:effectRef>
+          <a:fontRef idx="minor">
+            <a:schemeClr val="tx1"/>
+          </a:fontRef>
+        </p:style>
+      </p:cxnSp>
+    </p:spTree>
+    <p:extLst>
+      <p:ext uri="{BB962C8B-B14F-4D97-AF65-F5344CB8AC3E}">
+        <p14:creationId xmlns:p14="http://schemas.microsoft.com/office/powerpoint/2010/main" val="1425193946"/>
+      </p:ext>
+    </p:extLst>
+  </p:cSld>
+  <p:clrMapOvr>
+    <a:masterClrMapping/>
+  </p:clrMapOvr>
+</p:sld>
+</file>
+
 <file path=ppt/theme/theme1.xml><?xml version="1.0" encoding="utf-8"?>
 <a:theme xmlns:a="http://schemas.openxmlformats.org/drawingml/2006/main" name="Office Theme">
   <a:themeElements>

</xml_diff>

<commit_message>
Added the emergency stop section of the case study.
</commit_message>
<xml_diff>
--- a/5_CaseStudy_Doc/Case0_img/designDoc.pptx
+++ b/5_CaseStudy_Doc/Case0_img/designDoc.pptx
@@ -5,7 +5,7 @@
     <p:sldMasterId id="2147483648" r:id="rId1"/>
   </p:sldMasterIdLst>
   <p:notesMasterIdLst>
-    <p:notesMasterId r:id="rId7"/>
+    <p:notesMasterId r:id="rId8"/>
   </p:notesMasterIdLst>
   <p:sldIdLst>
     <p:sldId id="256" r:id="rId2"/>
@@ -13,6 +13,7 @@
     <p:sldId id="258" r:id="rId4"/>
     <p:sldId id="259" r:id="rId5"/>
     <p:sldId id="260" r:id="rId6"/>
+    <p:sldId id="261" r:id="rId7"/>
   </p:sldIdLst>
   <p:sldSz cx="12192000" cy="6858000"/>
   <p:notesSz cx="6858000" cy="9144000"/>
@@ -201,7 +202,7 @@
           <a:p>
             <a:fld id="{C92715EB-E2EB-42F3-8C73-85DCB3326215}" type="datetimeFigureOut">
               <a:rPr lang="en-SG" smtClean="0"/>
-              <a:t>8/5/2026</a:t>
+              <a:t>9/5/2026</a:t>
             </a:fld>
             <a:endParaRPr lang="en-SG"/>
           </a:p>
@@ -745,6 +746,90 @@
 </p:notes>
 </file>
 
+<file path=ppt/notesSlides/notesSlide4.xml><?xml version="1.0" encoding="utf-8"?>
+<p:notes xmlns:a="http://schemas.openxmlformats.org/drawingml/2006/main" xmlns:r="http://schemas.openxmlformats.org/officeDocument/2006/relationships" xmlns:p="http://schemas.openxmlformats.org/presentationml/2006/main">
+  <p:cSld>
+    <p:spTree>
+      <p:nvGrpSpPr>
+        <p:cNvPr id="1" name=""/>
+        <p:cNvGrpSpPr/>
+        <p:nvPr/>
+      </p:nvGrpSpPr>
+      <p:grpSpPr>
+        <a:xfrm>
+          <a:off x="0" y="0"/>
+          <a:ext cx="0" cy="0"/>
+          <a:chOff x="0" y="0"/>
+          <a:chExt cx="0" cy="0"/>
+        </a:xfrm>
+      </p:grpSpPr>
+      <p:sp>
+        <p:nvSpPr>
+          <p:cNvPr id="2" name="Slide Image Placeholder 1"/>
+          <p:cNvSpPr>
+            <a:spLocks noGrp="1" noRot="1" noChangeAspect="1"/>
+          </p:cNvSpPr>
+          <p:nvPr>
+            <p:ph type="sldImg"/>
+          </p:nvPr>
+        </p:nvSpPr>
+        <p:spPr/>
+      </p:sp>
+      <p:sp>
+        <p:nvSpPr>
+          <p:cNvPr id="3" name="Notes Placeholder 2"/>
+          <p:cNvSpPr>
+            <a:spLocks noGrp="1"/>
+          </p:cNvSpPr>
+          <p:nvPr>
+            <p:ph type="body" idx="1"/>
+          </p:nvPr>
+        </p:nvSpPr>
+        <p:spPr/>
+        <p:txBody>
+          <a:bodyPr/>
+          <a:lstStyle/>
+          <a:p>
+            <a:endParaRPr lang="en-SG" dirty="0"/>
+          </a:p>
+        </p:txBody>
+      </p:sp>
+      <p:sp>
+        <p:nvSpPr>
+          <p:cNvPr id="4" name="Slide Number Placeholder 3"/>
+          <p:cNvSpPr>
+            <a:spLocks noGrp="1"/>
+          </p:cNvSpPr>
+          <p:nvPr>
+            <p:ph type="sldNum" sz="quarter" idx="5"/>
+          </p:nvPr>
+        </p:nvSpPr>
+        <p:spPr/>
+        <p:txBody>
+          <a:bodyPr/>
+          <a:lstStyle/>
+          <a:p>
+            <a:fld id="{893DCAB4-0F4A-4B1D-A039-CE22C5E63A9C}" type="slidenum">
+              <a:rPr lang="en-SG" smtClean="0"/>
+              <a:t>6</a:t>
+            </a:fld>
+            <a:endParaRPr lang="en-SG"/>
+          </a:p>
+        </p:txBody>
+      </p:sp>
+    </p:spTree>
+    <p:extLst>
+      <p:ext uri="{BB962C8B-B14F-4D97-AF65-F5344CB8AC3E}">
+        <p14:creationId xmlns:p14="http://schemas.microsoft.com/office/powerpoint/2010/main" val="1583032375"/>
+      </p:ext>
+    </p:extLst>
+  </p:cSld>
+  <p:clrMapOvr>
+    <a:masterClrMapping/>
+  </p:clrMapOvr>
+</p:notes>
+</file>
+
 <file path=ppt/slideLayouts/slideLayout1.xml><?xml version="1.0" encoding="utf-8"?>
 <p:sldLayout xmlns:a="http://schemas.openxmlformats.org/drawingml/2006/main" xmlns:r="http://schemas.openxmlformats.org/officeDocument/2006/relationships" xmlns:p="http://schemas.openxmlformats.org/presentationml/2006/main" type="title" preserve="1">
   <p:cSld name="Title Slide">
@@ -894,7 +979,7 @@
           <a:p>
             <a:fld id="{34BE27F4-F3F1-4FF7-9C3C-2BECB05327F1}" type="datetimeFigureOut">
               <a:rPr lang="en-SG" smtClean="0"/>
-              <a:t>8/5/2026</a:t>
+              <a:t>9/5/2026</a:t>
             </a:fld>
             <a:endParaRPr lang="en-SG"/>
           </a:p>
@@ -1094,7 +1179,7 @@
           <a:p>
             <a:fld id="{34BE27F4-F3F1-4FF7-9C3C-2BECB05327F1}" type="datetimeFigureOut">
               <a:rPr lang="en-SG" smtClean="0"/>
-              <a:t>8/5/2026</a:t>
+              <a:t>9/5/2026</a:t>
             </a:fld>
             <a:endParaRPr lang="en-SG"/>
           </a:p>
@@ -1304,7 +1389,7 @@
           <a:p>
             <a:fld id="{34BE27F4-F3F1-4FF7-9C3C-2BECB05327F1}" type="datetimeFigureOut">
               <a:rPr lang="en-SG" smtClean="0"/>
-              <a:t>8/5/2026</a:t>
+              <a:t>9/5/2026</a:t>
             </a:fld>
             <a:endParaRPr lang="en-SG"/>
           </a:p>
@@ -1504,7 +1589,7 @@
           <a:p>
             <a:fld id="{34BE27F4-F3F1-4FF7-9C3C-2BECB05327F1}" type="datetimeFigureOut">
               <a:rPr lang="en-SG" smtClean="0"/>
-              <a:t>8/5/2026</a:t>
+              <a:t>9/5/2026</a:t>
             </a:fld>
             <a:endParaRPr lang="en-SG"/>
           </a:p>
@@ -1780,7 +1865,7 @@
           <a:p>
             <a:fld id="{34BE27F4-F3F1-4FF7-9C3C-2BECB05327F1}" type="datetimeFigureOut">
               <a:rPr lang="en-SG" smtClean="0"/>
-              <a:t>8/5/2026</a:t>
+              <a:t>9/5/2026</a:t>
             </a:fld>
             <a:endParaRPr lang="en-SG"/>
           </a:p>
@@ -2048,7 +2133,7 @@
           <a:p>
             <a:fld id="{34BE27F4-F3F1-4FF7-9C3C-2BECB05327F1}" type="datetimeFigureOut">
               <a:rPr lang="en-SG" smtClean="0"/>
-              <a:t>8/5/2026</a:t>
+              <a:t>9/5/2026</a:t>
             </a:fld>
             <a:endParaRPr lang="en-SG"/>
           </a:p>
@@ -2463,7 +2548,7 @@
           <a:p>
             <a:fld id="{34BE27F4-F3F1-4FF7-9C3C-2BECB05327F1}" type="datetimeFigureOut">
               <a:rPr lang="en-SG" smtClean="0"/>
-              <a:t>8/5/2026</a:t>
+              <a:t>9/5/2026</a:t>
             </a:fld>
             <a:endParaRPr lang="en-SG"/>
           </a:p>
@@ -2605,7 +2690,7 @@
           <a:p>
             <a:fld id="{34BE27F4-F3F1-4FF7-9C3C-2BECB05327F1}" type="datetimeFigureOut">
               <a:rPr lang="en-SG" smtClean="0"/>
-              <a:t>8/5/2026</a:t>
+              <a:t>9/5/2026</a:t>
             </a:fld>
             <a:endParaRPr lang="en-SG"/>
           </a:p>
@@ -2718,7 +2803,7 @@
           <a:p>
             <a:fld id="{34BE27F4-F3F1-4FF7-9C3C-2BECB05327F1}" type="datetimeFigureOut">
               <a:rPr lang="en-SG" smtClean="0"/>
-              <a:t>8/5/2026</a:t>
+              <a:t>9/5/2026</a:t>
             </a:fld>
             <a:endParaRPr lang="en-SG"/>
           </a:p>
@@ -3031,7 +3116,7 @@
           <a:p>
             <a:fld id="{34BE27F4-F3F1-4FF7-9C3C-2BECB05327F1}" type="datetimeFigureOut">
               <a:rPr lang="en-SG" smtClean="0"/>
-              <a:t>8/5/2026</a:t>
+              <a:t>9/5/2026</a:t>
             </a:fld>
             <a:endParaRPr lang="en-SG"/>
           </a:p>
@@ -3320,7 +3405,7 @@
           <a:p>
             <a:fld id="{34BE27F4-F3F1-4FF7-9C3C-2BECB05327F1}" type="datetimeFigureOut">
               <a:rPr lang="en-SG" smtClean="0"/>
-              <a:t>8/5/2026</a:t>
+              <a:t>9/5/2026</a:t>
             </a:fld>
             <a:endParaRPr lang="en-SG"/>
           </a:p>
@@ -3563,7 +3648,7 @@
           <a:p>
             <a:fld id="{34BE27F4-F3F1-4FF7-9C3C-2BECB05327F1}" type="datetimeFigureOut">
               <a:rPr lang="en-SG" smtClean="0"/>
-              <a:t>8/5/2026</a:t>
+              <a:t>9/5/2026</a:t>
             </a:fld>
             <a:endParaRPr lang="en-SG"/>
           </a:p>
@@ -24260,6 +24345,325 @@
     <p:extLst>
       <p:ext uri="{BB962C8B-B14F-4D97-AF65-F5344CB8AC3E}">
         <p14:creationId xmlns:p14="http://schemas.microsoft.com/office/powerpoint/2010/main" val="3967297542"/>
+      </p:ext>
+    </p:extLst>
+  </p:cSld>
+  <p:clrMapOvr>
+    <a:masterClrMapping/>
+  </p:clrMapOvr>
+</p:sld>
+</file>
+
+<file path=ppt/slides/slide6.xml><?xml version="1.0" encoding="utf-8"?>
+<p:sld xmlns:a="http://schemas.openxmlformats.org/drawingml/2006/main" xmlns:r="http://schemas.openxmlformats.org/officeDocument/2006/relationships" xmlns:p="http://schemas.openxmlformats.org/presentationml/2006/main">
+  <p:cSld>
+    <p:spTree>
+      <p:nvGrpSpPr>
+        <p:cNvPr id="1" name=""/>
+        <p:cNvGrpSpPr/>
+        <p:nvPr/>
+      </p:nvGrpSpPr>
+      <p:grpSpPr>
+        <a:xfrm>
+          <a:off x="0" y="0"/>
+          <a:ext cx="0" cy="0"/>
+          <a:chOff x="0" y="0"/>
+          <a:chExt cx="0" cy="0"/>
+        </a:xfrm>
+      </p:grpSpPr>
+      <p:pic>
+        <p:nvPicPr>
+          <p:cNvPr id="5" name="Picture 4">
+            <a:extLst>
+              <a:ext uri="{FF2B5EF4-FFF2-40B4-BE49-F238E27FC236}">
+                <a16:creationId xmlns:a16="http://schemas.microsoft.com/office/drawing/2014/main" id="{B7E0A2AF-7041-0710-588D-3C5D769FC54A}"/>
+              </a:ext>
+            </a:extLst>
+          </p:cNvPr>
+          <p:cNvPicPr>
+            <a:picLocks noChangeAspect="1"/>
+          </p:cNvPicPr>
+          <p:nvPr/>
+        </p:nvPicPr>
+        <p:blipFill>
+          <a:blip r:embed="rId3">
+            <a:extLst>
+              <a:ext uri="{28A0092B-C50C-407E-A947-70E740481C1C}">
+                <a14:useLocalDpi xmlns:a14="http://schemas.microsoft.com/office/drawing/2010/main" val="0"/>
+              </a:ext>
+            </a:extLst>
+          </a:blip>
+          <a:stretch>
+            <a:fillRect/>
+          </a:stretch>
+        </p:blipFill>
+        <p:spPr>
+          <a:xfrm>
+            <a:off x="952500" y="623454"/>
+            <a:ext cx="10287000" cy="5611091"/>
+          </a:xfrm>
+          <a:prstGeom prst="rect">
+            <a:avLst/>
+          </a:prstGeom>
+        </p:spPr>
+      </p:pic>
+      <p:pic>
+        <p:nvPicPr>
+          <p:cNvPr id="7" name="Picture 6">
+            <a:extLst>
+              <a:ext uri="{FF2B5EF4-FFF2-40B4-BE49-F238E27FC236}">
+                <a16:creationId xmlns:a16="http://schemas.microsoft.com/office/drawing/2014/main" id="{0EF063F0-E652-6C4C-3173-77738CF21992}"/>
+              </a:ext>
+            </a:extLst>
+          </p:cNvPr>
+          <p:cNvPicPr>
+            <a:picLocks noChangeAspect="1"/>
+          </p:cNvPicPr>
+          <p:nvPr/>
+        </p:nvPicPr>
+        <p:blipFill>
+          <a:blip r:embed="rId4"/>
+          <a:stretch>
+            <a:fillRect/>
+          </a:stretch>
+        </p:blipFill>
+        <p:spPr>
+          <a:xfrm>
+            <a:off x="1192112" y="2804239"/>
+            <a:ext cx="1932087" cy="1788969"/>
+          </a:xfrm>
+          <a:prstGeom prst="roundRect">
+            <a:avLst>
+              <a:gd name="adj" fmla="val 8594"/>
+            </a:avLst>
+          </a:prstGeom>
+          <a:solidFill>
+            <a:srgbClr val="FFFFFF">
+              <a:shade val="85000"/>
+            </a:srgbClr>
+          </a:solidFill>
+          <a:ln>
+            <a:noFill/>
+          </a:ln>
+          <a:effectLst>
+            <a:reflection blurRad="12700" stA="38000" endPos="28000" dist="5000" dir="5400000" sy="-100000" algn="bl" rotWithShape="0"/>
+          </a:effectLst>
+        </p:spPr>
+      </p:pic>
+      <p:pic>
+        <p:nvPicPr>
+          <p:cNvPr id="9" name="Picture 8">
+            <a:extLst>
+              <a:ext uri="{FF2B5EF4-FFF2-40B4-BE49-F238E27FC236}">
+                <a16:creationId xmlns:a16="http://schemas.microsoft.com/office/drawing/2014/main" id="{E9365F86-4DF8-7F26-B87F-28D9D6D6F4AA}"/>
+              </a:ext>
+            </a:extLst>
+          </p:cNvPr>
+          <p:cNvPicPr>
+            <a:picLocks noChangeAspect="1"/>
+          </p:cNvPicPr>
+          <p:nvPr/>
+        </p:nvPicPr>
+        <p:blipFill>
+          <a:blip r:embed="rId5"/>
+          <a:stretch>
+            <a:fillRect/>
+          </a:stretch>
+        </p:blipFill>
+        <p:spPr>
+          <a:xfrm>
+            <a:off x="8563310" y="3698723"/>
+            <a:ext cx="2676190" cy="961905"/>
+          </a:xfrm>
+          <a:prstGeom prst="roundRect">
+            <a:avLst>
+              <a:gd name="adj" fmla="val 8594"/>
+            </a:avLst>
+          </a:prstGeom>
+          <a:solidFill>
+            <a:srgbClr val="FFFFFF">
+              <a:shade val="85000"/>
+            </a:srgbClr>
+          </a:solidFill>
+          <a:ln>
+            <a:noFill/>
+          </a:ln>
+          <a:effectLst>
+            <a:reflection blurRad="12700" stA="38000" endPos="28000" dist="5000" dir="5400000" sy="-100000" algn="bl" rotWithShape="0"/>
+          </a:effectLst>
+        </p:spPr>
+      </p:pic>
+      <p:cxnSp>
+        <p:nvCxnSpPr>
+          <p:cNvPr id="13" name="Straight Arrow Connector 12">
+            <a:extLst>
+              <a:ext uri="{FF2B5EF4-FFF2-40B4-BE49-F238E27FC236}">
+                <a16:creationId xmlns:a16="http://schemas.microsoft.com/office/drawing/2014/main" id="{046819A2-4C5B-1B14-0C15-683A0656755C}"/>
+              </a:ext>
+            </a:extLst>
+          </p:cNvPr>
+          <p:cNvCxnSpPr/>
+          <p:nvPr/>
+        </p:nvCxnSpPr>
+        <p:spPr>
+          <a:xfrm>
+            <a:off x="10428514" y="3211286"/>
+            <a:ext cx="0" cy="487437"/>
+          </a:xfrm>
+          <a:prstGeom prst="straightConnector1">
+            <a:avLst/>
+          </a:prstGeom>
+          <a:ln>
+            <a:tailEnd type="triangle"/>
+          </a:ln>
+        </p:spPr>
+        <p:style>
+          <a:lnRef idx="2">
+            <a:schemeClr val="dk1"/>
+          </a:lnRef>
+          <a:fillRef idx="0">
+            <a:schemeClr val="dk1"/>
+          </a:fillRef>
+          <a:effectRef idx="1">
+            <a:schemeClr val="dk1"/>
+          </a:effectRef>
+          <a:fontRef idx="minor">
+            <a:schemeClr val="tx1"/>
+          </a:fontRef>
+        </p:style>
+      </p:cxnSp>
+      <p:cxnSp>
+        <p:nvCxnSpPr>
+          <p:cNvPr id="16" name="Connector: Elbow 15">
+            <a:extLst>
+              <a:ext uri="{FF2B5EF4-FFF2-40B4-BE49-F238E27FC236}">
+                <a16:creationId xmlns:a16="http://schemas.microsoft.com/office/drawing/2014/main" id="{9B526E41-8A0D-EA5D-C039-E4294BDDDF05}"/>
+              </a:ext>
+            </a:extLst>
+          </p:cNvPr>
+          <p:cNvCxnSpPr>
+            <a:cxnSpLocks/>
+            <a:endCxn id="7" idx="3"/>
+          </p:cNvCxnSpPr>
+          <p:nvPr/>
+        </p:nvCxnSpPr>
+        <p:spPr>
+          <a:xfrm rot="10800000" flipV="1">
+            <a:off x="3124200" y="2569028"/>
+            <a:ext cx="1284515" cy="1129695"/>
+          </a:xfrm>
+          <a:prstGeom prst="bentConnector3">
+            <a:avLst>
+              <a:gd name="adj1" fmla="val 36441"/>
+            </a:avLst>
+          </a:prstGeom>
+          <a:ln>
+            <a:tailEnd type="triangle"/>
+          </a:ln>
+        </p:spPr>
+        <p:style>
+          <a:lnRef idx="2">
+            <a:schemeClr val="dk1"/>
+          </a:lnRef>
+          <a:fillRef idx="0">
+            <a:schemeClr val="dk1"/>
+          </a:fillRef>
+          <a:effectRef idx="1">
+            <a:schemeClr val="dk1"/>
+          </a:effectRef>
+          <a:fontRef idx="minor">
+            <a:schemeClr val="tx1"/>
+          </a:fontRef>
+        </p:style>
+      </p:cxnSp>
+      <p:cxnSp>
+        <p:nvCxnSpPr>
+          <p:cNvPr id="19" name="Straight Arrow Connector 18">
+            <a:extLst>
+              <a:ext uri="{FF2B5EF4-FFF2-40B4-BE49-F238E27FC236}">
+                <a16:creationId xmlns:a16="http://schemas.microsoft.com/office/drawing/2014/main" id="{CE9B9B1F-7D59-2ADD-1983-818585419A1F}"/>
+              </a:ext>
+            </a:extLst>
+          </p:cNvPr>
+          <p:cNvCxnSpPr>
+            <a:cxnSpLocks/>
+          </p:cNvCxnSpPr>
+          <p:nvPr/>
+        </p:nvCxnSpPr>
+        <p:spPr>
+          <a:xfrm flipH="1">
+            <a:off x="4680857" y="5704115"/>
+            <a:ext cx="1970315" cy="0"/>
+          </a:xfrm>
+          <a:prstGeom prst="straightConnector1">
+            <a:avLst/>
+          </a:prstGeom>
+          <a:ln>
+            <a:tailEnd type="triangle"/>
+          </a:ln>
+        </p:spPr>
+        <p:style>
+          <a:lnRef idx="2">
+            <a:schemeClr val="dk1"/>
+          </a:lnRef>
+          <a:fillRef idx="0">
+            <a:schemeClr val="dk1"/>
+          </a:fillRef>
+          <a:effectRef idx="1">
+            <a:schemeClr val="dk1"/>
+          </a:effectRef>
+          <a:fontRef idx="minor">
+            <a:schemeClr val="tx1"/>
+          </a:fontRef>
+        </p:style>
+      </p:cxnSp>
+      <p:pic>
+        <p:nvPicPr>
+          <p:cNvPr id="23" name="Picture 22">
+            <a:extLst>
+              <a:ext uri="{FF2B5EF4-FFF2-40B4-BE49-F238E27FC236}">
+                <a16:creationId xmlns:a16="http://schemas.microsoft.com/office/drawing/2014/main" id="{2E56B6B3-BEEA-E7EE-A685-BF6D96D1DBB2}"/>
+              </a:ext>
+            </a:extLst>
+          </p:cNvPr>
+          <p:cNvPicPr>
+            <a:picLocks noChangeAspect="1"/>
+          </p:cNvPicPr>
+          <p:nvPr/>
+        </p:nvPicPr>
+        <p:blipFill>
+          <a:blip r:embed="rId6"/>
+          <a:stretch>
+            <a:fillRect/>
+          </a:stretch>
+        </p:blipFill>
+        <p:spPr>
+          <a:xfrm>
+            <a:off x="2228319" y="4936225"/>
+            <a:ext cx="2452538" cy="943284"/>
+          </a:xfrm>
+          <a:prstGeom prst="roundRect">
+            <a:avLst>
+              <a:gd name="adj" fmla="val 8594"/>
+            </a:avLst>
+          </a:prstGeom>
+          <a:solidFill>
+            <a:srgbClr val="FFFFFF">
+              <a:shade val="85000"/>
+            </a:srgbClr>
+          </a:solidFill>
+          <a:ln>
+            <a:noFill/>
+          </a:ln>
+          <a:effectLst>
+            <a:reflection blurRad="12700" stA="38000" endPos="28000" dist="5000" dir="5400000" sy="-100000" algn="bl" rotWithShape="0"/>
+          </a:effectLst>
+        </p:spPr>
+      </p:pic>
+    </p:spTree>
+    <p:extLst>
+      <p:ext uri="{BB962C8B-B14F-4D97-AF65-F5344CB8AC3E}">
+        <p14:creationId xmlns:p14="http://schemas.microsoft.com/office/powerpoint/2010/main" val="3764271208"/>
       </p:ext>
     </p:extLst>
   </p:cSld>

</xml_diff>

<commit_message>
Update the title image and the table of contents of the case study document.
</commit_message>
<xml_diff>
--- a/5_CaseStudy_Doc/Case0_img/designDoc.pptx
+++ b/5_CaseStudy_Doc/Case0_img/designDoc.pptx
@@ -5,7 +5,7 @@
     <p:sldMasterId id="2147483648" r:id="rId1"/>
   </p:sldMasterIdLst>
   <p:notesMasterIdLst>
-    <p:notesMasterId r:id="rId8"/>
+    <p:notesMasterId r:id="rId9"/>
   </p:notesMasterIdLst>
   <p:sldIdLst>
     <p:sldId id="256" r:id="rId2"/>
@@ -14,6 +14,7 @@
     <p:sldId id="259" r:id="rId5"/>
     <p:sldId id="260" r:id="rId6"/>
     <p:sldId id="261" r:id="rId7"/>
+    <p:sldId id="262" r:id="rId8"/>
   </p:sldIdLst>
   <p:sldSz cx="12192000" cy="6858000"/>
   <p:notesSz cx="6858000" cy="9144000"/>
@@ -202,7 +203,7 @@
           <a:p>
             <a:fld id="{C92715EB-E2EB-42F3-8C73-85DCB3326215}" type="datetimeFigureOut">
               <a:rPr lang="en-SG" smtClean="0"/>
-              <a:t>9/5/2026</a:t>
+              <a:t>10/5/2026</a:t>
             </a:fld>
             <a:endParaRPr lang="en-SG"/>
           </a:p>
@@ -979,7 +980,7 @@
           <a:p>
             <a:fld id="{34BE27F4-F3F1-4FF7-9C3C-2BECB05327F1}" type="datetimeFigureOut">
               <a:rPr lang="en-SG" smtClean="0"/>
-              <a:t>9/5/2026</a:t>
+              <a:t>10/5/2026</a:t>
             </a:fld>
             <a:endParaRPr lang="en-SG"/>
           </a:p>
@@ -1179,7 +1180,7 @@
           <a:p>
             <a:fld id="{34BE27F4-F3F1-4FF7-9C3C-2BECB05327F1}" type="datetimeFigureOut">
               <a:rPr lang="en-SG" smtClean="0"/>
-              <a:t>9/5/2026</a:t>
+              <a:t>10/5/2026</a:t>
             </a:fld>
             <a:endParaRPr lang="en-SG"/>
           </a:p>
@@ -1389,7 +1390,7 @@
           <a:p>
             <a:fld id="{34BE27F4-F3F1-4FF7-9C3C-2BECB05327F1}" type="datetimeFigureOut">
               <a:rPr lang="en-SG" smtClean="0"/>
-              <a:t>9/5/2026</a:t>
+              <a:t>10/5/2026</a:t>
             </a:fld>
             <a:endParaRPr lang="en-SG"/>
           </a:p>
@@ -1589,7 +1590,7 @@
           <a:p>
             <a:fld id="{34BE27F4-F3F1-4FF7-9C3C-2BECB05327F1}" type="datetimeFigureOut">
               <a:rPr lang="en-SG" smtClean="0"/>
-              <a:t>9/5/2026</a:t>
+              <a:t>10/5/2026</a:t>
             </a:fld>
             <a:endParaRPr lang="en-SG"/>
           </a:p>
@@ -1865,7 +1866,7 @@
           <a:p>
             <a:fld id="{34BE27F4-F3F1-4FF7-9C3C-2BECB05327F1}" type="datetimeFigureOut">
               <a:rPr lang="en-SG" smtClean="0"/>
-              <a:t>9/5/2026</a:t>
+              <a:t>10/5/2026</a:t>
             </a:fld>
             <a:endParaRPr lang="en-SG"/>
           </a:p>
@@ -2133,7 +2134,7 @@
           <a:p>
             <a:fld id="{34BE27F4-F3F1-4FF7-9C3C-2BECB05327F1}" type="datetimeFigureOut">
               <a:rPr lang="en-SG" smtClean="0"/>
-              <a:t>9/5/2026</a:t>
+              <a:t>10/5/2026</a:t>
             </a:fld>
             <a:endParaRPr lang="en-SG"/>
           </a:p>
@@ -2548,7 +2549,7 @@
           <a:p>
             <a:fld id="{34BE27F4-F3F1-4FF7-9C3C-2BECB05327F1}" type="datetimeFigureOut">
               <a:rPr lang="en-SG" smtClean="0"/>
-              <a:t>9/5/2026</a:t>
+              <a:t>10/5/2026</a:t>
             </a:fld>
             <a:endParaRPr lang="en-SG"/>
           </a:p>
@@ -2690,7 +2691,7 @@
           <a:p>
             <a:fld id="{34BE27F4-F3F1-4FF7-9C3C-2BECB05327F1}" type="datetimeFigureOut">
               <a:rPr lang="en-SG" smtClean="0"/>
-              <a:t>9/5/2026</a:t>
+              <a:t>10/5/2026</a:t>
             </a:fld>
             <a:endParaRPr lang="en-SG"/>
           </a:p>
@@ -2803,7 +2804,7 @@
           <a:p>
             <a:fld id="{34BE27F4-F3F1-4FF7-9C3C-2BECB05327F1}" type="datetimeFigureOut">
               <a:rPr lang="en-SG" smtClean="0"/>
-              <a:t>9/5/2026</a:t>
+              <a:t>10/5/2026</a:t>
             </a:fld>
             <a:endParaRPr lang="en-SG"/>
           </a:p>
@@ -3116,7 +3117,7 @@
           <a:p>
             <a:fld id="{34BE27F4-F3F1-4FF7-9C3C-2BECB05327F1}" type="datetimeFigureOut">
               <a:rPr lang="en-SG" smtClean="0"/>
-              <a:t>9/5/2026</a:t>
+              <a:t>10/5/2026</a:t>
             </a:fld>
             <a:endParaRPr lang="en-SG"/>
           </a:p>
@@ -3405,7 +3406,7 @@
           <a:p>
             <a:fld id="{34BE27F4-F3F1-4FF7-9C3C-2BECB05327F1}" type="datetimeFigureOut">
               <a:rPr lang="en-SG" smtClean="0"/>
-              <a:t>9/5/2026</a:t>
+              <a:t>10/5/2026</a:t>
             </a:fld>
             <a:endParaRPr lang="en-SG"/>
           </a:p>
@@ -3648,7 +3649,7 @@
           <a:p>
             <a:fld id="{34BE27F4-F3F1-4FF7-9C3C-2BECB05327F1}" type="datetimeFigureOut">
               <a:rPr lang="en-SG" smtClean="0"/>
-              <a:t>9/5/2026</a:t>
+              <a:t>10/5/2026</a:t>
             </a:fld>
             <a:endParaRPr lang="en-SG"/>
           </a:p>
@@ -24664,6 +24665,1048 @@
     <p:extLst>
       <p:ext uri="{BB962C8B-B14F-4D97-AF65-F5344CB8AC3E}">
         <p14:creationId xmlns:p14="http://schemas.microsoft.com/office/powerpoint/2010/main" val="3764271208"/>
+      </p:ext>
+    </p:extLst>
+  </p:cSld>
+  <p:clrMapOvr>
+    <a:masterClrMapping/>
+  </p:clrMapOvr>
+</p:sld>
+</file>
+
+<file path=ppt/slides/slide7.xml><?xml version="1.0" encoding="utf-8"?>
+<p:sld xmlns:a="http://schemas.openxmlformats.org/drawingml/2006/main" xmlns:r="http://schemas.openxmlformats.org/officeDocument/2006/relationships" xmlns:p="http://schemas.openxmlformats.org/presentationml/2006/main">
+  <p:cSld>
+    <p:spTree>
+      <p:nvGrpSpPr>
+        <p:cNvPr id="1" name=""/>
+        <p:cNvGrpSpPr/>
+        <p:nvPr/>
+      </p:nvGrpSpPr>
+      <p:grpSpPr>
+        <a:xfrm>
+          <a:off x="0" y="0"/>
+          <a:ext cx="0" cy="0"/>
+          <a:chOff x="0" y="0"/>
+          <a:chExt cx="0" cy="0"/>
+        </a:xfrm>
+      </p:grpSpPr>
+      <p:sp>
+        <p:nvSpPr>
+          <p:cNvPr id="31" name="Rectangle 30">
+            <a:extLst>
+              <a:ext uri="{FF2B5EF4-FFF2-40B4-BE49-F238E27FC236}">
+                <a16:creationId xmlns:a16="http://schemas.microsoft.com/office/drawing/2014/main" id="{5F39C37C-8128-B440-F2D2-86C1AB612244}"/>
+              </a:ext>
+            </a:extLst>
+          </p:cNvPr>
+          <p:cNvSpPr/>
+          <p:nvPr/>
+        </p:nvSpPr>
+        <p:spPr>
+          <a:xfrm>
+            <a:off x="304800" y="212436"/>
+            <a:ext cx="11453638" cy="6493164"/>
+          </a:xfrm>
+          <a:prstGeom prst="rect">
+            <a:avLst/>
+          </a:prstGeom>
+          <a:noFill/>
+        </p:spPr>
+        <p:style>
+          <a:lnRef idx="2">
+            <a:schemeClr val="accent1">
+              <a:shade val="15000"/>
+            </a:schemeClr>
+          </a:lnRef>
+          <a:fillRef idx="1">
+            <a:schemeClr val="accent1"/>
+          </a:fillRef>
+          <a:effectRef idx="0">
+            <a:schemeClr val="accent1"/>
+          </a:effectRef>
+          <a:fontRef idx="minor">
+            <a:schemeClr val="lt1"/>
+          </a:fontRef>
+        </p:style>
+        <p:txBody>
+          <a:bodyPr rtlCol="0" anchor="ctr"/>
+          <a:lstStyle/>
+          <a:p>
+            <a:pPr algn="ctr"/>
+            <a:endParaRPr lang="en-SG"/>
+          </a:p>
+        </p:txBody>
+      </p:sp>
+      <p:pic>
+        <p:nvPicPr>
+          <p:cNvPr id="7" name="Picture 6">
+            <a:extLst>
+              <a:ext uri="{FF2B5EF4-FFF2-40B4-BE49-F238E27FC236}">
+                <a16:creationId xmlns:a16="http://schemas.microsoft.com/office/drawing/2014/main" id="{3AC78270-AAC0-453A-4D4D-3FA4FD8D3D3F}"/>
+              </a:ext>
+            </a:extLst>
+          </p:cNvPr>
+          <p:cNvPicPr>
+            <a:picLocks noChangeAspect="1"/>
+          </p:cNvPicPr>
+          <p:nvPr/>
+        </p:nvPicPr>
+        <p:blipFill>
+          <a:blip r:embed="rId2">
+            <a:extLst>
+              <a:ext uri="{28A0092B-C50C-407E-A947-70E740481C1C}">
+                <a14:useLocalDpi xmlns:a14="http://schemas.microsoft.com/office/drawing/2010/main" val="0"/>
+              </a:ext>
+            </a:extLst>
+          </a:blip>
+          <a:stretch>
+            <a:fillRect/>
+          </a:stretch>
+        </p:blipFill>
+        <p:spPr>
+          <a:xfrm>
+            <a:off x="4674349" y="2653498"/>
+            <a:ext cx="6908051" cy="3928781"/>
+          </a:xfrm>
+          <a:prstGeom prst="rect">
+            <a:avLst/>
+          </a:prstGeom>
+        </p:spPr>
+      </p:pic>
+      <p:pic>
+        <p:nvPicPr>
+          <p:cNvPr id="11" name="Picture 10">
+            <a:extLst>
+              <a:ext uri="{FF2B5EF4-FFF2-40B4-BE49-F238E27FC236}">
+                <a16:creationId xmlns:a16="http://schemas.microsoft.com/office/drawing/2014/main" id="{3C74CAF2-6FA1-ADCA-7D1D-D41F46BFC937}"/>
+              </a:ext>
+            </a:extLst>
+          </p:cNvPr>
+          <p:cNvPicPr>
+            <a:picLocks noChangeAspect="1"/>
+          </p:cNvPicPr>
+          <p:nvPr/>
+        </p:nvPicPr>
+        <p:blipFill>
+          <a:blip r:embed="rId3">
+            <a:extLst>
+              <a:ext uri="{28A0092B-C50C-407E-A947-70E740481C1C}">
+                <a14:useLocalDpi xmlns:a14="http://schemas.microsoft.com/office/drawing/2010/main" val="0"/>
+              </a:ext>
+            </a:extLst>
+          </a:blip>
+          <a:stretch>
+            <a:fillRect/>
+          </a:stretch>
+        </p:blipFill>
+        <p:spPr>
+          <a:xfrm>
+            <a:off x="470506" y="4760361"/>
+            <a:ext cx="3999893" cy="1714240"/>
+          </a:xfrm>
+          <a:prstGeom prst="rect">
+            <a:avLst/>
+          </a:prstGeom>
+          <a:ln w="38100" cap="sq">
+            <a:solidFill>
+              <a:srgbClr val="000000"/>
+            </a:solidFill>
+            <a:prstDash val="solid"/>
+            <a:miter lim="800000"/>
+          </a:ln>
+          <a:effectLst>
+            <a:outerShdw blurRad="50800" dist="38100" dir="2700000" algn="tl" rotWithShape="0">
+              <a:srgbClr val="000000">
+                <a:alpha val="43000"/>
+              </a:srgbClr>
+            </a:outerShdw>
+          </a:effectLst>
+        </p:spPr>
+      </p:pic>
+      <p:pic>
+        <p:nvPicPr>
+          <p:cNvPr id="5" name="Picture 4">
+            <a:extLst>
+              <a:ext uri="{FF2B5EF4-FFF2-40B4-BE49-F238E27FC236}">
+                <a16:creationId xmlns:a16="http://schemas.microsoft.com/office/drawing/2014/main" id="{A7566E7F-06CF-B12D-C108-D81274FDA314}"/>
+              </a:ext>
+            </a:extLst>
+          </p:cNvPr>
+          <p:cNvPicPr>
+            <a:picLocks noChangeAspect="1"/>
+          </p:cNvPicPr>
+          <p:nvPr/>
+        </p:nvPicPr>
+        <p:blipFill>
+          <a:blip r:embed="rId4">
+            <a:extLst>
+              <a:ext uri="{28A0092B-C50C-407E-A947-70E740481C1C}">
+                <a14:useLocalDpi xmlns:a14="http://schemas.microsoft.com/office/drawing/2010/main" val="0"/>
+              </a:ext>
+            </a:extLst>
+          </a:blip>
+          <a:stretch>
+            <a:fillRect/>
+          </a:stretch>
+        </p:blipFill>
+        <p:spPr>
+          <a:xfrm>
+            <a:off x="433562" y="1216005"/>
+            <a:ext cx="5754802" cy="3272900"/>
+          </a:xfrm>
+          <a:prstGeom prst="rect">
+            <a:avLst/>
+          </a:prstGeom>
+        </p:spPr>
+      </p:pic>
+      <p:sp>
+        <p:nvSpPr>
+          <p:cNvPr id="12" name="Arrow: Bent 11">
+            <a:extLst>
+              <a:ext uri="{FF2B5EF4-FFF2-40B4-BE49-F238E27FC236}">
+                <a16:creationId xmlns:a16="http://schemas.microsoft.com/office/drawing/2014/main" id="{3BED3515-D945-F12E-44A2-4E2C3CC4B1A7}"/>
+              </a:ext>
+            </a:extLst>
+          </p:cNvPr>
+          <p:cNvSpPr/>
+          <p:nvPr/>
+        </p:nvSpPr>
+        <p:spPr>
+          <a:xfrm flipH="1">
+            <a:off x="5985163" y="2653498"/>
+            <a:ext cx="687779" cy="662737"/>
+          </a:xfrm>
+          <a:prstGeom prst="bentArrow">
+            <a:avLst/>
+          </a:prstGeom>
+          <a:solidFill>
+            <a:schemeClr val="accent2">
+              <a:lumMod val="75000"/>
+            </a:schemeClr>
+          </a:solidFill>
+        </p:spPr>
+        <p:style>
+          <a:lnRef idx="2">
+            <a:schemeClr val="accent1">
+              <a:shade val="15000"/>
+            </a:schemeClr>
+          </a:lnRef>
+          <a:fillRef idx="1">
+            <a:schemeClr val="accent1"/>
+          </a:fillRef>
+          <a:effectRef idx="0">
+            <a:schemeClr val="accent1"/>
+          </a:effectRef>
+          <a:fontRef idx="minor">
+            <a:schemeClr val="lt1"/>
+          </a:fontRef>
+        </p:style>
+        <p:txBody>
+          <a:bodyPr rtlCol="0" anchor="ctr"/>
+          <a:lstStyle/>
+          <a:p>
+            <a:pPr algn="ctr"/>
+            <a:endParaRPr lang="en-SG">
+              <a:solidFill>
+                <a:schemeClr val="tx1"/>
+              </a:solidFill>
+            </a:endParaRPr>
+          </a:p>
+        </p:txBody>
+      </p:sp>
+      <p:sp>
+        <p:nvSpPr>
+          <p:cNvPr id="13" name="Arrow: Down 12">
+            <a:extLst>
+              <a:ext uri="{FF2B5EF4-FFF2-40B4-BE49-F238E27FC236}">
+                <a16:creationId xmlns:a16="http://schemas.microsoft.com/office/drawing/2014/main" id="{4D559793-7084-6BF3-0A62-DA4673ED51A9}"/>
+              </a:ext>
+            </a:extLst>
+          </p:cNvPr>
+          <p:cNvSpPr/>
+          <p:nvPr/>
+        </p:nvSpPr>
+        <p:spPr>
+          <a:xfrm>
+            <a:off x="1845134" y="4314632"/>
+            <a:ext cx="269993" cy="571404"/>
+          </a:xfrm>
+          <a:prstGeom prst="downArrow">
+            <a:avLst/>
+          </a:prstGeom>
+          <a:solidFill>
+            <a:schemeClr val="accent2">
+              <a:lumMod val="75000"/>
+            </a:schemeClr>
+          </a:solidFill>
+        </p:spPr>
+        <p:style>
+          <a:lnRef idx="2">
+            <a:schemeClr val="accent1">
+              <a:shade val="15000"/>
+            </a:schemeClr>
+          </a:lnRef>
+          <a:fillRef idx="1">
+            <a:schemeClr val="accent1"/>
+          </a:fillRef>
+          <a:effectRef idx="0">
+            <a:schemeClr val="accent1"/>
+          </a:effectRef>
+          <a:fontRef idx="minor">
+            <a:schemeClr val="lt1"/>
+          </a:fontRef>
+        </p:style>
+        <p:txBody>
+          <a:bodyPr rtlCol="0" anchor="ctr"/>
+          <a:lstStyle/>
+          <a:p>
+            <a:pPr algn="ctr"/>
+            <a:endParaRPr lang="en-SG"/>
+          </a:p>
+        </p:txBody>
+      </p:sp>
+      <p:sp>
+        <p:nvSpPr>
+          <p:cNvPr id="14" name="TextBox 13">
+            <a:extLst>
+              <a:ext uri="{FF2B5EF4-FFF2-40B4-BE49-F238E27FC236}">
+                <a16:creationId xmlns:a16="http://schemas.microsoft.com/office/drawing/2014/main" id="{15659A56-4CB3-5BB1-A598-271E98B09F40}"/>
+              </a:ext>
+            </a:extLst>
+          </p:cNvPr>
+          <p:cNvSpPr txBox="1"/>
+          <p:nvPr/>
+        </p:nvSpPr>
+        <p:spPr>
+          <a:xfrm>
+            <a:off x="470506" y="359355"/>
+            <a:ext cx="10003530" cy="707886"/>
+          </a:xfrm>
+          <a:prstGeom prst="rect">
+            <a:avLst/>
+          </a:prstGeom>
+          <a:noFill/>
+          <a:ln w="19050">
+            <a:solidFill>
+              <a:schemeClr val="tx1"/>
+            </a:solidFill>
+            <a:prstDash val="sysDash"/>
+          </a:ln>
+        </p:spPr>
+        <p:txBody>
+          <a:bodyPr wrap="square" rtlCol="0">
+            <a:spAutoFit/>
+          </a:bodyPr>
+          <a:lstStyle/>
+          <a:p>
+            <a:r>
+              <a:rPr lang="en-US" sz="2000" b="1" dirty="0"/>
+              <a:t>High Speed Rail Spoofing Cyber Attack Case Study : Use Cyber Twin to Simulate the Cyber Incident Happened in Taiwan High Speed Rail in April 2026</a:t>
+            </a:r>
+            <a:endParaRPr lang="en-SG" sz="2000" b="1" dirty="0"/>
+          </a:p>
+        </p:txBody>
+      </p:sp>
+      <p:pic>
+        <p:nvPicPr>
+          <p:cNvPr id="15" name="Picture 14" descr="A logo of a train&#10;&#10;AI-generated content may be incorrect.">
+            <a:extLst>
+              <a:ext uri="{FF2B5EF4-FFF2-40B4-BE49-F238E27FC236}">
+                <a16:creationId xmlns:a16="http://schemas.microsoft.com/office/drawing/2014/main" id="{B9D51C81-7D7B-D213-DA1B-D400AAF50EEA}"/>
+              </a:ext>
+            </a:extLst>
+          </p:cNvPr>
+          <p:cNvPicPr>
+            <a:picLocks noChangeAspect="1"/>
+          </p:cNvPicPr>
+          <p:nvPr/>
+        </p:nvPicPr>
+        <p:blipFill>
+          <a:blip r:embed="rId5">
+            <a:extLst>
+              <a:ext uri="{28A0092B-C50C-407E-A947-70E740481C1C}">
+                <a14:useLocalDpi xmlns:a14="http://schemas.microsoft.com/office/drawing/2010/main" val="0"/>
+              </a:ext>
+            </a:extLst>
+          </a:blip>
+          <a:stretch>
+            <a:fillRect/>
+          </a:stretch>
+        </p:blipFill>
+        <p:spPr>
+          <a:xfrm>
+            <a:off x="10639745" y="359355"/>
+            <a:ext cx="868164" cy="892235"/>
+          </a:xfrm>
+          <a:prstGeom prst="roundRect">
+            <a:avLst>
+              <a:gd name="adj" fmla="val 4167"/>
+            </a:avLst>
+          </a:prstGeom>
+          <a:solidFill>
+            <a:srgbClr val="FFFFFF"/>
+          </a:solidFill>
+          <a:ln w="76200" cap="sq">
+            <a:solidFill>
+              <a:srgbClr val="292929"/>
+            </a:solidFill>
+            <a:miter lim="800000"/>
+          </a:ln>
+          <a:effectLst>
+            <a:reflection blurRad="12700" stA="28000" endPos="28000" dist="5000" dir="5400000" sy="-100000" algn="bl" rotWithShape="0"/>
+          </a:effectLst>
+          <a:scene3d>
+            <a:camera prst="orthographicFront"/>
+            <a:lightRig rig="threePt" dir="t">
+              <a:rot lat="0" lon="0" rev="2700000"/>
+            </a:lightRig>
+          </a:scene3d>
+          <a:sp3d>
+            <a:bevelT h="38100"/>
+            <a:contourClr>
+              <a:srgbClr val="C0C0C0"/>
+            </a:contourClr>
+          </a:sp3d>
+        </p:spPr>
+      </p:pic>
+      <p:sp>
+        <p:nvSpPr>
+          <p:cNvPr id="19" name="Rectangle: Rounded Corners 18">
+            <a:extLst>
+              <a:ext uri="{FF2B5EF4-FFF2-40B4-BE49-F238E27FC236}">
+                <a16:creationId xmlns:a16="http://schemas.microsoft.com/office/drawing/2014/main" id="{E7CB73A0-0925-FCBC-4F29-6CE65A666B15}"/>
+              </a:ext>
+            </a:extLst>
+          </p:cNvPr>
+          <p:cNvSpPr/>
+          <p:nvPr/>
+        </p:nvSpPr>
+        <p:spPr>
+          <a:xfrm>
+            <a:off x="6295627" y="1336861"/>
+            <a:ext cx="1491503" cy="446276"/>
+          </a:xfrm>
+          <a:prstGeom prst="roundRect">
+            <a:avLst/>
+          </a:prstGeom>
+        </p:spPr>
+        <p:style>
+          <a:lnRef idx="2">
+            <a:schemeClr val="accent1">
+              <a:shade val="50000"/>
+            </a:schemeClr>
+          </a:lnRef>
+          <a:fillRef idx="1">
+            <a:schemeClr val="accent1"/>
+          </a:fillRef>
+          <a:effectRef idx="0">
+            <a:schemeClr val="accent1"/>
+          </a:effectRef>
+          <a:fontRef idx="minor">
+            <a:schemeClr val="lt1"/>
+          </a:fontRef>
+        </p:style>
+        <p:txBody>
+          <a:bodyPr rtlCol="0" anchor="ctr"/>
+          <a:lstStyle/>
+          <a:p>
+            <a:r>
+              <a:rPr lang="en-US" sz="1100" b="1" dirty="0"/>
+              <a:t>Eavesdrop Railway Radio Signals</a:t>
+            </a:r>
+          </a:p>
+        </p:txBody>
+      </p:sp>
+      <p:sp>
+        <p:nvSpPr>
+          <p:cNvPr id="20" name="Rectangle: Rounded Corners 19">
+            <a:extLst>
+              <a:ext uri="{FF2B5EF4-FFF2-40B4-BE49-F238E27FC236}">
+                <a16:creationId xmlns:a16="http://schemas.microsoft.com/office/drawing/2014/main" id="{5C5EE9EF-B23B-FC30-C9E1-36386554BE19}"/>
+              </a:ext>
+            </a:extLst>
+          </p:cNvPr>
+          <p:cNvSpPr/>
+          <p:nvPr/>
+        </p:nvSpPr>
+        <p:spPr>
+          <a:xfrm>
+            <a:off x="8012658" y="1336861"/>
+            <a:ext cx="1362251" cy="446276"/>
+          </a:xfrm>
+          <a:prstGeom prst="roundRect">
+            <a:avLst/>
+          </a:prstGeom>
+          <a:solidFill>
+            <a:schemeClr val="accent2"/>
+          </a:solidFill>
+        </p:spPr>
+        <p:style>
+          <a:lnRef idx="2">
+            <a:schemeClr val="accent1">
+              <a:shade val="50000"/>
+            </a:schemeClr>
+          </a:lnRef>
+          <a:fillRef idx="1">
+            <a:schemeClr val="accent1"/>
+          </a:fillRef>
+          <a:effectRef idx="0">
+            <a:schemeClr val="accent1"/>
+          </a:effectRef>
+          <a:fontRef idx="minor">
+            <a:schemeClr val="lt1"/>
+          </a:fontRef>
+        </p:style>
+        <p:txBody>
+          <a:bodyPr rtlCol="0" anchor="ctr"/>
+          <a:lstStyle/>
+          <a:p>
+            <a:r>
+              <a:rPr lang="en-US" sz="1100" b="1" dirty="0"/>
+              <a:t>Decode S7 Comm Parameters</a:t>
+            </a:r>
+          </a:p>
+        </p:txBody>
+      </p:sp>
+      <p:sp>
+        <p:nvSpPr>
+          <p:cNvPr id="21" name="Arrow: Right 20">
+            <a:extLst>
+              <a:ext uri="{FF2B5EF4-FFF2-40B4-BE49-F238E27FC236}">
+                <a16:creationId xmlns:a16="http://schemas.microsoft.com/office/drawing/2014/main" id="{8A599A3A-FAD8-BA93-201D-5B68BDFA71FF}"/>
+              </a:ext>
+            </a:extLst>
+          </p:cNvPr>
+          <p:cNvSpPr/>
+          <p:nvPr/>
+        </p:nvSpPr>
+        <p:spPr>
+          <a:xfrm>
+            <a:off x="7820506" y="1478230"/>
+            <a:ext cx="158776" cy="87992"/>
+          </a:xfrm>
+          <a:prstGeom prst="rightArrow">
+            <a:avLst/>
+          </a:prstGeom>
+          <a:solidFill>
+            <a:schemeClr val="accent2">
+              <a:lumMod val="75000"/>
+            </a:schemeClr>
+          </a:solidFill>
+        </p:spPr>
+        <p:style>
+          <a:lnRef idx="2">
+            <a:schemeClr val="accent4">
+              <a:shade val="15000"/>
+            </a:schemeClr>
+          </a:lnRef>
+          <a:fillRef idx="1">
+            <a:schemeClr val="accent4"/>
+          </a:fillRef>
+          <a:effectRef idx="0">
+            <a:schemeClr val="accent4"/>
+          </a:effectRef>
+          <a:fontRef idx="minor">
+            <a:schemeClr val="lt1"/>
+          </a:fontRef>
+        </p:style>
+        <p:txBody>
+          <a:bodyPr rtlCol="0" anchor="ctr"/>
+          <a:lstStyle/>
+          <a:p>
+            <a:pPr algn="ctr"/>
+            <a:endParaRPr lang="en-SG"/>
+          </a:p>
+        </p:txBody>
+      </p:sp>
+      <p:sp>
+        <p:nvSpPr>
+          <p:cNvPr id="22" name="Arrow: Right 21">
+            <a:extLst>
+              <a:ext uri="{FF2B5EF4-FFF2-40B4-BE49-F238E27FC236}">
+                <a16:creationId xmlns:a16="http://schemas.microsoft.com/office/drawing/2014/main" id="{DE8F89B7-0CBC-51C6-5083-0D6BC3BECE90}"/>
+              </a:ext>
+            </a:extLst>
+          </p:cNvPr>
+          <p:cNvSpPr/>
+          <p:nvPr/>
+        </p:nvSpPr>
+        <p:spPr>
+          <a:xfrm>
+            <a:off x="9450898" y="1472007"/>
+            <a:ext cx="158776" cy="87992"/>
+          </a:xfrm>
+          <a:prstGeom prst="rightArrow">
+            <a:avLst/>
+          </a:prstGeom>
+          <a:solidFill>
+            <a:schemeClr val="accent2">
+              <a:lumMod val="75000"/>
+            </a:schemeClr>
+          </a:solidFill>
+        </p:spPr>
+        <p:style>
+          <a:lnRef idx="2">
+            <a:schemeClr val="accent4">
+              <a:shade val="15000"/>
+            </a:schemeClr>
+          </a:lnRef>
+          <a:fillRef idx="1">
+            <a:schemeClr val="accent4"/>
+          </a:fillRef>
+          <a:effectRef idx="0">
+            <a:schemeClr val="accent4"/>
+          </a:effectRef>
+          <a:fontRef idx="minor">
+            <a:schemeClr val="lt1"/>
+          </a:fontRef>
+        </p:style>
+        <p:txBody>
+          <a:bodyPr rtlCol="0" anchor="ctr"/>
+          <a:lstStyle/>
+          <a:p>
+            <a:pPr algn="ctr"/>
+            <a:endParaRPr lang="en-SG"/>
+          </a:p>
+        </p:txBody>
+      </p:sp>
+      <p:sp>
+        <p:nvSpPr>
+          <p:cNvPr id="23" name="Rectangle: Rounded Corners 22">
+            <a:extLst>
+              <a:ext uri="{FF2B5EF4-FFF2-40B4-BE49-F238E27FC236}">
+                <a16:creationId xmlns:a16="http://schemas.microsoft.com/office/drawing/2014/main" id="{CE68228A-F8EA-927A-407A-85EEEDD9A0B5}"/>
+              </a:ext>
+            </a:extLst>
+          </p:cNvPr>
+          <p:cNvSpPr/>
+          <p:nvPr/>
+        </p:nvSpPr>
+        <p:spPr>
+          <a:xfrm>
+            <a:off x="9685663" y="1344590"/>
+            <a:ext cx="1739719" cy="446276"/>
+          </a:xfrm>
+          <a:prstGeom prst="roundRect">
+            <a:avLst/>
+          </a:prstGeom>
+          <a:solidFill>
+            <a:schemeClr val="accent6">
+              <a:lumMod val="50000"/>
+            </a:schemeClr>
+          </a:solidFill>
+        </p:spPr>
+        <p:style>
+          <a:lnRef idx="2">
+            <a:schemeClr val="accent1">
+              <a:shade val="50000"/>
+            </a:schemeClr>
+          </a:lnRef>
+          <a:fillRef idx="1">
+            <a:schemeClr val="accent1"/>
+          </a:fillRef>
+          <a:effectRef idx="0">
+            <a:schemeClr val="accent1"/>
+          </a:effectRef>
+          <a:fontRef idx="minor">
+            <a:schemeClr val="lt1"/>
+          </a:fontRef>
+        </p:style>
+        <p:txBody>
+          <a:bodyPr rtlCol="0" anchor="ctr"/>
+          <a:lstStyle/>
+          <a:p>
+            <a:r>
+              <a:rPr lang="en-US" sz="1100" b="1" dirty="0"/>
+              <a:t>Create and Inject Spoofed Comm Signals</a:t>
+            </a:r>
+          </a:p>
+        </p:txBody>
+      </p:sp>
+      <p:sp>
+        <p:nvSpPr>
+          <p:cNvPr id="24" name="Rectangle: Rounded Corners 23">
+            <a:extLst>
+              <a:ext uri="{FF2B5EF4-FFF2-40B4-BE49-F238E27FC236}">
+                <a16:creationId xmlns:a16="http://schemas.microsoft.com/office/drawing/2014/main" id="{FFE4E75E-5361-0427-3AA3-7B7C78E50E33}"/>
+              </a:ext>
+            </a:extLst>
+          </p:cNvPr>
+          <p:cNvSpPr/>
+          <p:nvPr/>
+        </p:nvSpPr>
+        <p:spPr>
+          <a:xfrm>
+            <a:off x="9881870" y="2068215"/>
+            <a:ext cx="1477818" cy="446276"/>
+          </a:xfrm>
+          <a:prstGeom prst="roundRect">
+            <a:avLst/>
+          </a:prstGeom>
+          <a:solidFill>
+            <a:schemeClr val="accent2">
+              <a:lumMod val="40000"/>
+              <a:lumOff val="60000"/>
+            </a:schemeClr>
+          </a:solidFill>
+        </p:spPr>
+        <p:style>
+          <a:lnRef idx="2">
+            <a:schemeClr val="accent1">
+              <a:shade val="50000"/>
+            </a:schemeClr>
+          </a:lnRef>
+          <a:fillRef idx="1">
+            <a:schemeClr val="accent1"/>
+          </a:fillRef>
+          <a:effectRef idx="0">
+            <a:schemeClr val="accent1"/>
+          </a:effectRef>
+          <a:fontRef idx="minor">
+            <a:schemeClr val="lt1"/>
+          </a:fontRef>
+        </p:style>
+        <p:txBody>
+          <a:bodyPr rtlCol="0" anchor="ctr"/>
+          <a:lstStyle/>
+          <a:p>
+            <a:r>
+              <a:rPr lang="en-US" sz="1100" b="1" dirty="0">
+                <a:solidFill>
+                  <a:schemeClr val="tx1"/>
+                </a:solidFill>
+              </a:rPr>
+              <a:t>False Data Transfer to OCC HMI</a:t>
+            </a:r>
+          </a:p>
+        </p:txBody>
+      </p:sp>
+      <p:sp>
+        <p:nvSpPr>
+          <p:cNvPr id="25" name="Arrow: Right 24">
+            <a:extLst>
+              <a:ext uri="{FF2B5EF4-FFF2-40B4-BE49-F238E27FC236}">
+                <a16:creationId xmlns:a16="http://schemas.microsoft.com/office/drawing/2014/main" id="{6BE1E86B-75A4-9946-E3FA-78AA113108C4}"/>
+              </a:ext>
+            </a:extLst>
+          </p:cNvPr>
+          <p:cNvSpPr/>
+          <p:nvPr/>
+        </p:nvSpPr>
+        <p:spPr>
+          <a:xfrm rot="5400000">
+            <a:off x="10443287" y="1893606"/>
+            <a:ext cx="158776" cy="87992"/>
+          </a:xfrm>
+          <a:prstGeom prst="rightArrow">
+            <a:avLst/>
+          </a:prstGeom>
+          <a:solidFill>
+            <a:schemeClr val="accent2">
+              <a:lumMod val="75000"/>
+            </a:schemeClr>
+          </a:solidFill>
+        </p:spPr>
+        <p:style>
+          <a:lnRef idx="2">
+            <a:schemeClr val="accent4">
+              <a:shade val="15000"/>
+            </a:schemeClr>
+          </a:lnRef>
+          <a:fillRef idx="1">
+            <a:schemeClr val="accent4"/>
+          </a:fillRef>
+          <a:effectRef idx="0">
+            <a:schemeClr val="accent4"/>
+          </a:effectRef>
+          <a:fontRef idx="minor">
+            <a:schemeClr val="lt1"/>
+          </a:fontRef>
+        </p:style>
+        <p:txBody>
+          <a:bodyPr rtlCol="0" anchor="ctr"/>
+          <a:lstStyle/>
+          <a:p>
+            <a:pPr algn="ctr"/>
+            <a:endParaRPr lang="en-SG"/>
+          </a:p>
+        </p:txBody>
+      </p:sp>
+      <p:sp>
+        <p:nvSpPr>
+          <p:cNvPr id="26" name="Arrow: Right 25">
+            <a:extLst>
+              <a:ext uri="{FF2B5EF4-FFF2-40B4-BE49-F238E27FC236}">
+                <a16:creationId xmlns:a16="http://schemas.microsoft.com/office/drawing/2014/main" id="{28B365B9-F2B4-8CDB-8F26-BBC2D9F130E2}"/>
+              </a:ext>
+            </a:extLst>
+          </p:cNvPr>
+          <p:cNvSpPr/>
+          <p:nvPr/>
+        </p:nvSpPr>
+        <p:spPr>
+          <a:xfrm rot="10800000">
+            <a:off x="9660353" y="2247357"/>
+            <a:ext cx="158776" cy="87992"/>
+          </a:xfrm>
+          <a:prstGeom prst="rightArrow">
+            <a:avLst/>
+          </a:prstGeom>
+          <a:solidFill>
+            <a:schemeClr val="accent2">
+              <a:lumMod val="75000"/>
+            </a:schemeClr>
+          </a:solidFill>
+        </p:spPr>
+        <p:style>
+          <a:lnRef idx="2">
+            <a:schemeClr val="accent4">
+              <a:shade val="15000"/>
+            </a:schemeClr>
+          </a:lnRef>
+          <a:fillRef idx="1">
+            <a:schemeClr val="accent4"/>
+          </a:fillRef>
+          <a:effectRef idx="0">
+            <a:schemeClr val="accent4"/>
+          </a:effectRef>
+          <a:fontRef idx="minor">
+            <a:schemeClr val="lt1"/>
+          </a:fontRef>
+        </p:style>
+        <p:txBody>
+          <a:bodyPr rtlCol="0" anchor="ctr"/>
+          <a:lstStyle/>
+          <a:p>
+            <a:pPr algn="ctr"/>
+            <a:endParaRPr lang="en-SG"/>
+          </a:p>
+        </p:txBody>
+      </p:sp>
+      <p:sp>
+        <p:nvSpPr>
+          <p:cNvPr id="27" name="Rectangle: Rounded Corners 26">
+            <a:extLst>
+              <a:ext uri="{FF2B5EF4-FFF2-40B4-BE49-F238E27FC236}">
+                <a16:creationId xmlns:a16="http://schemas.microsoft.com/office/drawing/2014/main" id="{2F791416-F8E9-5721-34E0-EE0909500C43}"/>
+              </a:ext>
+            </a:extLst>
+          </p:cNvPr>
+          <p:cNvSpPr/>
+          <p:nvPr/>
+        </p:nvSpPr>
+        <p:spPr>
+          <a:xfrm>
+            <a:off x="8131856" y="2068215"/>
+            <a:ext cx="1477818" cy="446276"/>
+          </a:xfrm>
+          <a:prstGeom prst="roundRect">
+            <a:avLst/>
+          </a:prstGeom>
+          <a:solidFill>
+            <a:srgbClr val="FFC000"/>
+          </a:solidFill>
+        </p:spPr>
+        <p:style>
+          <a:lnRef idx="2">
+            <a:schemeClr val="accent1">
+              <a:shade val="50000"/>
+            </a:schemeClr>
+          </a:lnRef>
+          <a:fillRef idx="1">
+            <a:schemeClr val="accent1"/>
+          </a:fillRef>
+          <a:effectRef idx="0">
+            <a:schemeClr val="accent1"/>
+          </a:effectRef>
+          <a:fontRef idx="minor">
+            <a:schemeClr val="lt1"/>
+          </a:fontRef>
+        </p:style>
+        <p:txBody>
+          <a:bodyPr rtlCol="0" anchor="ctr"/>
+          <a:lstStyle/>
+          <a:p>
+            <a:r>
+              <a:rPr lang="en-US" sz="1100" b="1" dirty="0">
+                <a:solidFill>
+                  <a:schemeClr val="tx1"/>
+                </a:solidFill>
+              </a:rPr>
+              <a:t>Trigger Railway Alarm Mechanisms</a:t>
+            </a:r>
+          </a:p>
+        </p:txBody>
+      </p:sp>
+      <p:sp>
+        <p:nvSpPr>
+          <p:cNvPr id="28" name="Multiplication Sign 27">
+            <a:extLst>
+              <a:ext uri="{FF2B5EF4-FFF2-40B4-BE49-F238E27FC236}">
+                <a16:creationId xmlns:a16="http://schemas.microsoft.com/office/drawing/2014/main" id="{B1AB7772-0D3B-5C0B-599C-415D44856E98}"/>
+              </a:ext>
+            </a:extLst>
+          </p:cNvPr>
+          <p:cNvSpPr/>
+          <p:nvPr/>
+        </p:nvSpPr>
+        <p:spPr>
+          <a:xfrm>
+            <a:off x="2033367" y="5280978"/>
+            <a:ext cx="349955" cy="407579"/>
+          </a:xfrm>
+          <a:prstGeom prst="mathMultiply">
+            <a:avLst/>
+          </a:prstGeom>
+          <a:solidFill>
+            <a:srgbClr val="C00000"/>
+          </a:solidFill>
+          <a:ln>
+            <a:solidFill>
+              <a:schemeClr val="bg1"/>
+            </a:solidFill>
+          </a:ln>
+        </p:spPr>
+        <p:style>
+          <a:lnRef idx="2">
+            <a:schemeClr val="accent1">
+              <a:shade val="15000"/>
+            </a:schemeClr>
+          </a:lnRef>
+          <a:fillRef idx="1">
+            <a:schemeClr val="accent1"/>
+          </a:fillRef>
+          <a:effectRef idx="0">
+            <a:schemeClr val="accent1"/>
+          </a:effectRef>
+          <a:fontRef idx="minor">
+            <a:schemeClr val="lt1"/>
+          </a:fontRef>
+        </p:style>
+        <p:txBody>
+          <a:bodyPr rtlCol="0" anchor="ctr"/>
+          <a:lstStyle/>
+          <a:p>
+            <a:pPr algn="ctr"/>
+            <a:endParaRPr lang="en-SG">
+              <a:solidFill>
+                <a:srgbClr val="C00000"/>
+              </a:solidFill>
+            </a:endParaRPr>
+          </a:p>
+        </p:txBody>
+      </p:sp>
+      <p:sp>
+        <p:nvSpPr>
+          <p:cNvPr id="29" name="Arrow: Right 28">
+            <a:extLst>
+              <a:ext uri="{FF2B5EF4-FFF2-40B4-BE49-F238E27FC236}">
+                <a16:creationId xmlns:a16="http://schemas.microsoft.com/office/drawing/2014/main" id="{4BC75574-A25F-D1B6-1C16-25E16300A392}"/>
+              </a:ext>
+            </a:extLst>
+          </p:cNvPr>
+          <p:cNvSpPr/>
+          <p:nvPr/>
+        </p:nvSpPr>
+        <p:spPr>
+          <a:xfrm rot="10800000">
+            <a:off x="7910339" y="2255862"/>
+            <a:ext cx="158776" cy="87992"/>
+          </a:xfrm>
+          <a:prstGeom prst="rightArrow">
+            <a:avLst/>
+          </a:prstGeom>
+          <a:solidFill>
+            <a:schemeClr val="accent2">
+              <a:lumMod val="75000"/>
+            </a:schemeClr>
+          </a:solidFill>
+        </p:spPr>
+        <p:style>
+          <a:lnRef idx="2">
+            <a:schemeClr val="accent4">
+              <a:shade val="15000"/>
+            </a:schemeClr>
+          </a:lnRef>
+          <a:fillRef idx="1">
+            <a:schemeClr val="accent4"/>
+          </a:fillRef>
+          <a:effectRef idx="0">
+            <a:schemeClr val="accent4"/>
+          </a:effectRef>
+          <a:fontRef idx="minor">
+            <a:schemeClr val="lt1"/>
+          </a:fontRef>
+        </p:style>
+        <p:txBody>
+          <a:bodyPr rtlCol="0" anchor="ctr"/>
+          <a:lstStyle/>
+          <a:p>
+            <a:pPr algn="ctr"/>
+            <a:endParaRPr lang="en-SG"/>
+          </a:p>
+        </p:txBody>
+      </p:sp>
+      <p:sp>
+        <p:nvSpPr>
+          <p:cNvPr id="30" name="Rectangle: Rounded Corners 29">
+            <a:extLst>
+              <a:ext uri="{FF2B5EF4-FFF2-40B4-BE49-F238E27FC236}">
+                <a16:creationId xmlns:a16="http://schemas.microsoft.com/office/drawing/2014/main" id="{596C389F-B471-4A71-52C2-6950E6E62705}"/>
+              </a:ext>
+            </a:extLst>
+          </p:cNvPr>
+          <p:cNvSpPr/>
+          <p:nvPr/>
+        </p:nvSpPr>
+        <p:spPr>
+          <a:xfrm>
+            <a:off x="6278197" y="2068214"/>
+            <a:ext cx="1581463" cy="446276"/>
+          </a:xfrm>
+          <a:prstGeom prst="roundRect">
+            <a:avLst/>
+          </a:prstGeom>
+          <a:solidFill>
+            <a:srgbClr val="C00000"/>
+          </a:solidFill>
+        </p:spPr>
+        <p:style>
+          <a:lnRef idx="2">
+            <a:schemeClr val="accent1">
+              <a:shade val="50000"/>
+            </a:schemeClr>
+          </a:lnRef>
+          <a:fillRef idx="1">
+            <a:schemeClr val="accent1"/>
+          </a:fillRef>
+          <a:effectRef idx="0">
+            <a:schemeClr val="accent1"/>
+          </a:effectRef>
+          <a:fontRef idx="minor">
+            <a:schemeClr val="lt1"/>
+          </a:fontRef>
+        </p:style>
+        <p:txBody>
+          <a:bodyPr rtlCol="0" anchor="ctr"/>
+          <a:lstStyle/>
+          <a:p>
+            <a:r>
+              <a:rPr lang="en-US" sz="1100" b="1" dirty="0">
+                <a:solidFill>
+                  <a:schemeClr val="bg1"/>
+                </a:solidFill>
+              </a:rPr>
+              <a:t>Emergency Stop Protection Activation</a:t>
+            </a:r>
+          </a:p>
+        </p:txBody>
+      </p:sp>
+    </p:spTree>
+    <p:extLst>
+      <p:ext uri="{BB962C8B-B14F-4D97-AF65-F5344CB8AC3E}">
+        <p14:creationId xmlns:p14="http://schemas.microsoft.com/office/powerpoint/2010/main" val="4067454738"/>
       </p:ext>
     </p:extLst>
   </p:cSld>

</xml_diff>

<commit_message>
update the video link.
</commit_message>
<xml_diff>
--- a/5_CaseStudy_Doc/Case0_img/designDoc.pptx
+++ b/5_CaseStudy_Doc/Case0_img/designDoc.pptx
@@ -5,16 +5,17 @@
     <p:sldMasterId id="2147483648" r:id="rId1"/>
   </p:sldMasterIdLst>
   <p:notesMasterIdLst>
-    <p:notesMasterId r:id="rId9"/>
+    <p:notesMasterId r:id="rId10"/>
   </p:notesMasterIdLst>
   <p:sldIdLst>
-    <p:sldId id="256" r:id="rId2"/>
-    <p:sldId id="257" r:id="rId3"/>
-    <p:sldId id="258" r:id="rId4"/>
-    <p:sldId id="259" r:id="rId5"/>
-    <p:sldId id="260" r:id="rId6"/>
-    <p:sldId id="261" r:id="rId7"/>
-    <p:sldId id="262" r:id="rId8"/>
+    <p:sldId id="263" r:id="rId2"/>
+    <p:sldId id="256" r:id="rId3"/>
+    <p:sldId id="257" r:id="rId4"/>
+    <p:sldId id="258" r:id="rId5"/>
+    <p:sldId id="259" r:id="rId6"/>
+    <p:sldId id="260" r:id="rId7"/>
+    <p:sldId id="261" r:id="rId8"/>
+    <p:sldId id="262" r:id="rId9"/>
   </p:sldIdLst>
   <p:sldSz cx="12192000" cy="6858000"/>
   <p:notesSz cx="6858000" cy="9144000"/>
@@ -536,7 +537,7 @@
           <a:p>
             <a:fld id="{893DCAB4-0F4A-4B1D-A039-CE22C5E63A9C}" type="slidenum">
               <a:rPr lang="en-SG" smtClean="0"/>
-              <a:t>3</a:t>
+              <a:t>4</a:t>
             </a:fld>
             <a:endParaRPr lang="en-SG"/>
           </a:p>
@@ -620,7 +621,7 @@
           <a:p>
             <a:fld id="{893DCAB4-0F4A-4B1D-A039-CE22C5E63A9C}" type="slidenum">
               <a:rPr lang="en-SG" smtClean="0"/>
-              <a:t>4</a:t>
+              <a:t>5</a:t>
             </a:fld>
             <a:endParaRPr lang="en-SG"/>
           </a:p>
@@ -728,7 +729,7 @@
           <a:p>
             <a:fld id="{893DCAB4-0F4A-4B1D-A039-CE22C5E63A9C}" type="slidenum">
               <a:rPr lang="en-SG" smtClean="0"/>
-              <a:t>5</a:t>
+              <a:t>6</a:t>
             </a:fld>
             <a:endParaRPr lang="en-SG"/>
           </a:p>
@@ -812,7 +813,7 @@
           <a:p>
             <a:fld id="{893DCAB4-0F4A-4B1D-A039-CE22C5E63A9C}" type="slidenum">
               <a:rPr lang="en-SG" smtClean="0"/>
-              <a:t>6</a:t>
+              <a:t>7</a:t>
             </a:fld>
             <a:endParaRPr lang="en-SG"/>
           </a:p>
@@ -4071,7 +4072,7 @@
           <p:cNvPr id="5" name="Picture 4">
             <a:extLst>
               <a:ext uri="{FF2B5EF4-FFF2-40B4-BE49-F238E27FC236}">
-                <a16:creationId xmlns:a16="http://schemas.microsoft.com/office/drawing/2014/main" id="{9A72A85F-23C1-5D4B-945B-C74A7D2D668E}"/>
+                <a16:creationId xmlns:a16="http://schemas.microsoft.com/office/drawing/2014/main" id="{3A76B2B5-5264-46F4-1F59-F2961F3A22DA}"/>
               </a:ext>
             </a:extLst>
           </p:cNvPr>
@@ -4081,32 +4082,79 @@
           <p:nvPr/>
         </p:nvPicPr>
         <p:blipFill>
-          <a:blip r:embed="rId2"/>
+          <a:blip r:embed="rId2">
+            <a:extLst>
+              <a:ext uri="{28A0092B-C50C-407E-A947-70E740481C1C}">
+                <a14:useLocalDpi xmlns:a14="http://schemas.microsoft.com/office/drawing/2010/main" val="0"/>
+              </a:ext>
+            </a:extLst>
+          </a:blip>
           <a:stretch>
             <a:fillRect/>
           </a:stretch>
         </p:blipFill>
         <p:spPr>
           <a:xfrm>
-            <a:off x="1690673" y="1193532"/>
-            <a:ext cx="4405327" cy="4646608"/>
+            <a:off x="872084" y="1978357"/>
+            <a:ext cx="4502624" cy="2381888"/>
           </a:xfrm>
           <a:prstGeom prst="rect">
             <a:avLst/>
           </a:prstGeom>
-          <a:ln w="12700">
-            <a:solidFill>
-              <a:schemeClr val="tx1"/>
-            </a:solidFill>
-          </a:ln>
         </p:spPr>
       </p:pic>
+      <p:sp>
+        <p:nvSpPr>
+          <p:cNvPr id="7" name="Arrow: Right 6">
+            <a:extLst>
+              <a:ext uri="{FF2B5EF4-FFF2-40B4-BE49-F238E27FC236}">
+                <a16:creationId xmlns:a16="http://schemas.microsoft.com/office/drawing/2014/main" id="{59048276-6A2D-7F1B-C469-93D3D8AD3161}"/>
+              </a:ext>
+            </a:extLst>
+          </p:cNvPr>
+          <p:cNvSpPr/>
+          <p:nvPr/>
+        </p:nvSpPr>
+        <p:spPr>
+          <a:xfrm>
+            <a:off x="5374708" y="3089709"/>
+            <a:ext cx="1834614" cy="339291"/>
+          </a:xfrm>
+          <a:prstGeom prst="rightArrow">
+            <a:avLst/>
+          </a:prstGeom>
+        </p:spPr>
+        <p:style>
+          <a:lnRef idx="2">
+            <a:schemeClr val="accent2">
+              <a:shade val="15000"/>
+            </a:schemeClr>
+          </a:lnRef>
+          <a:fillRef idx="1">
+            <a:schemeClr val="accent2"/>
+          </a:fillRef>
+          <a:effectRef idx="0">
+            <a:schemeClr val="accent2"/>
+          </a:effectRef>
+          <a:fontRef idx="minor">
+            <a:schemeClr val="lt1"/>
+          </a:fontRef>
+        </p:style>
+        <p:txBody>
+          <a:bodyPr rtlCol="0" anchor="ctr"/>
+          <a:lstStyle/>
+          <a:p>
+            <a:pPr algn="ctr"/>
+            <a:endParaRPr lang="en-SG"/>
+          </a:p>
+        </p:txBody>
+      </p:sp>
       <p:pic>
         <p:nvPicPr>
-          <p:cNvPr id="7" name="Picture 6">
-            <a:extLst>
-              <a:ext uri="{FF2B5EF4-FFF2-40B4-BE49-F238E27FC236}">
-                <a16:creationId xmlns:a16="http://schemas.microsoft.com/office/drawing/2014/main" id="{AE8E9F2C-53C7-3804-9C5A-089DFF819352}"/>
+          <p:cNvPr id="6" name="Picture 5" descr="A logo of a train&#10;&#10;AI-generated content may be incorrect.">
+            <a:extLst>
+              <a:ext uri="{FF2B5EF4-FFF2-40B4-BE49-F238E27FC236}">
+                <a16:creationId xmlns:a16="http://schemas.microsoft.com/office/drawing/2014/main" id="{5E62BB00-D6C3-88DA-13D1-6F76420DA11E}"/>
               </a:ext>
             </a:extLst>
           </p:cNvPr>
@@ -4116,30 +4164,93 @@
           <p:nvPr/>
         </p:nvPicPr>
         <p:blipFill>
-          <a:blip r:embed="rId3"/>
+          <a:blip r:embed="rId3">
+            <a:extLst>
+              <a:ext uri="{28A0092B-C50C-407E-A947-70E740481C1C}">
+                <a14:useLocalDpi xmlns:a14="http://schemas.microsoft.com/office/drawing/2010/main" val="0"/>
+              </a:ext>
+            </a:extLst>
+          </a:blip>
           <a:stretch>
             <a:fillRect/>
           </a:stretch>
         </p:blipFill>
         <p:spPr>
           <a:xfrm>
-            <a:off x="6240546" y="1193532"/>
-            <a:ext cx="4432970" cy="4646608"/>
+            <a:off x="5707966" y="2652268"/>
+            <a:ext cx="1109328" cy="1140086"/>
+          </a:xfrm>
+          <a:prstGeom prst="roundRect">
+            <a:avLst>
+              <a:gd name="adj" fmla="val 4167"/>
+            </a:avLst>
+          </a:prstGeom>
+          <a:solidFill>
+            <a:srgbClr val="FFFFFF"/>
+          </a:solidFill>
+          <a:ln w="76200" cap="sq">
+            <a:solidFill>
+              <a:srgbClr val="292929"/>
+            </a:solidFill>
+            <a:miter lim="800000"/>
+          </a:ln>
+          <a:effectLst>
+            <a:reflection blurRad="12700" stA="28000" endPos="28000" dist="5000" dir="5400000" sy="-100000" algn="bl" rotWithShape="0"/>
+          </a:effectLst>
+          <a:scene3d>
+            <a:camera prst="orthographicFront"/>
+            <a:lightRig rig="threePt" dir="t">
+              <a:rot lat="0" lon="0" rev="2700000"/>
+            </a:lightRig>
+          </a:scene3d>
+          <a:sp3d>
+            <a:bevelT h="38100"/>
+            <a:contourClr>
+              <a:srgbClr val="C0C0C0"/>
+            </a:contourClr>
+          </a:sp3d>
+        </p:spPr>
+      </p:pic>
+      <p:pic>
+        <p:nvPicPr>
+          <p:cNvPr id="11" name="Picture 10">
+            <a:extLst>
+              <a:ext uri="{FF2B5EF4-FFF2-40B4-BE49-F238E27FC236}">
+                <a16:creationId xmlns:a16="http://schemas.microsoft.com/office/drawing/2014/main" id="{8736D9EE-C99F-A9CF-1E09-0BE7D27D13D1}"/>
+              </a:ext>
+            </a:extLst>
+          </p:cNvPr>
+          <p:cNvPicPr>
+            <a:picLocks noChangeAspect="1"/>
+          </p:cNvPicPr>
+          <p:nvPr/>
+        </p:nvPicPr>
+        <p:blipFill>
+          <a:blip r:embed="rId4">
+            <a:extLst>
+              <a:ext uri="{28A0092B-C50C-407E-A947-70E740481C1C}">
+                <a14:useLocalDpi xmlns:a14="http://schemas.microsoft.com/office/drawing/2010/main" val="0"/>
+              </a:ext>
+            </a:extLst>
+          </a:blip>
+          <a:stretch>
+            <a:fillRect/>
+          </a:stretch>
+        </p:blipFill>
+        <p:spPr>
+          <a:xfrm>
+            <a:off x="7209323" y="1973130"/>
+            <a:ext cx="4110594" cy="2337798"/>
           </a:xfrm>
           <a:prstGeom prst="rect">
             <a:avLst/>
           </a:prstGeom>
-          <a:ln w="12700">
-            <a:solidFill>
-              <a:schemeClr val="tx1"/>
-            </a:solidFill>
-          </a:ln>
         </p:spPr>
       </p:pic>
     </p:spTree>
     <p:extLst>
       <p:ext uri="{BB962C8B-B14F-4D97-AF65-F5344CB8AC3E}">
-        <p14:creationId xmlns:p14="http://schemas.microsoft.com/office/powerpoint/2010/main" val="1345676097"/>
+        <p14:creationId xmlns:p14="http://schemas.microsoft.com/office/powerpoint/2010/main" val="3361605793"/>
       </p:ext>
     </p:extLst>
   </p:cSld>
@@ -4168,6 +4279,106 @@
       </p:grpSpPr>
       <p:pic>
         <p:nvPicPr>
+          <p:cNvPr id="5" name="Picture 4">
+            <a:extLst>
+              <a:ext uri="{FF2B5EF4-FFF2-40B4-BE49-F238E27FC236}">
+                <a16:creationId xmlns:a16="http://schemas.microsoft.com/office/drawing/2014/main" id="{9A72A85F-23C1-5D4B-945B-C74A7D2D668E}"/>
+              </a:ext>
+            </a:extLst>
+          </p:cNvPr>
+          <p:cNvPicPr>
+            <a:picLocks noChangeAspect="1"/>
+          </p:cNvPicPr>
+          <p:nvPr/>
+        </p:nvPicPr>
+        <p:blipFill>
+          <a:blip r:embed="rId2"/>
+          <a:stretch>
+            <a:fillRect/>
+          </a:stretch>
+        </p:blipFill>
+        <p:spPr>
+          <a:xfrm>
+            <a:off x="1690673" y="1193532"/>
+            <a:ext cx="4405327" cy="4646608"/>
+          </a:xfrm>
+          <a:prstGeom prst="rect">
+            <a:avLst/>
+          </a:prstGeom>
+          <a:ln w="12700">
+            <a:solidFill>
+              <a:schemeClr val="tx1"/>
+            </a:solidFill>
+          </a:ln>
+        </p:spPr>
+      </p:pic>
+      <p:pic>
+        <p:nvPicPr>
+          <p:cNvPr id="7" name="Picture 6">
+            <a:extLst>
+              <a:ext uri="{FF2B5EF4-FFF2-40B4-BE49-F238E27FC236}">
+                <a16:creationId xmlns:a16="http://schemas.microsoft.com/office/drawing/2014/main" id="{AE8E9F2C-53C7-3804-9C5A-089DFF819352}"/>
+              </a:ext>
+            </a:extLst>
+          </p:cNvPr>
+          <p:cNvPicPr>
+            <a:picLocks noChangeAspect="1"/>
+          </p:cNvPicPr>
+          <p:nvPr/>
+        </p:nvPicPr>
+        <p:blipFill>
+          <a:blip r:embed="rId3"/>
+          <a:stretch>
+            <a:fillRect/>
+          </a:stretch>
+        </p:blipFill>
+        <p:spPr>
+          <a:xfrm>
+            <a:off x="6240546" y="1193532"/>
+            <a:ext cx="4432970" cy="4646608"/>
+          </a:xfrm>
+          <a:prstGeom prst="rect">
+            <a:avLst/>
+          </a:prstGeom>
+          <a:ln w="12700">
+            <a:solidFill>
+              <a:schemeClr val="tx1"/>
+            </a:solidFill>
+          </a:ln>
+        </p:spPr>
+      </p:pic>
+    </p:spTree>
+    <p:extLst>
+      <p:ext uri="{BB962C8B-B14F-4D97-AF65-F5344CB8AC3E}">
+        <p14:creationId xmlns:p14="http://schemas.microsoft.com/office/powerpoint/2010/main" val="1345676097"/>
+      </p:ext>
+    </p:extLst>
+  </p:cSld>
+  <p:clrMapOvr>
+    <a:masterClrMapping/>
+  </p:clrMapOvr>
+</p:sld>
+</file>
+
+<file path=ppt/slides/slide3.xml><?xml version="1.0" encoding="utf-8"?>
+<p:sld xmlns:a="http://schemas.openxmlformats.org/drawingml/2006/main" xmlns:r="http://schemas.openxmlformats.org/officeDocument/2006/relationships" xmlns:p="http://schemas.openxmlformats.org/presentationml/2006/main">
+  <p:cSld>
+    <p:spTree>
+      <p:nvGrpSpPr>
+        <p:cNvPr id="1" name=""/>
+        <p:cNvGrpSpPr/>
+        <p:nvPr/>
+      </p:nvGrpSpPr>
+      <p:grpSpPr>
+        <a:xfrm>
+          <a:off x="0" y="0"/>
+          <a:ext cx="0" cy="0"/>
+          <a:chOff x="0" y="0"/>
+          <a:chExt cx="0" cy="0"/>
+        </a:xfrm>
+      </p:grpSpPr>
+      <p:pic>
+        <p:nvPicPr>
           <p:cNvPr id="4" name="Picture 2" descr="Train Side View: Over 3,932 Royalty-Free Licensable Stock Illustrations &amp;  Drawings | Shutterstock">
             <a:extLst>
               <a:ext uri="{FF2B5EF4-FFF2-40B4-BE49-F238E27FC236}">
@@ -7550,7 +7761,7 @@
 </p:sld>
 </file>
 
-<file path=ppt/slides/slide3.xml><?xml version="1.0" encoding="utf-8"?>
+<file path=ppt/slides/slide4.xml><?xml version="1.0" encoding="utf-8"?>
 <p:sld xmlns:a="http://schemas.openxmlformats.org/drawingml/2006/main" xmlns:r="http://schemas.openxmlformats.org/officeDocument/2006/relationships" xmlns:p="http://schemas.openxmlformats.org/presentationml/2006/main">
   <p:cSld>
     <p:spTree>
@@ -13074,7 +13285,7 @@
 </p:sld>
 </file>
 
-<file path=ppt/slides/slide4.xml><?xml version="1.0" encoding="utf-8"?>
+<file path=ppt/slides/slide5.xml><?xml version="1.0" encoding="utf-8"?>
 <p:sld xmlns:a="http://schemas.openxmlformats.org/drawingml/2006/main" xmlns:r="http://schemas.openxmlformats.org/officeDocument/2006/relationships" xmlns:p="http://schemas.openxmlformats.org/presentationml/2006/main">
   <p:cSld>
     <p:spTree>
@@ -18156,7 +18367,7 @@
 </p:sld>
 </file>
 
-<file path=ppt/slides/slide5.xml><?xml version="1.0" encoding="utf-8"?>
+<file path=ppt/slides/slide6.xml><?xml version="1.0" encoding="utf-8"?>
 <p:sld xmlns:a="http://schemas.openxmlformats.org/drawingml/2006/main" xmlns:r="http://schemas.openxmlformats.org/officeDocument/2006/relationships" xmlns:p="http://schemas.openxmlformats.org/presentationml/2006/main">
   <p:cSld>
     <p:spTree>
@@ -24355,7 +24566,7 @@
 </p:sld>
 </file>
 
-<file path=ppt/slides/slide6.xml><?xml version="1.0" encoding="utf-8"?>
+<file path=ppt/slides/slide7.xml><?xml version="1.0" encoding="utf-8"?>
 <p:sld xmlns:a="http://schemas.openxmlformats.org/drawingml/2006/main" xmlns:r="http://schemas.openxmlformats.org/officeDocument/2006/relationships" xmlns:p="http://schemas.openxmlformats.org/presentationml/2006/main">
   <p:cSld>
     <p:spTree>
@@ -24674,7 +24885,7 @@
 </p:sld>
 </file>
 
-<file path=ppt/slides/slide7.xml><?xml version="1.0" encoding="utf-8"?>
+<file path=ppt/slides/slide8.xml><?xml version="1.0" encoding="utf-8"?>
 <p:sld xmlns:a="http://schemas.openxmlformats.org/drawingml/2006/main" xmlns:r="http://schemas.openxmlformats.org/officeDocument/2006/relationships" xmlns:p="http://schemas.openxmlformats.org/presentationml/2006/main">
   <p:cSld>
     <p:spTree>

</xml_diff>